<commit_message>
Fill in partner name and tighten line spacing in bold theme
Co-Authored-By: Claude Fable 5.1 <noreply@anthropic.com>
Claude-Session: https://claude.ai/code/session_017z6FTKMRuHAVL86624AoYU
</commit_message>
<xml_diff>
--- a/proposal/ふたりの計画のご提案.pptx
+++ b/proposal/ふたりの計画のご提案.pptx
@@ -907,7 +907,7 @@
                 <a:ea typeface="Yu Gothic"/>
                 <a:cs typeface="Yu Gothic"/>
               </a:rPr>
-              <a:t>【彼の名前】さん 御中</a:t>
+              <a:t>凪さん 御中</a:t>
             </a:r>
           </a:p>
         </p:txBody>
@@ -934,7 +934,7 @@
           <a:p>
             <a:pPr algn="l">
               <a:lnSpc>
-                <a:spcPct val="112000"/>
+                <a:spcPct val="105000"/>
               </a:lnSpc>
             </a:pPr>
             <a:r>
@@ -952,7 +952,7 @@
           <a:p>
             <a:pPr algn="l">
               <a:lnSpc>
-                <a:spcPct val="112000"/>
+                <a:spcPct val="105000"/>
               </a:lnSpc>
             </a:pPr>
             <a:r>
@@ -1141,7 +1141,7 @@
           <a:p>
             <a:pPr algn="l">
               <a:lnSpc>
-                <a:spcPct val="165000"/>
+                <a:spcPct val="140000"/>
               </a:lnSpc>
             </a:pPr>
             <a:r>
@@ -1233,20 +1233,20 @@
         <p:spPr>
           <a:xfrm>
             <a:off x="841248" y="2414016"/>
-            <a:ext cx="2320290" cy="1097280"/>
-          </a:xfrm>
-          <a:prstGeom prst="rect">
-            <a:avLst/>
-          </a:prstGeom>
-          <a:noFill/>
-        </p:spPr>
-        <p:txBody>
-          <a:bodyPr wrap="square" lIns="0" tIns="0" rIns="0" bIns="0" anchor="t" rtlCol="0"/>
-          <a:lstStyle/>
-          <a:p>
-            <a:pPr algn="l">
-              <a:lnSpc>
-                <a:spcPct val="135000"/>
+            <a:ext cx="2320290" cy="1005840"/>
+          </a:xfrm>
+          <a:prstGeom prst="rect">
+            <a:avLst/>
+          </a:prstGeom>
+          <a:noFill/>
+        </p:spPr>
+        <p:txBody>
+          <a:bodyPr wrap="square" lIns="0" tIns="0" rIns="0" bIns="0" anchor="t" rtlCol="0"/>
+          <a:lstStyle/>
+          <a:p>
+            <a:pPr algn="l">
+              <a:lnSpc>
+                <a:spcPct val="125000"/>
               </a:lnSpc>
             </a:pPr>
             <a:r>
@@ -1264,7 +1264,7 @@
           <a:p>
             <a:pPr algn="l">
               <a:lnSpc>
-                <a:spcPct val="135000"/>
+                <a:spcPct val="125000"/>
               </a:lnSpc>
             </a:pPr>
             <a:r>
@@ -1289,21 +1289,21 @@
         </p:nvSpPr>
         <p:spPr>
           <a:xfrm>
-            <a:off x="841248" y="3602736"/>
-            <a:ext cx="2320290" cy="1353312"/>
-          </a:xfrm>
-          <a:prstGeom prst="rect">
-            <a:avLst/>
-          </a:prstGeom>
-          <a:noFill/>
-        </p:spPr>
-        <p:txBody>
-          <a:bodyPr wrap="square" lIns="0" tIns="0" rIns="0" bIns="0" anchor="t" rtlCol="0"/>
-          <a:lstStyle/>
-          <a:p>
-            <a:pPr algn="l">
-              <a:lnSpc>
-                <a:spcPct val="175000"/>
+            <a:off x="841248" y="3511296"/>
+            <a:ext cx="2320290" cy="1444752"/>
+          </a:xfrm>
+          <a:prstGeom prst="rect">
+            <a:avLst/>
+          </a:prstGeom>
+          <a:noFill/>
+        </p:spPr>
+        <p:txBody>
+          <a:bodyPr wrap="square" lIns="0" tIns="0" rIns="0" bIns="0" anchor="t" rtlCol="0"/>
+          <a:lstStyle/>
+          <a:p>
+            <a:pPr algn="l">
+              <a:lnSpc>
+                <a:spcPct val="155000"/>
               </a:lnSpc>
             </a:pPr>
             <a:r>
@@ -1395,20 +1395,20 @@
         <p:spPr>
           <a:xfrm>
             <a:off x="3573018" y="2414016"/>
-            <a:ext cx="2320290" cy="1097280"/>
-          </a:xfrm>
-          <a:prstGeom prst="rect">
-            <a:avLst/>
-          </a:prstGeom>
-          <a:noFill/>
-        </p:spPr>
-        <p:txBody>
-          <a:bodyPr wrap="square" lIns="0" tIns="0" rIns="0" bIns="0" anchor="t" rtlCol="0"/>
-          <a:lstStyle/>
-          <a:p>
-            <a:pPr algn="l">
-              <a:lnSpc>
-                <a:spcPct val="135000"/>
+            <a:ext cx="2320290" cy="1005840"/>
+          </a:xfrm>
+          <a:prstGeom prst="rect">
+            <a:avLst/>
+          </a:prstGeom>
+          <a:noFill/>
+        </p:spPr>
+        <p:txBody>
+          <a:bodyPr wrap="square" lIns="0" tIns="0" rIns="0" bIns="0" anchor="t" rtlCol="0"/>
+          <a:lstStyle/>
+          <a:p>
+            <a:pPr algn="l">
+              <a:lnSpc>
+                <a:spcPct val="125000"/>
               </a:lnSpc>
             </a:pPr>
             <a:r>
@@ -1426,7 +1426,7 @@
           <a:p>
             <a:pPr algn="l">
               <a:lnSpc>
-                <a:spcPct val="135000"/>
+                <a:spcPct val="125000"/>
               </a:lnSpc>
             </a:pPr>
             <a:r>
@@ -1451,21 +1451,21 @@
         </p:nvSpPr>
         <p:spPr>
           <a:xfrm>
-            <a:off x="3573018" y="3602736"/>
-            <a:ext cx="2320290" cy="1353312"/>
-          </a:xfrm>
-          <a:prstGeom prst="rect">
-            <a:avLst/>
-          </a:prstGeom>
-          <a:noFill/>
-        </p:spPr>
-        <p:txBody>
-          <a:bodyPr wrap="square" lIns="0" tIns="0" rIns="0" bIns="0" anchor="t" rtlCol="0"/>
-          <a:lstStyle/>
-          <a:p>
-            <a:pPr algn="l">
-              <a:lnSpc>
-                <a:spcPct val="175000"/>
+            <a:off x="3573018" y="3511296"/>
+            <a:ext cx="2320290" cy="1444752"/>
+          </a:xfrm>
+          <a:prstGeom prst="rect">
+            <a:avLst/>
+          </a:prstGeom>
+          <a:noFill/>
+        </p:spPr>
+        <p:txBody>
+          <a:bodyPr wrap="square" lIns="0" tIns="0" rIns="0" bIns="0" anchor="t" rtlCol="0"/>
+          <a:lstStyle/>
+          <a:p>
+            <a:pPr algn="l">
+              <a:lnSpc>
+                <a:spcPct val="155000"/>
               </a:lnSpc>
             </a:pPr>
             <a:r>
@@ -1557,20 +1557,20 @@
         <p:spPr>
           <a:xfrm>
             <a:off x="6304788" y="2414016"/>
-            <a:ext cx="2320290" cy="1097280"/>
-          </a:xfrm>
-          <a:prstGeom prst="rect">
-            <a:avLst/>
-          </a:prstGeom>
-          <a:noFill/>
-        </p:spPr>
-        <p:txBody>
-          <a:bodyPr wrap="square" lIns="0" tIns="0" rIns="0" bIns="0" anchor="t" rtlCol="0"/>
-          <a:lstStyle/>
-          <a:p>
-            <a:pPr algn="l">
-              <a:lnSpc>
-                <a:spcPct val="135000"/>
+            <a:ext cx="2320290" cy="1005840"/>
+          </a:xfrm>
+          <a:prstGeom prst="rect">
+            <a:avLst/>
+          </a:prstGeom>
+          <a:noFill/>
+        </p:spPr>
+        <p:txBody>
+          <a:bodyPr wrap="square" lIns="0" tIns="0" rIns="0" bIns="0" anchor="t" rtlCol="0"/>
+          <a:lstStyle/>
+          <a:p>
+            <a:pPr algn="l">
+              <a:lnSpc>
+                <a:spcPct val="125000"/>
               </a:lnSpc>
             </a:pPr>
             <a:r>
@@ -1588,7 +1588,7 @@
           <a:p>
             <a:pPr algn="l">
               <a:lnSpc>
-                <a:spcPct val="135000"/>
+                <a:spcPct val="125000"/>
               </a:lnSpc>
             </a:pPr>
             <a:r>
@@ -1613,21 +1613,21 @@
         </p:nvSpPr>
         <p:spPr>
           <a:xfrm>
-            <a:off x="6304788" y="3602736"/>
-            <a:ext cx="2320290" cy="1353312"/>
-          </a:xfrm>
-          <a:prstGeom prst="rect">
-            <a:avLst/>
-          </a:prstGeom>
-          <a:noFill/>
-        </p:spPr>
-        <p:txBody>
-          <a:bodyPr wrap="square" lIns="0" tIns="0" rIns="0" bIns="0" anchor="t" rtlCol="0"/>
-          <a:lstStyle/>
-          <a:p>
-            <a:pPr algn="l">
-              <a:lnSpc>
-                <a:spcPct val="175000"/>
+            <a:off x="6304788" y="3511296"/>
+            <a:ext cx="2320290" cy="1444752"/>
+          </a:xfrm>
+          <a:prstGeom prst="rect">
+            <a:avLst/>
+          </a:prstGeom>
+          <a:noFill/>
+        </p:spPr>
+        <p:txBody>
+          <a:bodyPr wrap="square" lIns="0" tIns="0" rIns="0" bIns="0" anchor="t" rtlCol="0"/>
+          <a:lstStyle/>
+          <a:p>
+            <a:pPr algn="l">
+              <a:lnSpc>
+                <a:spcPct val="155000"/>
               </a:lnSpc>
             </a:pPr>
             <a:r>
@@ -1719,20 +1719,20 @@
         <p:spPr>
           <a:xfrm>
             <a:off x="9036558" y="2414016"/>
-            <a:ext cx="2320290" cy="1097280"/>
-          </a:xfrm>
-          <a:prstGeom prst="rect">
-            <a:avLst/>
-          </a:prstGeom>
-          <a:noFill/>
-        </p:spPr>
-        <p:txBody>
-          <a:bodyPr wrap="square" lIns="0" tIns="0" rIns="0" bIns="0" anchor="t" rtlCol="0"/>
-          <a:lstStyle/>
-          <a:p>
-            <a:pPr algn="l">
-              <a:lnSpc>
-                <a:spcPct val="135000"/>
+            <a:ext cx="2320290" cy="1005840"/>
+          </a:xfrm>
+          <a:prstGeom prst="rect">
+            <a:avLst/>
+          </a:prstGeom>
+          <a:noFill/>
+        </p:spPr>
+        <p:txBody>
+          <a:bodyPr wrap="square" lIns="0" tIns="0" rIns="0" bIns="0" anchor="t" rtlCol="0"/>
+          <a:lstStyle/>
+          <a:p>
+            <a:pPr algn="l">
+              <a:lnSpc>
+                <a:spcPct val="125000"/>
               </a:lnSpc>
             </a:pPr>
             <a:r>
@@ -1750,7 +1750,7 @@
           <a:p>
             <a:pPr algn="l">
               <a:lnSpc>
-                <a:spcPct val="135000"/>
+                <a:spcPct val="125000"/>
               </a:lnSpc>
             </a:pPr>
             <a:r>
@@ -1775,21 +1775,21 @@
         </p:nvSpPr>
         <p:spPr>
           <a:xfrm>
-            <a:off x="9036558" y="3602736"/>
-            <a:ext cx="2320290" cy="1353312"/>
-          </a:xfrm>
-          <a:prstGeom prst="rect">
-            <a:avLst/>
-          </a:prstGeom>
-          <a:noFill/>
-        </p:spPr>
-        <p:txBody>
-          <a:bodyPr wrap="square" lIns="0" tIns="0" rIns="0" bIns="0" anchor="t" rtlCol="0"/>
-          <a:lstStyle/>
-          <a:p>
-            <a:pPr algn="l">
-              <a:lnSpc>
-                <a:spcPct val="175000"/>
+            <a:off x="9036558" y="3511296"/>
+            <a:ext cx="2320290" cy="1444752"/>
+          </a:xfrm>
+          <a:prstGeom prst="rect">
+            <a:avLst/>
+          </a:prstGeom>
+          <a:noFill/>
+        </p:spPr>
+        <p:txBody>
+          <a:bodyPr wrap="square" lIns="0" tIns="0" rIns="0" bIns="0" anchor="t" rtlCol="0"/>
+          <a:lstStyle/>
+          <a:p>
+            <a:pPr algn="l">
+              <a:lnSpc>
+                <a:spcPct val="155000"/>
               </a:lnSpc>
             </a:pPr>
             <a:r>
@@ -1828,7 +1828,7 @@
           <a:p>
             <a:pPr algn="l">
               <a:lnSpc>
-                <a:spcPct val="140000"/>
+                <a:spcPct val="125000"/>
               </a:lnSpc>
             </a:pPr>
             <a:r>
@@ -2017,7 +2017,7 @@
           <a:p>
             <a:pPr algn="l">
               <a:lnSpc>
-                <a:spcPct val="120000"/>
+                <a:spcPct val="112000"/>
               </a:lnSpc>
             </a:pPr>
             <a:r>
@@ -2035,7 +2035,7 @@
           <a:p>
             <a:pPr algn="l">
               <a:lnSpc>
-                <a:spcPct val="120000"/>
+                <a:spcPct val="112000"/>
               </a:lnSpc>
             </a:pPr>
             <a:r>
@@ -2074,7 +2074,7 @@
           <a:p>
             <a:pPr algn="l">
               <a:lnSpc>
-                <a:spcPct val="160000"/>
+                <a:spcPct val="145000"/>
               </a:lnSpc>
             </a:pPr>
             <a:r>
@@ -2185,7 +2185,7 @@
           <a:p>
             <a:pPr algn="l">
               <a:lnSpc>
-                <a:spcPct val="165000"/>
+                <a:spcPct val="140000"/>
               </a:lnSpc>
             </a:pPr>
             <a:r>
@@ -2288,7 +2288,7 @@
           <a:p>
             <a:pPr algn="l">
               <a:lnSpc>
-                <a:spcPct val="170000"/>
+                <a:spcPct val="145000"/>
               </a:lnSpc>
             </a:pPr>
             <a:r>
@@ -2388,7 +2388,7 @@
           <a:p>
             <a:pPr algn="l">
               <a:lnSpc>
-                <a:spcPct val="170000"/>
+                <a:spcPct val="145000"/>
               </a:lnSpc>
             </a:pPr>
             <a:r>
@@ -2488,7 +2488,7 @@
           <a:p>
             <a:pPr algn="l">
               <a:lnSpc>
-                <a:spcPct val="170000"/>
+                <a:spcPct val="145000"/>
               </a:lnSpc>
             </a:pPr>
             <a:r>
@@ -2549,7 +2549,7 @@
           <a:p>
             <a:pPr algn="l">
               <a:lnSpc>
-                <a:spcPct val="140000"/>
+                <a:spcPct val="125000"/>
               </a:lnSpc>
             </a:pPr>
             <a:r>
@@ -2738,7 +2738,7 @@
           <a:p>
             <a:pPr algn="l">
               <a:lnSpc>
-                <a:spcPct val="165000"/>
+                <a:spcPct val="140000"/>
               </a:lnSpc>
             </a:pPr>
             <a:r>
@@ -2857,7 +2857,7 @@
                 <a:ea typeface="Yu Gothic"/>
                 <a:cs typeface="Yu Gothic"/>
               </a:rPr>
-              <a:t>【彼の名前】</a:t>
+              <a:t>凪</a:t>
             </a:r>
           </a:p>
         </p:txBody>
@@ -2911,7 +2911,7 @@
           <a:p>
             <a:pPr algn="l">
               <a:lnSpc>
-                <a:spcPct val="145000"/>
+                <a:spcPct val="130000"/>
               </a:lnSpc>
             </a:pPr>
             <a:r>
@@ -2950,7 +2950,7 @@
           <a:p>
             <a:pPr algn="l">
               <a:lnSpc>
-                <a:spcPct val="145000"/>
+                <a:spcPct val="130000"/>
               </a:lnSpc>
             </a:pPr>
             <a:r>
@@ -2989,7 +2989,7 @@
           <a:p>
             <a:pPr algn="l">
               <a:lnSpc>
-                <a:spcPct val="145000"/>
+                <a:spcPct val="130000"/>
               </a:lnSpc>
             </a:pPr>
             <a:r>
@@ -3055,7 +3055,7 @@
           <a:p>
             <a:pPr algn="l">
               <a:lnSpc>
-                <a:spcPct val="145000"/>
+                <a:spcPct val="130000"/>
               </a:lnSpc>
             </a:pPr>
             <a:r>
@@ -3094,7 +3094,7 @@
           <a:p>
             <a:pPr algn="l">
               <a:lnSpc>
-                <a:spcPct val="145000"/>
+                <a:spcPct val="130000"/>
               </a:lnSpc>
             </a:pPr>
             <a:r>
@@ -3133,7 +3133,7 @@
           <a:p>
             <a:pPr algn="l">
               <a:lnSpc>
-                <a:spcPct val="145000"/>
+                <a:spcPct val="130000"/>
               </a:lnSpc>
             </a:pPr>
             <a:r>
@@ -3199,7 +3199,7 @@
           <a:p>
             <a:pPr algn="l">
               <a:lnSpc>
-                <a:spcPct val="145000"/>
+                <a:spcPct val="130000"/>
               </a:lnSpc>
             </a:pPr>
             <a:r>
@@ -3238,7 +3238,7 @@
           <a:p>
             <a:pPr algn="l">
               <a:lnSpc>
-                <a:spcPct val="145000"/>
+                <a:spcPct val="130000"/>
               </a:lnSpc>
             </a:pPr>
             <a:r>
@@ -3277,7 +3277,7 @@
           <a:p>
             <a:pPr algn="l">
               <a:lnSpc>
-                <a:spcPct val="145000"/>
+                <a:spcPct val="130000"/>
               </a:lnSpc>
             </a:pPr>
             <a:r>
@@ -3343,7 +3343,7 @@
           <a:p>
             <a:pPr algn="l">
               <a:lnSpc>
-                <a:spcPct val="145000"/>
+                <a:spcPct val="130000"/>
               </a:lnSpc>
             </a:pPr>
             <a:r>
@@ -3382,7 +3382,7 @@
           <a:p>
             <a:pPr algn="l">
               <a:lnSpc>
-                <a:spcPct val="145000"/>
+                <a:spcPct val="130000"/>
               </a:lnSpc>
             </a:pPr>
             <a:r>
@@ -3421,7 +3421,7 @@
           <a:p>
             <a:pPr algn="l">
               <a:lnSpc>
-                <a:spcPct val="145000"/>
+                <a:spcPct val="130000"/>
               </a:lnSpc>
             </a:pPr>
             <a:r>
@@ -3460,7 +3460,7 @@
           <a:p>
             <a:pPr algn="l">
               <a:lnSpc>
-                <a:spcPct val="140000"/>
+                <a:spcPct val="125000"/>
               </a:lnSpc>
             </a:pPr>
             <a:r>
@@ -3649,7 +3649,7 @@
           <a:p>
             <a:pPr algn="l">
               <a:lnSpc>
-                <a:spcPct val="165000"/>
+                <a:spcPct val="140000"/>
               </a:lnSpc>
             </a:pPr>
             <a:r>
@@ -3777,7 +3777,7 @@
           <a:p>
             <a:pPr algn="l">
               <a:lnSpc>
-                <a:spcPct val="150000"/>
+                <a:spcPct val="135000"/>
               </a:lnSpc>
             </a:pPr>
             <a:r>
@@ -3905,7 +3905,7 @@
           <a:p>
             <a:pPr algn="l">
               <a:lnSpc>
-                <a:spcPct val="150000"/>
+                <a:spcPct val="135000"/>
               </a:lnSpc>
             </a:pPr>
             <a:r>
@@ -4033,7 +4033,7 @@
           <a:p>
             <a:pPr algn="l">
               <a:lnSpc>
-                <a:spcPct val="150000"/>
+                <a:spcPct val="135000"/>
               </a:lnSpc>
             </a:pPr>
             <a:r>
@@ -4072,7 +4072,7 @@
           <a:p>
             <a:pPr algn="l">
               <a:lnSpc>
-                <a:spcPct val="140000"/>
+                <a:spcPct val="125000"/>
               </a:lnSpc>
             </a:pPr>
             <a:r>
@@ -6735,7 +6735,7 @@
           <a:p>
             <a:pPr algn="l">
               <a:lnSpc>
-                <a:spcPct val="165000"/>
+                <a:spcPct val="140000"/>
               </a:lnSpc>
             </a:pPr>
             <a:r>
@@ -6852,20 +6852,20 @@
         <p:spPr>
           <a:xfrm>
             <a:off x="841248" y="2414016"/>
-            <a:ext cx="2320290" cy="1097280"/>
-          </a:xfrm>
-          <a:prstGeom prst="rect">
-            <a:avLst/>
-          </a:prstGeom>
-          <a:noFill/>
-        </p:spPr>
-        <p:txBody>
-          <a:bodyPr wrap="square" lIns="0" tIns="0" rIns="0" bIns="0" anchor="t" rtlCol="0"/>
-          <a:lstStyle/>
-          <a:p>
-            <a:pPr algn="l">
-              <a:lnSpc>
-                <a:spcPct val="135000"/>
+            <a:ext cx="2320290" cy="1005840"/>
+          </a:xfrm>
+          <a:prstGeom prst="rect">
+            <a:avLst/>
+          </a:prstGeom>
+          <a:noFill/>
+        </p:spPr>
+        <p:txBody>
+          <a:bodyPr wrap="square" lIns="0" tIns="0" rIns="0" bIns="0" anchor="t" rtlCol="0"/>
+          <a:lstStyle/>
+          <a:p>
+            <a:pPr algn="l">
+              <a:lnSpc>
+                <a:spcPct val="125000"/>
               </a:lnSpc>
             </a:pPr>
             <a:r>
@@ -6890,21 +6890,21 @@
         </p:nvSpPr>
         <p:spPr>
           <a:xfrm>
-            <a:off x="841248" y="3602736"/>
-            <a:ext cx="2320290" cy="1353312"/>
-          </a:xfrm>
-          <a:prstGeom prst="rect">
-            <a:avLst/>
-          </a:prstGeom>
-          <a:noFill/>
-        </p:spPr>
-        <p:txBody>
-          <a:bodyPr wrap="square" lIns="0" tIns="0" rIns="0" bIns="0" anchor="t" rtlCol="0"/>
-          <a:lstStyle/>
-          <a:p>
-            <a:pPr algn="l">
-              <a:lnSpc>
-                <a:spcPct val="175000"/>
+            <a:off x="841248" y="3511296"/>
+            <a:ext cx="2320290" cy="1444752"/>
+          </a:xfrm>
+          <a:prstGeom prst="rect">
+            <a:avLst/>
+          </a:prstGeom>
+          <a:noFill/>
+        </p:spPr>
+        <p:txBody>
+          <a:bodyPr wrap="square" lIns="0" tIns="0" rIns="0" bIns="0" anchor="t" rtlCol="0"/>
+          <a:lstStyle/>
+          <a:p>
+            <a:pPr algn="l">
+              <a:lnSpc>
+                <a:spcPct val="155000"/>
               </a:lnSpc>
             </a:pPr>
             <a:r>
@@ -6996,20 +6996,20 @@
         <p:spPr>
           <a:xfrm>
             <a:off x="3573018" y="2414016"/>
-            <a:ext cx="2320290" cy="1097280"/>
-          </a:xfrm>
-          <a:prstGeom prst="rect">
-            <a:avLst/>
-          </a:prstGeom>
-          <a:noFill/>
-        </p:spPr>
-        <p:txBody>
-          <a:bodyPr wrap="square" lIns="0" tIns="0" rIns="0" bIns="0" anchor="t" rtlCol="0"/>
-          <a:lstStyle/>
-          <a:p>
-            <a:pPr algn="l">
-              <a:lnSpc>
-                <a:spcPct val="135000"/>
+            <a:ext cx="2320290" cy="1005840"/>
+          </a:xfrm>
+          <a:prstGeom prst="rect">
+            <a:avLst/>
+          </a:prstGeom>
+          <a:noFill/>
+        </p:spPr>
+        <p:txBody>
+          <a:bodyPr wrap="square" lIns="0" tIns="0" rIns="0" bIns="0" anchor="t" rtlCol="0"/>
+          <a:lstStyle/>
+          <a:p>
+            <a:pPr algn="l">
+              <a:lnSpc>
+                <a:spcPct val="125000"/>
               </a:lnSpc>
             </a:pPr>
             <a:r>
@@ -7027,7 +7027,7 @@
           <a:p>
             <a:pPr algn="l">
               <a:lnSpc>
-                <a:spcPct val="135000"/>
+                <a:spcPct val="125000"/>
               </a:lnSpc>
             </a:pPr>
             <a:r>
@@ -7052,21 +7052,21 @@
         </p:nvSpPr>
         <p:spPr>
           <a:xfrm>
-            <a:off x="3573018" y="3602736"/>
-            <a:ext cx="2320290" cy="1353312"/>
-          </a:xfrm>
-          <a:prstGeom prst="rect">
-            <a:avLst/>
-          </a:prstGeom>
-          <a:noFill/>
-        </p:spPr>
-        <p:txBody>
-          <a:bodyPr wrap="square" lIns="0" tIns="0" rIns="0" bIns="0" anchor="t" rtlCol="0"/>
-          <a:lstStyle/>
-          <a:p>
-            <a:pPr algn="l">
-              <a:lnSpc>
-                <a:spcPct val="175000"/>
+            <a:off x="3573018" y="3511296"/>
+            <a:ext cx="2320290" cy="1444752"/>
+          </a:xfrm>
+          <a:prstGeom prst="rect">
+            <a:avLst/>
+          </a:prstGeom>
+          <a:noFill/>
+        </p:spPr>
+        <p:txBody>
+          <a:bodyPr wrap="square" lIns="0" tIns="0" rIns="0" bIns="0" anchor="t" rtlCol="0"/>
+          <a:lstStyle/>
+          <a:p>
+            <a:pPr algn="l">
+              <a:lnSpc>
+                <a:spcPct val="155000"/>
               </a:lnSpc>
             </a:pPr>
             <a:r>
@@ -7158,20 +7158,20 @@
         <p:spPr>
           <a:xfrm>
             <a:off x="6304788" y="2414016"/>
-            <a:ext cx="2320290" cy="1097280"/>
-          </a:xfrm>
-          <a:prstGeom prst="rect">
-            <a:avLst/>
-          </a:prstGeom>
-          <a:noFill/>
-        </p:spPr>
-        <p:txBody>
-          <a:bodyPr wrap="square" lIns="0" tIns="0" rIns="0" bIns="0" anchor="t" rtlCol="0"/>
-          <a:lstStyle/>
-          <a:p>
-            <a:pPr algn="l">
-              <a:lnSpc>
-                <a:spcPct val="135000"/>
+            <a:ext cx="2320290" cy="1005840"/>
+          </a:xfrm>
+          <a:prstGeom prst="rect">
+            <a:avLst/>
+          </a:prstGeom>
+          <a:noFill/>
+        </p:spPr>
+        <p:txBody>
+          <a:bodyPr wrap="square" lIns="0" tIns="0" rIns="0" bIns="0" anchor="t" rtlCol="0"/>
+          <a:lstStyle/>
+          <a:p>
+            <a:pPr algn="l">
+              <a:lnSpc>
+                <a:spcPct val="125000"/>
               </a:lnSpc>
             </a:pPr>
             <a:r>
@@ -7196,21 +7196,21 @@
         </p:nvSpPr>
         <p:spPr>
           <a:xfrm>
-            <a:off x="6304788" y="3602736"/>
-            <a:ext cx="2320290" cy="1353312"/>
-          </a:xfrm>
-          <a:prstGeom prst="rect">
-            <a:avLst/>
-          </a:prstGeom>
-          <a:noFill/>
-        </p:spPr>
-        <p:txBody>
-          <a:bodyPr wrap="square" lIns="0" tIns="0" rIns="0" bIns="0" anchor="t" rtlCol="0"/>
-          <a:lstStyle/>
-          <a:p>
-            <a:pPr algn="l">
-              <a:lnSpc>
-                <a:spcPct val="175000"/>
+            <a:off x="6304788" y="3511296"/>
+            <a:ext cx="2320290" cy="1444752"/>
+          </a:xfrm>
+          <a:prstGeom prst="rect">
+            <a:avLst/>
+          </a:prstGeom>
+          <a:noFill/>
+        </p:spPr>
+        <p:txBody>
+          <a:bodyPr wrap="square" lIns="0" tIns="0" rIns="0" bIns="0" anchor="t" rtlCol="0"/>
+          <a:lstStyle/>
+          <a:p>
+            <a:pPr algn="l">
+              <a:lnSpc>
+                <a:spcPct val="155000"/>
               </a:lnSpc>
             </a:pPr>
             <a:r>
@@ -7302,20 +7302,20 @@
         <p:spPr>
           <a:xfrm>
             <a:off x="9036558" y="2414016"/>
-            <a:ext cx="2320290" cy="1097280"/>
-          </a:xfrm>
-          <a:prstGeom prst="rect">
-            <a:avLst/>
-          </a:prstGeom>
-          <a:noFill/>
-        </p:spPr>
-        <p:txBody>
-          <a:bodyPr wrap="square" lIns="0" tIns="0" rIns="0" bIns="0" anchor="t" rtlCol="0"/>
-          <a:lstStyle/>
-          <a:p>
-            <a:pPr algn="l">
-              <a:lnSpc>
-                <a:spcPct val="135000"/>
+            <a:ext cx="2320290" cy="1005840"/>
+          </a:xfrm>
+          <a:prstGeom prst="rect">
+            <a:avLst/>
+          </a:prstGeom>
+          <a:noFill/>
+        </p:spPr>
+        <p:txBody>
+          <a:bodyPr wrap="square" lIns="0" tIns="0" rIns="0" bIns="0" anchor="t" rtlCol="0"/>
+          <a:lstStyle/>
+          <a:p>
+            <a:pPr algn="l">
+              <a:lnSpc>
+                <a:spcPct val="125000"/>
               </a:lnSpc>
             </a:pPr>
             <a:r>
@@ -7333,7 +7333,7 @@
           <a:p>
             <a:pPr algn="l">
               <a:lnSpc>
-                <a:spcPct val="135000"/>
+                <a:spcPct val="125000"/>
               </a:lnSpc>
             </a:pPr>
             <a:r>
@@ -7358,21 +7358,21 @@
         </p:nvSpPr>
         <p:spPr>
           <a:xfrm>
-            <a:off x="9036558" y="3602736"/>
-            <a:ext cx="2320290" cy="1353312"/>
-          </a:xfrm>
-          <a:prstGeom prst="rect">
-            <a:avLst/>
-          </a:prstGeom>
-          <a:noFill/>
-        </p:spPr>
-        <p:txBody>
-          <a:bodyPr wrap="square" lIns="0" tIns="0" rIns="0" bIns="0" anchor="t" rtlCol="0"/>
-          <a:lstStyle/>
-          <a:p>
-            <a:pPr algn="l">
-              <a:lnSpc>
-                <a:spcPct val="175000"/>
+            <a:off x="9036558" y="3511296"/>
+            <a:ext cx="2320290" cy="1444752"/>
+          </a:xfrm>
+          <a:prstGeom prst="rect">
+            <a:avLst/>
+          </a:prstGeom>
+          <a:noFill/>
+        </p:spPr>
+        <p:txBody>
+          <a:bodyPr wrap="square" lIns="0" tIns="0" rIns="0" bIns="0" anchor="t" rtlCol="0"/>
+          <a:lstStyle/>
+          <a:p>
+            <a:pPr algn="l">
+              <a:lnSpc>
+                <a:spcPct val="155000"/>
               </a:lnSpc>
             </a:pPr>
             <a:r>
@@ -7411,7 +7411,7 @@
           <a:p>
             <a:pPr algn="l">
               <a:lnSpc>
-                <a:spcPct val="140000"/>
+                <a:spcPct val="125000"/>
               </a:lnSpc>
             </a:pPr>
             <a:r>
@@ -7600,7 +7600,7 @@
           <a:p>
             <a:pPr algn="l">
               <a:lnSpc>
-                <a:spcPct val="165000"/>
+                <a:spcPct val="140000"/>
               </a:lnSpc>
             </a:pPr>
             <a:r>
@@ -7692,20 +7692,20 @@
         <p:spPr>
           <a:xfrm>
             <a:off x="841248" y="2414016"/>
-            <a:ext cx="2320290" cy="1097280"/>
-          </a:xfrm>
-          <a:prstGeom prst="rect">
-            <a:avLst/>
-          </a:prstGeom>
-          <a:noFill/>
-        </p:spPr>
-        <p:txBody>
-          <a:bodyPr wrap="square" lIns="0" tIns="0" rIns="0" bIns="0" anchor="t" rtlCol="0"/>
-          <a:lstStyle/>
-          <a:p>
-            <a:pPr algn="l">
-              <a:lnSpc>
-                <a:spcPct val="135000"/>
+            <a:ext cx="2320290" cy="1005840"/>
+          </a:xfrm>
+          <a:prstGeom prst="rect">
+            <a:avLst/>
+          </a:prstGeom>
+          <a:noFill/>
+        </p:spPr>
+        <p:txBody>
+          <a:bodyPr wrap="square" lIns="0" tIns="0" rIns="0" bIns="0" anchor="t" rtlCol="0"/>
+          <a:lstStyle/>
+          <a:p>
+            <a:pPr algn="l">
+              <a:lnSpc>
+                <a:spcPct val="125000"/>
               </a:lnSpc>
             </a:pPr>
             <a:r>
@@ -7723,7 +7723,7 @@
           <a:p>
             <a:pPr algn="l">
               <a:lnSpc>
-                <a:spcPct val="135000"/>
+                <a:spcPct val="125000"/>
               </a:lnSpc>
             </a:pPr>
             <a:r>
@@ -7748,21 +7748,21 @@
         </p:nvSpPr>
         <p:spPr>
           <a:xfrm>
-            <a:off x="841248" y="3602736"/>
-            <a:ext cx="2320290" cy="1353312"/>
-          </a:xfrm>
-          <a:prstGeom prst="rect">
-            <a:avLst/>
-          </a:prstGeom>
-          <a:noFill/>
-        </p:spPr>
-        <p:txBody>
-          <a:bodyPr wrap="square" lIns="0" tIns="0" rIns="0" bIns="0" anchor="t" rtlCol="0"/>
-          <a:lstStyle/>
-          <a:p>
-            <a:pPr algn="l">
-              <a:lnSpc>
-                <a:spcPct val="175000"/>
+            <a:off x="841248" y="3511296"/>
+            <a:ext cx="2320290" cy="1444752"/>
+          </a:xfrm>
+          <a:prstGeom prst="rect">
+            <a:avLst/>
+          </a:prstGeom>
+          <a:noFill/>
+        </p:spPr>
+        <p:txBody>
+          <a:bodyPr wrap="square" lIns="0" tIns="0" rIns="0" bIns="0" anchor="t" rtlCol="0"/>
+          <a:lstStyle/>
+          <a:p>
+            <a:pPr algn="l">
+              <a:lnSpc>
+                <a:spcPct val="155000"/>
               </a:lnSpc>
             </a:pPr>
             <a:r>
@@ -7854,20 +7854,20 @@
         <p:spPr>
           <a:xfrm>
             <a:off x="3573018" y="2414016"/>
-            <a:ext cx="2320290" cy="1097280"/>
-          </a:xfrm>
-          <a:prstGeom prst="rect">
-            <a:avLst/>
-          </a:prstGeom>
-          <a:noFill/>
-        </p:spPr>
-        <p:txBody>
-          <a:bodyPr wrap="square" lIns="0" tIns="0" rIns="0" bIns="0" anchor="t" rtlCol="0"/>
-          <a:lstStyle/>
-          <a:p>
-            <a:pPr algn="l">
-              <a:lnSpc>
-                <a:spcPct val="135000"/>
+            <a:ext cx="2320290" cy="1005840"/>
+          </a:xfrm>
+          <a:prstGeom prst="rect">
+            <a:avLst/>
+          </a:prstGeom>
+          <a:noFill/>
+        </p:spPr>
+        <p:txBody>
+          <a:bodyPr wrap="square" lIns="0" tIns="0" rIns="0" bIns="0" anchor="t" rtlCol="0"/>
+          <a:lstStyle/>
+          <a:p>
+            <a:pPr algn="l">
+              <a:lnSpc>
+                <a:spcPct val="125000"/>
               </a:lnSpc>
             </a:pPr>
             <a:r>
@@ -7885,7 +7885,7 @@
           <a:p>
             <a:pPr algn="l">
               <a:lnSpc>
-                <a:spcPct val="135000"/>
+                <a:spcPct val="125000"/>
               </a:lnSpc>
             </a:pPr>
             <a:r>
@@ -7910,21 +7910,21 @@
         </p:nvSpPr>
         <p:spPr>
           <a:xfrm>
-            <a:off x="3573018" y="3602736"/>
-            <a:ext cx="2320290" cy="1353312"/>
-          </a:xfrm>
-          <a:prstGeom prst="rect">
-            <a:avLst/>
-          </a:prstGeom>
-          <a:noFill/>
-        </p:spPr>
-        <p:txBody>
-          <a:bodyPr wrap="square" lIns="0" tIns="0" rIns="0" bIns="0" anchor="t" rtlCol="0"/>
-          <a:lstStyle/>
-          <a:p>
-            <a:pPr algn="l">
-              <a:lnSpc>
-                <a:spcPct val="175000"/>
+            <a:off x="3573018" y="3511296"/>
+            <a:ext cx="2320290" cy="1444752"/>
+          </a:xfrm>
+          <a:prstGeom prst="rect">
+            <a:avLst/>
+          </a:prstGeom>
+          <a:noFill/>
+        </p:spPr>
+        <p:txBody>
+          <a:bodyPr wrap="square" lIns="0" tIns="0" rIns="0" bIns="0" anchor="t" rtlCol="0"/>
+          <a:lstStyle/>
+          <a:p>
+            <a:pPr algn="l">
+              <a:lnSpc>
+                <a:spcPct val="155000"/>
               </a:lnSpc>
             </a:pPr>
             <a:r>
@@ -8016,20 +8016,20 @@
         <p:spPr>
           <a:xfrm>
             <a:off x="6304788" y="2414016"/>
-            <a:ext cx="2320290" cy="1097280"/>
-          </a:xfrm>
-          <a:prstGeom prst="rect">
-            <a:avLst/>
-          </a:prstGeom>
-          <a:noFill/>
-        </p:spPr>
-        <p:txBody>
-          <a:bodyPr wrap="square" lIns="0" tIns="0" rIns="0" bIns="0" anchor="t" rtlCol="0"/>
-          <a:lstStyle/>
-          <a:p>
-            <a:pPr algn="l">
-              <a:lnSpc>
-                <a:spcPct val="135000"/>
+            <a:ext cx="2320290" cy="1005840"/>
+          </a:xfrm>
+          <a:prstGeom prst="rect">
+            <a:avLst/>
+          </a:prstGeom>
+          <a:noFill/>
+        </p:spPr>
+        <p:txBody>
+          <a:bodyPr wrap="square" lIns="0" tIns="0" rIns="0" bIns="0" anchor="t" rtlCol="0"/>
+          <a:lstStyle/>
+          <a:p>
+            <a:pPr algn="l">
+              <a:lnSpc>
+                <a:spcPct val="125000"/>
               </a:lnSpc>
             </a:pPr>
             <a:r>
@@ -8047,7 +8047,7 @@
           <a:p>
             <a:pPr algn="l">
               <a:lnSpc>
-                <a:spcPct val="135000"/>
+                <a:spcPct val="125000"/>
               </a:lnSpc>
             </a:pPr>
             <a:r>
@@ -8072,21 +8072,21 @@
         </p:nvSpPr>
         <p:spPr>
           <a:xfrm>
-            <a:off x="6304788" y="3602736"/>
-            <a:ext cx="2320290" cy="1353312"/>
-          </a:xfrm>
-          <a:prstGeom prst="rect">
-            <a:avLst/>
-          </a:prstGeom>
-          <a:noFill/>
-        </p:spPr>
-        <p:txBody>
-          <a:bodyPr wrap="square" lIns="0" tIns="0" rIns="0" bIns="0" anchor="t" rtlCol="0"/>
-          <a:lstStyle/>
-          <a:p>
-            <a:pPr algn="l">
-              <a:lnSpc>
-                <a:spcPct val="175000"/>
+            <a:off x="6304788" y="3511296"/>
+            <a:ext cx="2320290" cy="1444752"/>
+          </a:xfrm>
+          <a:prstGeom prst="rect">
+            <a:avLst/>
+          </a:prstGeom>
+          <a:noFill/>
+        </p:spPr>
+        <p:txBody>
+          <a:bodyPr wrap="square" lIns="0" tIns="0" rIns="0" bIns="0" anchor="t" rtlCol="0"/>
+          <a:lstStyle/>
+          <a:p>
+            <a:pPr algn="l">
+              <a:lnSpc>
+                <a:spcPct val="155000"/>
               </a:lnSpc>
             </a:pPr>
             <a:r>
@@ -8178,20 +8178,20 @@
         <p:spPr>
           <a:xfrm>
             <a:off x="9036558" y="2414016"/>
-            <a:ext cx="2320290" cy="1097280"/>
-          </a:xfrm>
-          <a:prstGeom prst="rect">
-            <a:avLst/>
-          </a:prstGeom>
-          <a:noFill/>
-        </p:spPr>
-        <p:txBody>
-          <a:bodyPr wrap="square" lIns="0" tIns="0" rIns="0" bIns="0" anchor="t" rtlCol="0"/>
-          <a:lstStyle/>
-          <a:p>
-            <a:pPr algn="l">
-              <a:lnSpc>
-                <a:spcPct val="135000"/>
+            <a:ext cx="2320290" cy="1005840"/>
+          </a:xfrm>
+          <a:prstGeom prst="rect">
+            <a:avLst/>
+          </a:prstGeom>
+          <a:noFill/>
+        </p:spPr>
+        <p:txBody>
+          <a:bodyPr wrap="square" lIns="0" tIns="0" rIns="0" bIns="0" anchor="t" rtlCol="0"/>
+          <a:lstStyle/>
+          <a:p>
+            <a:pPr algn="l">
+              <a:lnSpc>
+                <a:spcPct val="125000"/>
               </a:lnSpc>
             </a:pPr>
             <a:r>
@@ -8209,7 +8209,7 @@
           <a:p>
             <a:pPr algn="l">
               <a:lnSpc>
-                <a:spcPct val="135000"/>
+                <a:spcPct val="125000"/>
               </a:lnSpc>
             </a:pPr>
             <a:r>
@@ -8234,21 +8234,21 @@
         </p:nvSpPr>
         <p:spPr>
           <a:xfrm>
-            <a:off x="9036558" y="3602736"/>
-            <a:ext cx="2320290" cy="1353312"/>
-          </a:xfrm>
-          <a:prstGeom prst="rect">
-            <a:avLst/>
-          </a:prstGeom>
-          <a:noFill/>
-        </p:spPr>
-        <p:txBody>
-          <a:bodyPr wrap="square" lIns="0" tIns="0" rIns="0" bIns="0" anchor="t" rtlCol="0"/>
-          <a:lstStyle/>
-          <a:p>
-            <a:pPr algn="l">
-              <a:lnSpc>
-                <a:spcPct val="175000"/>
+            <a:off x="9036558" y="3511296"/>
+            <a:ext cx="2320290" cy="1444752"/>
+          </a:xfrm>
+          <a:prstGeom prst="rect">
+            <a:avLst/>
+          </a:prstGeom>
+          <a:noFill/>
+        </p:spPr>
+        <p:txBody>
+          <a:bodyPr wrap="square" lIns="0" tIns="0" rIns="0" bIns="0" anchor="t" rtlCol="0"/>
+          <a:lstStyle/>
+          <a:p>
+            <a:pPr algn="l">
+              <a:lnSpc>
+                <a:spcPct val="155000"/>
               </a:lnSpc>
             </a:pPr>
             <a:r>
@@ -8287,7 +8287,7 @@
           <a:p>
             <a:pPr algn="l">
               <a:lnSpc>
-                <a:spcPct val="140000"/>
+                <a:spcPct val="125000"/>
               </a:lnSpc>
             </a:pPr>
             <a:r>
@@ -8476,7 +8476,7 @@
           <a:p>
             <a:pPr algn="l">
               <a:lnSpc>
-                <a:spcPct val="165000"/>
+                <a:spcPct val="140000"/>
               </a:lnSpc>
             </a:pPr>
             <a:r>
@@ -8554,7 +8554,7 @@
           <a:p>
             <a:pPr algn="l">
               <a:lnSpc>
-                <a:spcPct val="170000"/>
+                <a:spcPct val="145000"/>
               </a:lnSpc>
             </a:pPr>
             <a:r>
@@ -8654,7 +8654,7 @@
           <a:p>
             <a:pPr algn="l">
               <a:lnSpc>
-                <a:spcPct val="170000"/>
+                <a:spcPct val="145000"/>
               </a:lnSpc>
             </a:pPr>
             <a:r>
@@ -8754,7 +8754,7 @@
           <a:p>
             <a:pPr algn="l">
               <a:lnSpc>
-                <a:spcPct val="170000"/>
+                <a:spcPct val="145000"/>
               </a:lnSpc>
             </a:pPr>
             <a:r>
@@ -8815,7 +8815,7 @@
           <a:p>
             <a:pPr algn="l">
               <a:lnSpc>
-                <a:spcPct val="140000"/>
+                <a:spcPct val="125000"/>
               </a:lnSpc>
             </a:pPr>
             <a:r>
@@ -9004,7 +9004,7 @@
           <a:p>
             <a:pPr algn="l">
               <a:lnSpc>
-                <a:spcPct val="165000"/>
+                <a:spcPct val="140000"/>
               </a:lnSpc>
             </a:pPr>
             <a:r>
@@ -9187,7 +9187,7 @@
           <a:p>
             <a:pPr algn="l">
               <a:lnSpc>
-                <a:spcPct val="145000"/>
+                <a:spcPct val="130000"/>
               </a:lnSpc>
             </a:pPr>
             <a:r>
@@ -9226,7 +9226,7 @@
           <a:p>
             <a:pPr algn="l">
               <a:lnSpc>
-                <a:spcPct val="145000"/>
+                <a:spcPct val="130000"/>
               </a:lnSpc>
             </a:pPr>
             <a:r>
@@ -9265,7 +9265,7 @@
           <a:p>
             <a:pPr algn="l">
               <a:lnSpc>
-                <a:spcPct val="145000"/>
+                <a:spcPct val="130000"/>
               </a:lnSpc>
             </a:pPr>
             <a:r>
@@ -9331,7 +9331,7 @@
           <a:p>
             <a:pPr algn="l">
               <a:lnSpc>
-                <a:spcPct val="145000"/>
+                <a:spcPct val="130000"/>
               </a:lnSpc>
             </a:pPr>
             <a:r>
@@ -9370,7 +9370,7 @@
           <a:p>
             <a:pPr algn="l">
               <a:lnSpc>
-                <a:spcPct val="145000"/>
+                <a:spcPct val="130000"/>
               </a:lnSpc>
             </a:pPr>
             <a:r>
@@ -9409,7 +9409,7 @@
           <a:p>
             <a:pPr algn="l">
               <a:lnSpc>
-                <a:spcPct val="145000"/>
+                <a:spcPct val="130000"/>
               </a:lnSpc>
             </a:pPr>
             <a:r>
@@ -9475,7 +9475,7 @@
           <a:p>
             <a:pPr algn="l">
               <a:lnSpc>
-                <a:spcPct val="145000"/>
+                <a:spcPct val="130000"/>
               </a:lnSpc>
             </a:pPr>
             <a:r>
@@ -9514,7 +9514,7 @@
           <a:p>
             <a:pPr algn="l">
               <a:lnSpc>
-                <a:spcPct val="145000"/>
+                <a:spcPct val="130000"/>
               </a:lnSpc>
             </a:pPr>
             <a:r>
@@ -9553,7 +9553,7 @@
           <a:p>
             <a:pPr algn="l">
               <a:lnSpc>
-                <a:spcPct val="145000"/>
+                <a:spcPct val="130000"/>
               </a:lnSpc>
             </a:pPr>
             <a:r>
@@ -9565,7 +9565,7 @@
                 <a:ea typeface="Yu Gothic"/>
                 <a:cs typeface="Yu Gothic"/>
               </a:rPr>
-              <a:t>【彼の名前】</a:t>
+              <a:t>凪</a:t>
             </a:r>
           </a:p>
         </p:txBody>
@@ -9619,7 +9619,7 @@
           <a:p>
             <a:pPr algn="l">
               <a:lnSpc>
-                <a:spcPct val="145000"/>
+                <a:spcPct val="130000"/>
               </a:lnSpc>
             </a:pPr>
             <a:r>
@@ -9658,7 +9658,7 @@
           <a:p>
             <a:pPr algn="l">
               <a:lnSpc>
-                <a:spcPct val="145000"/>
+                <a:spcPct val="130000"/>
               </a:lnSpc>
             </a:pPr>
             <a:r>
@@ -9697,7 +9697,7 @@
           <a:p>
             <a:pPr algn="l">
               <a:lnSpc>
-                <a:spcPct val="145000"/>
+                <a:spcPct val="130000"/>
               </a:lnSpc>
             </a:pPr>
             <a:r>
@@ -9763,7 +9763,7 @@
           <a:p>
             <a:pPr algn="l">
               <a:lnSpc>
-                <a:spcPct val="145000"/>
+                <a:spcPct val="130000"/>
               </a:lnSpc>
             </a:pPr>
             <a:r>
@@ -9802,7 +9802,7 @@
           <a:p>
             <a:pPr algn="l">
               <a:lnSpc>
-                <a:spcPct val="145000"/>
+                <a:spcPct val="130000"/>
               </a:lnSpc>
             </a:pPr>
             <a:r>
@@ -9841,7 +9841,7 @@
           <a:p>
             <a:pPr algn="l">
               <a:lnSpc>
-                <a:spcPct val="145000"/>
+                <a:spcPct val="130000"/>
               </a:lnSpc>
             </a:pPr>
             <a:r>
@@ -9853,7 +9853,7 @@
                 <a:ea typeface="Yu Gothic"/>
                 <a:cs typeface="Yu Gothic"/>
               </a:rPr>
-              <a:t>【彼の名前】</a:t>
+              <a:t>凪</a:t>
             </a:r>
           </a:p>
         </p:txBody>
@@ -9934,7 +9934,7 @@
           <a:p>
             <a:pPr algn="l">
               <a:lnSpc>
-                <a:spcPct val="145000"/>
+                <a:spcPct val="130000"/>
               </a:lnSpc>
             </a:pPr>
             <a:r>
@@ -9973,7 +9973,7 @@
           <a:p>
             <a:pPr algn="l">
               <a:lnSpc>
-                <a:spcPct val="145000"/>
+                <a:spcPct val="130000"/>
               </a:lnSpc>
             </a:pPr>
             <a:r>
@@ -10012,7 +10012,7 @@
           <a:p>
             <a:pPr algn="l">
               <a:lnSpc>
-                <a:spcPct val="145000"/>
+                <a:spcPct val="130000"/>
               </a:lnSpc>
             </a:pPr>
             <a:r>
@@ -10024,7 +10024,7 @@
                 <a:ea typeface="Yu Gothic"/>
                 <a:cs typeface="Yu Gothic"/>
               </a:rPr>
-              <a:t>【彼の名前】</a:t>
+              <a:t>凪</a:t>
             </a:r>
           </a:p>
         </p:txBody>
@@ -10078,7 +10078,7 @@
           <a:p>
             <a:pPr algn="l">
               <a:lnSpc>
-                <a:spcPct val="145000"/>
+                <a:spcPct val="130000"/>
               </a:lnSpc>
             </a:pPr>
             <a:r>
@@ -10117,7 +10117,7 @@
           <a:p>
             <a:pPr algn="l">
               <a:lnSpc>
-                <a:spcPct val="145000"/>
+                <a:spcPct val="130000"/>
               </a:lnSpc>
             </a:pPr>
             <a:r>
@@ -10156,7 +10156,7 @@
           <a:p>
             <a:pPr algn="l">
               <a:lnSpc>
-                <a:spcPct val="145000"/>
+                <a:spcPct val="130000"/>
               </a:lnSpc>
             </a:pPr>
             <a:r>

</xml_diff>

<commit_message>
Add 私の魅力 and お互いについて pages to plan proposal
Two pages before 約束: five numbered points on my side, and three
columns on how we work as a pair, closing on living together.

Co-Authored-By: Claude Opus 5 <noreply@anthropic.com>
Claude-Session: https://claude.ai/code/session_017z6FTKMRuHAVL86624AoYU
</commit_message>
<xml_diff>
--- a/proposal/ふたりの計画のご提案.pptx
+++ b/proposal/ふたりの計画のご提案.pptx
@@ -19,6 +19,8 @@
     <p:sldId id="264" r:id="rId11"/>
     <p:sldId id="265" r:id="rId12"/>
     <p:sldId id="266" r:id="rId13"/>
+    <p:sldId id="267" r:id="rId14"/>
+    <p:sldId id="268" r:id="rId15"/>
   </p:sldIdLst>
   <p:sldSz cx="12191695" cy="6858000"/>
   <p:notesSz cx="6858000" cy="9144000"/>
@@ -231,7 +233,7 @@
           <a:p>
             <a:r>
               <a:rPr lang="ja-JP" altLang="en-US" sz="1200"/>
-              <a:t>「改善中」は正直に。自己PRはしない。</a:t>
+              <a:t>真顔で読む。5つ目で笑われたら成功。</a:t>
             </a:r>
           </a:p>
         </p:txBody>
@@ -245,6 +247,124 @@
 </file>
 
 <file path=ppt/notesSlides/notesSlide11.xml><?xml version="1.0" encoding="utf-8"?>
+<p:notes xmlns:a="http://schemas.openxmlformats.org/drawingml/2006/main" xmlns:r="http://schemas.openxmlformats.org/officeDocument/2006/relationships" xmlns:p="http://schemas.openxmlformats.org/presentationml/2006/main">
+  <p:cSld>
+    <p:spTree>
+      <p:nvGrpSpPr>
+        <p:cNvPr id="1" name=""/>
+        <p:cNvGrpSpPr/>
+        <p:nvPr/>
+      </p:nvGrpSpPr>
+      <p:grpSpPr>
+        <a:xfrm>
+          <a:off x="0" y="0"/>
+          <a:ext cx="0" cy="0"/>
+          <a:chOff x="0" y="0"/>
+          <a:chExt cx="0" cy="0"/>
+        </a:xfrm>
+      </p:grpSpPr>
+      <p:sp>
+        <p:nvSpPr>
+          <p:cNvPr id="2" name="Slide Image Placeholder 1"/>
+          <p:cNvSpPr>
+            <a:spLocks noGrp="1" noRot="1" noChangeAspect="1"/>
+          </p:cNvSpPr>
+          <p:nvPr>
+            <p:ph type="sldImg"/>
+          </p:nvPr>
+        </p:nvSpPr>
+        <p:spPr/>
+      </p:sp>
+      <p:sp>
+        <p:nvSpPr>
+          <p:cNvPr id="3" name="Notes Placeholder 2"/>
+          <p:cNvSpPr>
+            <a:spLocks noGrp="1"/>
+          </p:cNvSpPr>
+          <p:nvPr>
+            <p:ph type="body" idx="1"/>
+          </p:nvPr>
+        </p:nvSpPr>
+        <p:spPr/>
+        <p:txBody>
+          <a:bodyPr/>
+          <a:lstStyle/>
+          <a:p>
+            <a:r>
+              <a:rPr lang="ja-JP" altLang="en-US" sz="1200"/>
+              <a:t>「たぶん」を消さない。言い切ると嘘くさくなる。</a:t>
+            </a:r>
+          </a:p>
+        </p:txBody>
+      </p:sp>
+    </p:spTree>
+  </p:cSld>
+  <p:clrMapOvr>
+    <a:masterClrMapping/>
+  </p:clrMapOvr>
+</p:notes>
+</file>
+
+<file path=ppt/notesSlides/notesSlide12.xml><?xml version="1.0" encoding="utf-8"?>
+<p:notes xmlns:a="http://schemas.openxmlformats.org/drawingml/2006/main" xmlns:r="http://schemas.openxmlformats.org/officeDocument/2006/relationships" xmlns:p="http://schemas.openxmlformats.org/presentationml/2006/main">
+  <p:cSld>
+    <p:spTree>
+      <p:nvGrpSpPr>
+        <p:cNvPr id="1" name=""/>
+        <p:cNvGrpSpPr/>
+        <p:nvPr/>
+      </p:nvGrpSpPr>
+      <p:grpSpPr>
+        <a:xfrm>
+          <a:off x="0" y="0"/>
+          <a:ext cx="0" cy="0"/>
+          <a:chOff x="0" y="0"/>
+          <a:chExt cx="0" cy="0"/>
+        </a:xfrm>
+      </p:grpSpPr>
+      <p:sp>
+        <p:nvSpPr>
+          <p:cNvPr id="2" name="Slide Image Placeholder 1"/>
+          <p:cNvSpPr>
+            <a:spLocks noGrp="1" noRot="1" noChangeAspect="1"/>
+          </p:cNvSpPr>
+          <p:nvPr>
+            <p:ph type="sldImg"/>
+          </p:nvPr>
+        </p:nvSpPr>
+        <p:spPr/>
+      </p:sp>
+      <p:sp>
+        <p:nvSpPr>
+          <p:cNvPr id="3" name="Notes Placeholder 2"/>
+          <p:cNvSpPr>
+            <a:spLocks noGrp="1"/>
+          </p:cNvSpPr>
+          <p:nvPr>
+            <p:ph type="body" idx="1"/>
+          </p:nvPr>
+        </p:nvSpPr>
+        <p:spPr/>
+        <p:txBody>
+          <a:bodyPr/>
+          <a:lstStyle/>
+          <a:p>
+            <a:r>
+              <a:rPr lang="ja-JP" altLang="en-US" sz="1200"/>
+              <a:t>「改善中」は正直に。自己PRはしない。</a:t>
+            </a:r>
+          </a:p>
+        </p:txBody>
+      </p:sp>
+    </p:spTree>
+  </p:cSld>
+  <p:clrMapOvr>
+    <a:masterClrMapping/>
+  </p:clrMapOvr>
+</p:notes>
+</file>
+
+<file path=ppt/notesSlides/notesSlide13.xml><?xml version="1.0" encoding="utf-8"?>
 <p:notes xmlns:a="http://schemas.openxmlformats.org/drawingml/2006/main" xmlns:r="http://schemas.openxmlformats.org/officeDocument/2006/relationships" xmlns:p="http://schemas.openxmlformats.org/presentationml/2006/main">
   <p:cSld>
     <p:spTree>
@@ -1114,7 +1234,7 @@
                 <a:ea typeface="Yu Gothic"/>
                 <a:cs typeface="Yu Gothic"/>
               </a:rPr>
-              <a:t>約束</a:t>
+              <a:t>私の魅力</a:t>
             </a:r>
           </a:p>
         </p:txBody>
@@ -1153,36 +1273,73 @@
                 <a:ea typeface="Yu Gothic Medium"/>
                 <a:cs typeface="Yu Gothic Medium"/>
               </a:rPr>
-              <a:t>私の側から先に書きます。変えないことと、直すことに分けました。</a:t>
-            </a:r>
-          </a:p>
-        </p:txBody>
-      </p:sp>
-      <p:sp>
-        <p:nvSpPr>
-          <p:cNvPr id="4" name="Shape 4"/>
-          <p:cNvSpPr/>
-          <p:nvPr/>
-        </p:nvSpPr>
-        <p:spPr>
-          <a:xfrm>
-            <a:off x="841248" y="1773936"/>
-            <a:ext cx="2320290" cy="38100"/>
-          </a:xfrm>
-          <a:prstGeom prst="rect">
-            <a:avLst/>
-          </a:prstGeom>
-          <a:solidFill>
-            <a:srgbClr val="00C4B3"/>
-          </a:solidFill>
-          <a:ln>
-            <a:noFill/>
-          </a:ln>
-        </p:spPr>
-        <p:txBody>
-          <a:bodyPr wrap="square" lIns="0" tIns="0" rIns="0" bIns="0" anchor="ctr" rtlCol="0"/>
-          <a:lstStyle/>
-          <a:p/>
+              <a:t>自分で言うのもなんですが、</a:t>
+            </a:r>
+            <a:r>
+              <a:rPr lang="ja-JP" altLang="en-US" sz="2200" b="0">
+                <a:solidFill>
+                  <a:srgbClr val="14141A"/>
+                </a:solidFill>
+                <a:highlight>
+                  <a:srgbClr val="FFD93D"/>
+                </a:highlight>
+                <a:latin typeface="Yu Gothic Medium"/>
+                <a:ea typeface="Yu Gothic Medium"/>
+                <a:cs typeface="Yu Gothic Medium"/>
+              </a:rPr>
+              <a:t>5つ</a:t>
+            </a:r>
+            <a:r>
+              <a:rPr lang="ja-JP" altLang="en-US" sz="2200" b="0">
+                <a:solidFill>
+                  <a:srgbClr val="14141A"/>
+                </a:solidFill>
+                <a:latin typeface="Yu Gothic Medium"/>
+                <a:ea typeface="Yu Gothic Medium"/>
+                <a:cs typeface="Yu Gothic Medium"/>
+              </a:rPr>
+              <a:t>あります。</a:t>
+            </a:r>
+          </a:p>
+        </p:txBody>
+      </p:sp>
+      <p:sp>
+        <p:nvSpPr>
+          <p:cNvPr id="4" name="TextBox 4"/>
+          <p:cNvSpPr txBox="1"/>
+          <p:nvPr/>
+        </p:nvSpPr>
+        <p:spPr>
+          <a:xfrm>
+            <a:off x="841248" y="1877264"/>
+            <a:ext cx="640080" cy="365760"/>
+          </a:xfrm>
+          <a:prstGeom prst="rect">
+            <a:avLst/>
+          </a:prstGeom>
+          <a:noFill/>
+        </p:spPr>
+        <p:txBody>
+          <a:bodyPr wrap="square" lIns="0" tIns="0" rIns="0" bIns="0" anchor="t" rtlCol="0"/>
+          <a:lstStyle/>
+          <a:p>
+            <a:pPr algn="l">
+              <a:lnSpc>
+                <a:spcPct val="145000"/>
+              </a:lnSpc>
+            </a:pPr>
+            <a:r>
+              <a:rPr lang="ja-JP" altLang="en-US" sz="1500" b="1" spc="100">
+                <a:solidFill>
+                  <a:srgbClr val="00C4B3"/>
+                </a:solidFill>
+                <a:latin typeface="Yu Gothic"/>
+                <a:ea typeface="Yu Gothic"/>
+                <a:cs typeface="Yu Gothic"/>
+              </a:rPr>
+              <a:t>01</a:t>
+            </a:r>
+          </a:p>
         </p:txBody>
       </p:sp>
       <p:sp>
@@ -1193,25 +1350,86 @@
         </p:nvSpPr>
         <p:spPr>
           <a:xfrm>
-            <a:off x="841248" y="2002536"/>
-            <a:ext cx="2320290" cy="320040"/>
-          </a:xfrm>
-          <a:prstGeom prst="rect">
-            <a:avLst/>
-          </a:prstGeom>
-          <a:noFill/>
-        </p:spPr>
-        <p:txBody>
-          <a:bodyPr wrap="square" lIns="0" tIns="0" rIns="0" bIns="0" anchor="t" rtlCol="0"/>
-          <a:lstStyle/>
-          <a:p>
-            <a:pPr algn="l">
-              <a:lnSpc>
-                <a:spcPct val="145000"/>
-              </a:lnSpc>
-            </a:pPr>
-            <a:r>
-              <a:rPr lang="ja-JP" altLang="en-US" sz="1200" b="1" spc="120">
+            <a:off x="1527048" y="1785824"/>
+            <a:ext cx="9784080" cy="914400"/>
+          </a:xfrm>
+          <a:prstGeom prst="rect">
+            <a:avLst/>
+          </a:prstGeom>
+          <a:noFill/>
+        </p:spPr>
+        <p:txBody>
+          <a:bodyPr wrap="square" lIns="0" tIns="0" rIns="0" bIns="0" anchor="t" rtlCol="0"/>
+          <a:lstStyle/>
+          <a:p>
+            <a:pPr algn="l">
+              <a:lnSpc>
+                <a:spcPct val="145000"/>
+              </a:lnSpc>
+            </a:pPr>
+            <a:r>
+              <a:rPr lang="ja-JP" altLang="en-US" sz="2000" b="0">
+                <a:solidFill>
+                  <a:srgbClr val="14141A"/>
+                </a:solidFill>
+                <a:latin typeface="Yu Gothic"/>
+                <a:ea typeface="Yu Gothic"/>
+                <a:cs typeface="Yu Gothic"/>
+              </a:rPr>
+              <a:t>顔面偏差値は、</a:t>
+            </a:r>
+            <a:r>
+              <a:rPr lang="ja-JP" altLang="en-US" sz="2000" b="1">
+                <a:solidFill>
+                  <a:srgbClr val="14141A"/>
+                </a:solidFill>
+                <a:latin typeface="Yu Gothic"/>
+                <a:ea typeface="Yu Gothic"/>
+                <a:cs typeface="Yu Gothic"/>
+              </a:rPr>
+              <a:t>まあまあ</a:t>
+            </a:r>
+            <a:r>
+              <a:rPr lang="ja-JP" altLang="en-US" sz="2000" b="0">
+                <a:solidFill>
+                  <a:srgbClr val="14141A"/>
+                </a:solidFill>
+                <a:latin typeface="Yu Gothic"/>
+                <a:ea typeface="Yu Gothic"/>
+                <a:cs typeface="Yu Gothic"/>
+              </a:rPr>
+              <a:t>あると思っています。</a:t>
+            </a:r>
+          </a:p>
+        </p:txBody>
+      </p:sp>
+      <p:sp>
+        <p:nvSpPr>
+          <p:cNvPr id="6" name="TextBox 6"/>
+          <p:cNvSpPr txBox="1"/>
+          <p:nvPr/>
+        </p:nvSpPr>
+        <p:spPr>
+          <a:xfrm>
+            <a:off x="841248" y="2723998"/>
+            <a:ext cx="640080" cy="365760"/>
+          </a:xfrm>
+          <a:prstGeom prst="rect">
+            <a:avLst/>
+          </a:prstGeom>
+          <a:noFill/>
+        </p:spPr>
+        <p:txBody>
+          <a:bodyPr wrap="square" lIns="0" tIns="0" rIns="0" bIns="0" anchor="t" rtlCol="0"/>
+          <a:lstStyle/>
+          <a:p>
+            <a:pPr algn="l">
+              <a:lnSpc>
+                <a:spcPct val="145000"/>
+              </a:lnSpc>
+            </a:pPr>
+            <a:r>
+              <a:rPr lang="ja-JP" altLang="en-US" sz="1500" b="1" spc="100">
                 <a:solidFill>
                   <a:srgbClr val="00C4B3"/>
                 </a:solidFill>
@@ -1219,64 +1437,7 @@
                 <a:ea typeface="Yu Gothic"/>
                 <a:cs typeface="Yu Gothic"/>
               </a:rPr>
-              <a:t>仕事</a:t>
-            </a:r>
-          </a:p>
-        </p:txBody>
-      </p:sp>
-      <p:sp>
-        <p:nvSpPr>
-          <p:cNvPr id="6" name="TextBox 6"/>
-          <p:cNvSpPr txBox="1"/>
-          <p:nvPr/>
-        </p:nvSpPr>
-        <p:spPr>
-          <a:xfrm>
-            <a:off x="841248" y="2414016"/>
-            <a:ext cx="2320290" cy="1005840"/>
-          </a:xfrm>
-          <a:prstGeom prst="rect">
-            <a:avLst/>
-          </a:prstGeom>
-          <a:noFill/>
-        </p:spPr>
-        <p:txBody>
-          <a:bodyPr wrap="square" lIns="0" tIns="0" rIns="0" bIns="0" anchor="t" rtlCol="0"/>
-          <a:lstStyle/>
-          <a:p>
-            <a:pPr algn="l">
-              <a:lnSpc>
-                <a:spcPct val="125000"/>
-              </a:lnSpc>
-            </a:pPr>
-            <a:r>
-              <a:rPr lang="ja-JP" altLang="en-US" sz="2200" b="1">
-                <a:solidFill>
-                  <a:srgbClr val="14141A"/>
-                </a:solidFill>
-                <a:latin typeface="Yu Gothic"/>
-                <a:ea typeface="Yu Gothic"/>
-                <a:cs typeface="Yu Gothic"/>
-              </a:rPr>
-              <a:t>熱量は</a:t>
-            </a:r>
-          </a:p>
-          <a:p>
-            <a:pPr algn="l">
-              <a:lnSpc>
-                <a:spcPct val="125000"/>
-              </a:lnSpc>
-            </a:pPr>
-            <a:r>
-              <a:rPr lang="ja-JP" altLang="en-US" sz="2200" b="1">
-                <a:solidFill>
-                  <a:srgbClr val="14141A"/>
-                </a:solidFill>
-                <a:latin typeface="Yu Gothic"/>
-                <a:ea typeface="Yu Gothic"/>
-                <a:cs typeface="Yu Gothic"/>
-              </a:rPr>
-              <a:t>落としません</a:t>
+              <a:t>02</a:t>
             </a:r>
           </a:p>
         </p:txBody>
@@ -1289,62 +1450,96 @@
         </p:nvSpPr>
         <p:spPr>
           <a:xfrm>
-            <a:off x="841248" y="3511296"/>
-            <a:ext cx="2320290" cy="1444752"/>
-          </a:xfrm>
-          <a:prstGeom prst="rect">
-            <a:avLst/>
-          </a:prstGeom>
-          <a:noFill/>
-        </p:spPr>
-        <p:txBody>
-          <a:bodyPr wrap="square" lIns="0" tIns="0" rIns="0" bIns="0" anchor="t" rtlCol="0"/>
-          <a:lstStyle/>
-          <a:p>
-            <a:pPr algn="l">
-              <a:lnSpc>
-                <a:spcPct val="155000"/>
-              </a:lnSpc>
-            </a:pPr>
-            <a:r>
-              <a:rPr lang="ja-JP" altLang="en-US" sz="1400" b="0">
-                <a:solidFill>
-                  <a:srgbClr val="14141A"/>
-                </a:solidFill>
-                <a:latin typeface="Yu Gothic"/>
-                <a:ea typeface="Yu Gothic"/>
-                <a:cs typeface="Yu Gothic"/>
-              </a:rPr>
-              <a:t>30歳まではお互い仕事優先です。結婚が仕事の邪魔をしない形にします。</a:t>
-            </a:r>
-          </a:p>
-        </p:txBody>
-      </p:sp>
-      <p:sp>
-        <p:nvSpPr>
-          <p:cNvPr id="8" name="Shape 8"/>
-          <p:cNvSpPr/>
-          <p:nvPr/>
-        </p:nvSpPr>
-        <p:spPr>
-          <a:xfrm>
-            <a:off x="3573018" y="1773936"/>
-            <a:ext cx="2320290" cy="38100"/>
-          </a:xfrm>
-          <a:prstGeom prst="rect">
-            <a:avLst/>
-          </a:prstGeom>
-          <a:solidFill>
-            <a:srgbClr val="FFD93D"/>
-          </a:solidFill>
-          <a:ln>
-            <a:noFill/>
-          </a:ln>
-        </p:spPr>
-        <p:txBody>
-          <a:bodyPr wrap="square" lIns="0" tIns="0" rIns="0" bIns="0" anchor="ctr" rtlCol="0"/>
-          <a:lstStyle/>
-          <a:p/>
+            <a:off x="1527048" y="2632558"/>
+            <a:ext cx="9784080" cy="914400"/>
+          </a:xfrm>
+          <a:prstGeom prst="rect">
+            <a:avLst/>
+          </a:prstGeom>
+          <a:noFill/>
+        </p:spPr>
+        <p:txBody>
+          <a:bodyPr wrap="square" lIns="0" tIns="0" rIns="0" bIns="0" anchor="t" rtlCol="0"/>
+          <a:lstStyle/>
+          <a:p>
+            <a:pPr algn="l">
+              <a:lnSpc>
+                <a:spcPct val="145000"/>
+              </a:lnSpc>
+            </a:pPr>
+            <a:r>
+              <a:rPr lang="ja-JP" altLang="en-US" sz="2000" b="0">
+                <a:solidFill>
+                  <a:srgbClr val="14141A"/>
+                </a:solidFill>
+                <a:latin typeface="Yu Gothic"/>
+                <a:ea typeface="Yu Gothic"/>
+                <a:cs typeface="Yu Gothic"/>
+              </a:rPr>
+              <a:t>仕事に人生をかけているので、</a:t>
+            </a:r>
+            <a:r>
+              <a:rPr lang="ja-JP" altLang="en-US" sz="2000" b="1">
+                <a:solidFill>
+                  <a:srgbClr val="14141A"/>
+                </a:solidFill>
+                <a:latin typeface="Yu Gothic"/>
+                <a:ea typeface="Yu Gothic"/>
+                <a:cs typeface="Yu Gothic"/>
+              </a:rPr>
+              <a:t>自立</a:t>
+            </a:r>
+            <a:r>
+              <a:rPr lang="ja-JP" altLang="en-US" sz="2000" b="0">
+                <a:solidFill>
+                  <a:srgbClr val="14141A"/>
+                </a:solidFill>
+                <a:latin typeface="Yu Gothic"/>
+                <a:ea typeface="Yu Gothic"/>
+                <a:cs typeface="Yu Gothic"/>
+              </a:rPr>
+              <a:t>しています。将来の安定性もあります。</a:t>
+            </a:r>
+          </a:p>
+        </p:txBody>
+      </p:sp>
+      <p:sp>
+        <p:nvSpPr>
+          <p:cNvPr id="8" name="TextBox 8"/>
+          <p:cNvSpPr txBox="1"/>
+          <p:nvPr/>
+        </p:nvSpPr>
+        <p:spPr>
+          <a:xfrm>
+            <a:off x="841248" y="3570732"/>
+            <a:ext cx="640080" cy="365760"/>
+          </a:xfrm>
+          <a:prstGeom prst="rect">
+            <a:avLst/>
+          </a:prstGeom>
+          <a:noFill/>
+        </p:spPr>
+        <p:txBody>
+          <a:bodyPr wrap="square" lIns="0" tIns="0" rIns="0" bIns="0" anchor="t" rtlCol="0"/>
+          <a:lstStyle/>
+          <a:p>
+            <a:pPr algn="l">
+              <a:lnSpc>
+                <a:spcPct val="145000"/>
+              </a:lnSpc>
+            </a:pPr>
+            <a:r>
+              <a:rPr lang="ja-JP" altLang="en-US" sz="1500" b="1" spc="100">
+                <a:solidFill>
+                  <a:srgbClr val="00C4B3"/>
+                </a:solidFill>
+                <a:latin typeface="Yu Gothic"/>
+                <a:ea typeface="Yu Gothic"/>
+                <a:cs typeface="Yu Gothic"/>
+              </a:rPr>
+              <a:t>03</a:t>
+            </a:r>
+          </a:p>
         </p:txBody>
       </p:sp>
       <p:sp>
@@ -1355,33 +1550,55 @@
         </p:nvSpPr>
         <p:spPr>
           <a:xfrm>
-            <a:off x="3573018" y="2002536"/>
-            <a:ext cx="2320290" cy="320040"/>
-          </a:xfrm>
-          <a:prstGeom prst="rect">
-            <a:avLst/>
-          </a:prstGeom>
-          <a:noFill/>
-        </p:spPr>
-        <p:txBody>
-          <a:bodyPr wrap="square" lIns="0" tIns="0" rIns="0" bIns="0" anchor="t" rtlCol="0"/>
-          <a:lstStyle/>
-          <a:p>
-            <a:pPr algn="l">
-              <a:lnSpc>
-                <a:spcPct val="145000"/>
-              </a:lnSpc>
-            </a:pPr>
-            <a:r>
-              <a:rPr lang="ja-JP" altLang="en-US" sz="1200" b="1" spc="120">
-                <a:solidFill>
-                  <a:srgbClr val="14141A"/>
-                </a:solidFill>
-                <a:latin typeface="Yu Gothic"/>
-                <a:ea typeface="Yu Gothic"/>
-                <a:cs typeface="Yu Gothic"/>
-              </a:rPr>
-              <a:t>自由</a:t>
+            <a:off x="1527048" y="3479292"/>
+            <a:ext cx="9784080" cy="914400"/>
+          </a:xfrm>
+          <a:prstGeom prst="rect">
+            <a:avLst/>
+          </a:prstGeom>
+          <a:noFill/>
+        </p:spPr>
+        <p:txBody>
+          <a:bodyPr wrap="square" lIns="0" tIns="0" rIns="0" bIns="0" anchor="t" rtlCol="0"/>
+          <a:lstStyle/>
+          <a:p>
+            <a:pPr algn="l">
+              <a:lnSpc>
+                <a:spcPct val="145000"/>
+              </a:lnSpc>
+            </a:pPr>
+            <a:r>
+              <a:rPr lang="ja-JP" altLang="en-US" sz="2000" b="0">
+                <a:solidFill>
+                  <a:srgbClr val="14141A"/>
+                </a:solidFill>
+                <a:latin typeface="Yu Gothic"/>
+                <a:ea typeface="Yu Gothic"/>
+                <a:cs typeface="Yu Gothic"/>
+              </a:rPr>
+              <a:t>性格もそこそこ悪くないです。</a:t>
+            </a:r>
+            <a:r>
+              <a:rPr lang="ja-JP" altLang="en-US" sz="2000" b="1">
+                <a:solidFill>
+                  <a:srgbClr val="14141A"/>
+                </a:solidFill>
+                <a:latin typeface="Yu Gothic"/>
+                <a:ea typeface="Yu Gothic"/>
+                <a:cs typeface="Yu Gothic"/>
+              </a:rPr>
+              <a:t>家で二人でご飯</a:t>
+            </a:r>
+            <a:r>
+              <a:rPr lang="ja-JP" altLang="en-US" sz="2000" b="0">
+                <a:solidFill>
+                  <a:srgbClr val="14141A"/>
+                </a:solidFill>
+                <a:latin typeface="Yu Gothic"/>
+                <a:ea typeface="Yu Gothic"/>
+                <a:cs typeface="Yu Gothic"/>
+              </a:rPr>
+              <a:t>、を強要しません。</a:t>
             </a:r>
           </a:p>
         </p:txBody>
@@ -1394,51 +1611,33 @@
         </p:nvSpPr>
         <p:spPr>
           <a:xfrm>
-            <a:off x="3573018" y="2414016"/>
-            <a:ext cx="2320290" cy="1005840"/>
-          </a:xfrm>
-          <a:prstGeom prst="rect">
-            <a:avLst/>
-          </a:prstGeom>
-          <a:noFill/>
-        </p:spPr>
-        <p:txBody>
-          <a:bodyPr wrap="square" lIns="0" tIns="0" rIns="0" bIns="0" anchor="t" rtlCol="0"/>
-          <a:lstStyle/>
-          <a:p>
-            <a:pPr algn="l">
-              <a:lnSpc>
-                <a:spcPct val="125000"/>
-              </a:lnSpc>
-            </a:pPr>
-            <a:r>
-              <a:rPr lang="ja-JP" altLang="en-US" sz="2200" b="1">
-                <a:solidFill>
-                  <a:srgbClr val="14141A"/>
-                </a:solidFill>
-                <a:latin typeface="Yu Gothic"/>
-                <a:ea typeface="Yu Gothic"/>
-                <a:cs typeface="Yu Gothic"/>
-              </a:rPr>
-              <a:t>ひとりの時間は</a:t>
-            </a:r>
-          </a:p>
-          <a:p>
-            <a:pPr algn="l">
-              <a:lnSpc>
-                <a:spcPct val="125000"/>
-              </a:lnSpc>
-            </a:pPr>
-            <a:r>
-              <a:rPr lang="ja-JP" altLang="en-US" sz="2200" b="1">
-                <a:solidFill>
-                  <a:srgbClr val="14141A"/>
-                </a:solidFill>
-                <a:latin typeface="Yu Gothic"/>
-                <a:ea typeface="Yu Gothic"/>
-                <a:cs typeface="Yu Gothic"/>
-              </a:rPr>
-              <a:t>制度で守ります</a:t>
+            <a:off x="841248" y="4417466"/>
+            <a:ext cx="640080" cy="365760"/>
+          </a:xfrm>
+          <a:prstGeom prst="rect">
+            <a:avLst/>
+          </a:prstGeom>
+          <a:noFill/>
+        </p:spPr>
+        <p:txBody>
+          <a:bodyPr wrap="square" lIns="0" tIns="0" rIns="0" bIns="0" anchor="t" rtlCol="0"/>
+          <a:lstStyle/>
+          <a:p>
+            <a:pPr algn="l">
+              <a:lnSpc>
+                <a:spcPct val="145000"/>
+              </a:lnSpc>
+            </a:pPr>
+            <a:r>
+              <a:rPr lang="ja-JP" altLang="en-US" sz="1500" b="1" spc="100">
+                <a:solidFill>
+                  <a:srgbClr val="00C4B3"/>
+                </a:solidFill>
+                <a:latin typeface="Yu Gothic"/>
+                <a:ea typeface="Yu Gothic"/>
+                <a:cs typeface="Yu Gothic"/>
+              </a:rPr>
+              <a:t>04</a:t>
             </a:r>
           </a:p>
         </p:txBody>
@@ -1451,62 +1650,96 @@
         </p:nvSpPr>
         <p:spPr>
           <a:xfrm>
-            <a:off x="3573018" y="3511296"/>
-            <a:ext cx="2320290" cy="1444752"/>
-          </a:xfrm>
-          <a:prstGeom prst="rect">
-            <a:avLst/>
-          </a:prstGeom>
-          <a:noFill/>
-        </p:spPr>
-        <p:txBody>
-          <a:bodyPr wrap="square" lIns="0" tIns="0" rIns="0" bIns="0" anchor="t" rtlCol="0"/>
-          <a:lstStyle/>
-          <a:p>
-            <a:pPr algn="l">
-              <a:lnSpc>
-                <a:spcPct val="155000"/>
-              </a:lnSpc>
-            </a:pPr>
-            <a:r>
-              <a:rPr lang="ja-JP" altLang="en-US" sz="1400" b="0">
-                <a:solidFill>
-                  <a:srgbClr val="14141A"/>
-                </a:solidFill>
-                <a:latin typeface="Yu Gothic"/>
-                <a:ea typeface="Yu Gothic"/>
-                <a:cs typeface="Yu Gothic"/>
-              </a:rPr>
-              <a:t>二人の家に自室を持ちます。週に一度は別行動でかまいません。</a:t>
-            </a:r>
-          </a:p>
-        </p:txBody>
-      </p:sp>
-      <p:sp>
-        <p:nvSpPr>
-          <p:cNvPr id="12" name="Shape 12"/>
-          <p:cNvSpPr/>
-          <p:nvPr/>
-        </p:nvSpPr>
-        <p:spPr>
-          <a:xfrm>
-            <a:off x="6304788" y="1773936"/>
-            <a:ext cx="2320290" cy="38100"/>
-          </a:xfrm>
-          <a:prstGeom prst="rect">
-            <a:avLst/>
-          </a:prstGeom>
-          <a:solidFill>
-            <a:srgbClr val="FF5C77"/>
-          </a:solidFill>
-          <a:ln>
-            <a:noFill/>
-          </a:ln>
-        </p:spPr>
-        <p:txBody>
-          <a:bodyPr wrap="square" lIns="0" tIns="0" rIns="0" bIns="0" anchor="ctr" rtlCol="0"/>
-          <a:lstStyle/>
-          <a:p/>
+            <a:off x="1527048" y="4326026"/>
+            <a:ext cx="9784080" cy="914400"/>
+          </a:xfrm>
+          <a:prstGeom prst="rect">
+            <a:avLst/>
+          </a:prstGeom>
+          <a:noFill/>
+        </p:spPr>
+        <p:txBody>
+          <a:bodyPr wrap="square" lIns="0" tIns="0" rIns="0" bIns="0" anchor="t" rtlCol="0"/>
+          <a:lstStyle/>
+          <a:p>
+            <a:pPr algn="l">
+              <a:lnSpc>
+                <a:spcPct val="145000"/>
+              </a:lnSpc>
+            </a:pPr>
+            <a:r>
+              <a:rPr lang="ja-JP" altLang="en-US" sz="2000" b="0">
+                <a:solidFill>
+                  <a:srgbClr val="14141A"/>
+                </a:solidFill>
+                <a:latin typeface="Yu Gothic"/>
+                <a:ea typeface="Yu Gothic"/>
+                <a:cs typeface="Yu Gothic"/>
+              </a:rPr>
+              <a:t>人脈もそこそこあります。凪さんの仕事の</a:t>
+            </a:r>
+            <a:r>
+              <a:rPr lang="ja-JP" altLang="en-US" sz="2000" b="1">
+                <a:solidFill>
+                  <a:srgbClr val="14141A"/>
+                </a:solidFill>
+                <a:latin typeface="Yu Gothic"/>
+                <a:ea typeface="Yu Gothic"/>
+                <a:cs typeface="Yu Gothic"/>
+              </a:rPr>
+              <a:t>ビジネスマッチング</a:t>
+            </a:r>
+            <a:r>
+              <a:rPr lang="ja-JP" altLang="en-US" sz="2000" b="0">
+                <a:solidFill>
+                  <a:srgbClr val="14141A"/>
+                </a:solidFill>
+                <a:latin typeface="Yu Gothic"/>
+                <a:ea typeface="Yu Gothic"/>
+                <a:cs typeface="Yu Gothic"/>
+              </a:rPr>
+              <a:t>もできます。</a:t>
+            </a:r>
+          </a:p>
+        </p:txBody>
+      </p:sp>
+      <p:sp>
+        <p:nvSpPr>
+          <p:cNvPr id="12" name="TextBox 12"/>
+          <p:cNvSpPr txBox="1"/>
+          <p:nvPr/>
+        </p:nvSpPr>
+        <p:spPr>
+          <a:xfrm>
+            <a:off x="841248" y="5264200"/>
+            <a:ext cx="640080" cy="365760"/>
+          </a:xfrm>
+          <a:prstGeom prst="rect">
+            <a:avLst/>
+          </a:prstGeom>
+          <a:noFill/>
+        </p:spPr>
+        <p:txBody>
+          <a:bodyPr wrap="square" lIns="0" tIns="0" rIns="0" bIns="0" anchor="t" rtlCol="0"/>
+          <a:lstStyle/>
+          <a:p>
+            <a:pPr algn="l">
+              <a:lnSpc>
+                <a:spcPct val="145000"/>
+              </a:lnSpc>
+            </a:pPr>
+            <a:r>
+              <a:rPr lang="ja-JP" altLang="en-US" sz="1500" b="1" spc="100">
+                <a:solidFill>
+                  <a:srgbClr val="00C4B3"/>
+                </a:solidFill>
+                <a:latin typeface="Yu Gothic"/>
+                <a:ea typeface="Yu Gothic"/>
+                <a:cs typeface="Yu Gothic"/>
+              </a:rPr>
+              <a:t>05</a:t>
+            </a:r>
+          </a:p>
         </p:txBody>
       </p:sp>
       <p:sp>
@@ -1517,33 +1750,44 @@
         </p:nvSpPr>
         <p:spPr>
           <a:xfrm>
-            <a:off x="6304788" y="2002536"/>
-            <a:ext cx="2320290" cy="320040"/>
-          </a:xfrm>
-          <a:prstGeom prst="rect">
-            <a:avLst/>
-          </a:prstGeom>
-          <a:noFill/>
-        </p:spPr>
-        <p:txBody>
-          <a:bodyPr wrap="square" lIns="0" tIns="0" rIns="0" bIns="0" anchor="t" rtlCol="0"/>
-          <a:lstStyle/>
-          <a:p>
-            <a:pPr algn="l">
-              <a:lnSpc>
-                <a:spcPct val="145000"/>
-              </a:lnSpc>
-            </a:pPr>
-            <a:r>
-              <a:rPr lang="ja-JP" altLang="en-US" sz="1200" b="1" spc="120">
-                <a:solidFill>
-                  <a:srgbClr val="FF5C77"/>
-                </a:solidFill>
-                <a:latin typeface="Yu Gothic"/>
-                <a:ea typeface="Yu Gothic"/>
-                <a:cs typeface="Yu Gothic"/>
-              </a:rPr>
-              <a:t>家事</a:t>
+            <a:off x="1527048" y="5172760"/>
+            <a:ext cx="9784080" cy="914400"/>
+          </a:xfrm>
+          <a:prstGeom prst="rect">
+            <a:avLst/>
+          </a:prstGeom>
+          <a:noFill/>
+        </p:spPr>
+        <p:txBody>
+          <a:bodyPr wrap="square" lIns="0" tIns="0" rIns="0" bIns="0" anchor="t" rtlCol="0"/>
+          <a:lstStyle/>
+          <a:p>
+            <a:pPr algn="l">
+              <a:lnSpc>
+                <a:spcPct val="145000"/>
+              </a:lnSpc>
+            </a:pPr>
+            <a:r>
+              <a:rPr lang="ja-JP" altLang="en-US" sz="2000" b="1">
+                <a:solidFill>
+                  <a:srgbClr val="14141A"/>
+                </a:solidFill>
+                <a:latin typeface="Yu Gothic"/>
+                <a:ea typeface="Yu Gothic"/>
+                <a:cs typeface="Yu Gothic"/>
+              </a:rPr>
+              <a:t>柔軟性と伸びしろ</a:t>
+            </a:r>
+            <a:r>
+              <a:rPr lang="ja-JP" altLang="en-US" sz="2000" b="0">
+                <a:solidFill>
+                  <a:srgbClr val="14141A"/>
+                </a:solidFill>
+                <a:latin typeface="Yu Gothic"/>
+                <a:ea typeface="Yu Gothic"/>
+                <a:cs typeface="Yu Gothic"/>
+              </a:rPr>
+              <a:t>があります。片付けも掃除も、少しずつ対応中です。</a:t>
             </a:r>
           </a:p>
         </p:txBody>
@@ -1551,303 +1795,6 @@
       <p:sp>
         <p:nvSpPr>
           <p:cNvPr id="14" name="TextBox 14"/>
-          <p:cNvSpPr txBox="1"/>
-          <p:nvPr/>
-        </p:nvSpPr>
-        <p:spPr>
-          <a:xfrm>
-            <a:off x="6304788" y="2414016"/>
-            <a:ext cx="2320290" cy="1005840"/>
-          </a:xfrm>
-          <a:prstGeom prst="rect">
-            <a:avLst/>
-          </a:prstGeom>
-          <a:noFill/>
-        </p:spPr>
-        <p:txBody>
-          <a:bodyPr wrap="square" lIns="0" tIns="0" rIns="0" bIns="0" anchor="t" rtlCol="0"/>
-          <a:lstStyle/>
-          <a:p>
-            <a:pPr algn="l">
-              <a:lnSpc>
-                <a:spcPct val="125000"/>
-              </a:lnSpc>
-            </a:pPr>
-            <a:r>
-              <a:rPr lang="ja-JP" altLang="en-US" sz="2200" b="1">
-                <a:solidFill>
-                  <a:srgbClr val="14141A"/>
-                </a:solidFill>
-                <a:latin typeface="Yu Gothic"/>
-                <a:ea typeface="Yu Gothic"/>
-                <a:cs typeface="Yu Gothic"/>
-              </a:rPr>
-              <a:t>掃除は</a:t>
-            </a:r>
-          </a:p>
-          <a:p>
-            <a:pPr algn="l">
-              <a:lnSpc>
-                <a:spcPct val="125000"/>
-              </a:lnSpc>
-            </a:pPr>
-            <a:r>
-              <a:rPr lang="ja-JP" altLang="en-US" sz="2200" b="1">
-                <a:solidFill>
-                  <a:srgbClr val="14141A"/>
-                </a:solidFill>
-                <a:latin typeface="Yu Gothic"/>
-                <a:ea typeface="Yu Gothic"/>
-                <a:cs typeface="Yu Gothic"/>
-              </a:rPr>
-              <a:t>改善中です</a:t>
-            </a:r>
-          </a:p>
-        </p:txBody>
-      </p:sp>
-      <p:sp>
-        <p:nvSpPr>
-          <p:cNvPr id="15" name="TextBox 15"/>
-          <p:cNvSpPr txBox="1"/>
-          <p:nvPr/>
-        </p:nvSpPr>
-        <p:spPr>
-          <a:xfrm>
-            <a:off x="6304788" y="3511296"/>
-            <a:ext cx="2320290" cy="1444752"/>
-          </a:xfrm>
-          <a:prstGeom prst="rect">
-            <a:avLst/>
-          </a:prstGeom>
-          <a:noFill/>
-        </p:spPr>
-        <p:txBody>
-          <a:bodyPr wrap="square" lIns="0" tIns="0" rIns="0" bIns="0" anchor="t" rtlCol="0"/>
-          <a:lstStyle/>
-          <a:p>
-            <a:pPr algn="l">
-              <a:lnSpc>
-                <a:spcPct val="155000"/>
-              </a:lnSpc>
-            </a:pPr>
-            <a:r>
-              <a:rPr lang="ja-JP" altLang="en-US" sz="1400" b="0">
-                <a:solidFill>
-                  <a:srgbClr val="14141A"/>
-                </a:solidFill>
-                <a:latin typeface="Yu Gothic"/>
-                <a:ea typeface="Yu Gothic"/>
-                <a:cs typeface="Yu Gothic"/>
-              </a:rPr>
-              <a:t>得意なほうがやります。決まらないものは、外注も選択肢に入れます。</a:t>
-            </a:r>
-          </a:p>
-        </p:txBody>
-      </p:sp>
-      <p:sp>
-        <p:nvSpPr>
-          <p:cNvPr id="16" name="Shape 16"/>
-          <p:cNvSpPr/>
-          <p:nvPr/>
-        </p:nvSpPr>
-        <p:spPr>
-          <a:xfrm>
-            <a:off x="9036558" y="1773936"/>
-            <a:ext cx="2320290" cy="38100"/>
-          </a:xfrm>
-          <a:prstGeom prst="rect">
-            <a:avLst/>
-          </a:prstGeom>
-          <a:solidFill>
-            <a:srgbClr val="6C5CE7"/>
-          </a:solidFill>
-          <a:ln>
-            <a:noFill/>
-          </a:ln>
-        </p:spPr>
-        <p:txBody>
-          <a:bodyPr wrap="square" lIns="0" tIns="0" rIns="0" bIns="0" anchor="ctr" rtlCol="0"/>
-          <a:lstStyle/>
-          <a:p/>
-        </p:txBody>
-      </p:sp>
-      <p:sp>
-        <p:nvSpPr>
-          <p:cNvPr id="17" name="TextBox 17"/>
-          <p:cNvSpPr txBox="1"/>
-          <p:nvPr/>
-        </p:nvSpPr>
-        <p:spPr>
-          <a:xfrm>
-            <a:off x="9036558" y="2002536"/>
-            <a:ext cx="2320290" cy="320040"/>
-          </a:xfrm>
-          <a:prstGeom prst="rect">
-            <a:avLst/>
-          </a:prstGeom>
-          <a:noFill/>
-        </p:spPr>
-        <p:txBody>
-          <a:bodyPr wrap="square" lIns="0" tIns="0" rIns="0" bIns="0" anchor="t" rtlCol="0"/>
-          <a:lstStyle/>
-          <a:p>
-            <a:pPr algn="l">
-              <a:lnSpc>
-                <a:spcPct val="145000"/>
-              </a:lnSpc>
-            </a:pPr>
-            <a:r>
-              <a:rPr lang="ja-JP" altLang="en-US" sz="1200" b="1" spc="120">
-                <a:solidFill>
-                  <a:srgbClr val="6C5CE7"/>
-                </a:solidFill>
-                <a:latin typeface="Yu Gothic"/>
-                <a:ea typeface="Yu Gothic"/>
-                <a:cs typeface="Yu Gothic"/>
-              </a:rPr>
-              <a:t>ケンカ</a:t>
-            </a:r>
-          </a:p>
-        </p:txBody>
-      </p:sp>
-      <p:sp>
-        <p:nvSpPr>
-          <p:cNvPr id="18" name="TextBox 18"/>
-          <p:cNvSpPr txBox="1"/>
-          <p:nvPr/>
-        </p:nvSpPr>
-        <p:spPr>
-          <a:xfrm>
-            <a:off x="9036558" y="2414016"/>
-            <a:ext cx="2320290" cy="1005840"/>
-          </a:xfrm>
-          <a:prstGeom prst="rect">
-            <a:avLst/>
-          </a:prstGeom>
-          <a:noFill/>
-        </p:spPr>
-        <p:txBody>
-          <a:bodyPr wrap="square" lIns="0" tIns="0" rIns="0" bIns="0" anchor="t" rtlCol="0"/>
-          <a:lstStyle/>
-          <a:p>
-            <a:pPr algn="l">
-              <a:lnSpc>
-                <a:spcPct val="125000"/>
-              </a:lnSpc>
-            </a:pPr>
-            <a:r>
-              <a:rPr lang="ja-JP" altLang="en-US" sz="2200" b="1">
-                <a:solidFill>
-                  <a:srgbClr val="14141A"/>
-                </a:solidFill>
-                <a:latin typeface="Yu Gothic"/>
-                <a:ea typeface="Yu Gothic"/>
-                <a:cs typeface="Yu Gothic"/>
-              </a:rPr>
-              <a:t>片方が謝って</a:t>
-            </a:r>
-          </a:p>
-          <a:p>
-            <a:pPr algn="l">
-              <a:lnSpc>
-                <a:spcPct val="125000"/>
-              </a:lnSpc>
-            </a:pPr>
-            <a:r>
-              <a:rPr lang="ja-JP" altLang="en-US" sz="2200" b="1">
-                <a:solidFill>
-                  <a:srgbClr val="14141A"/>
-                </a:solidFill>
-                <a:latin typeface="Yu Gothic"/>
-                <a:ea typeface="Yu Gothic"/>
-                <a:cs typeface="Yu Gothic"/>
-              </a:rPr>
-              <a:t>終わります</a:t>
-            </a:r>
-          </a:p>
-        </p:txBody>
-      </p:sp>
-      <p:sp>
-        <p:nvSpPr>
-          <p:cNvPr id="19" name="TextBox 19"/>
-          <p:cNvSpPr txBox="1"/>
-          <p:nvPr/>
-        </p:nvSpPr>
-        <p:spPr>
-          <a:xfrm>
-            <a:off x="9036558" y="3511296"/>
-            <a:ext cx="2320290" cy="1444752"/>
-          </a:xfrm>
-          <a:prstGeom prst="rect">
-            <a:avLst/>
-          </a:prstGeom>
-          <a:noFill/>
-        </p:spPr>
-        <p:txBody>
-          <a:bodyPr wrap="square" lIns="0" tIns="0" rIns="0" bIns="0" anchor="t" rtlCol="0"/>
-          <a:lstStyle/>
-          <a:p>
-            <a:pPr algn="l">
-              <a:lnSpc>
-                <a:spcPct val="155000"/>
-              </a:lnSpc>
-            </a:pPr>
-            <a:r>
-              <a:rPr lang="ja-JP" altLang="en-US" sz="1400" b="0">
-                <a:solidFill>
-                  <a:srgbClr val="14141A"/>
-                </a:solidFill>
-                <a:latin typeface="Yu Gothic"/>
-                <a:ea typeface="Yu Gothic"/>
-                <a:cs typeface="Yu Gothic"/>
-              </a:rPr>
-              <a:t>今のやり方を変えません。翌日には持ち越しません。</a:t>
-            </a:r>
-          </a:p>
-        </p:txBody>
-      </p:sp>
-      <p:sp>
-        <p:nvSpPr>
-          <p:cNvPr id="20" name="TextBox 20"/>
-          <p:cNvSpPr txBox="1"/>
-          <p:nvPr/>
-        </p:nvSpPr>
-        <p:spPr>
-          <a:xfrm>
-            <a:off x="841248" y="5138928"/>
-            <a:ext cx="10515600" cy="914400"/>
-          </a:xfrm>
-          <a:prstGeom prst="rect">
-            <a:avLst/>
-          </a:prstGeom>
-          <a:noFill/>
-        </p:spPr>
-        <p:txBody>
-          <a:bodyPr wrap="square" lIns="0" tIns="0" rIns="0" bIns="0" anchor="b" rtlCol="0"/>
-          <a:lstStyle/>
-          <a:p>
-            <a:pPr algn="l">
-              <a:lnSpc>
-                <a:spcPct val="125000"/>
-              </a:lnSpc>
-            </a:pPr>
-            <a:r>
-              <a:rPr lang="ja-JP" altLang="en-US" sz="2800" b="1">
-                <a:solidFill>
-                  <a:srgbClr val="14141A"/>
-                </a:solidFill>
-                <a:latin typeface="Yu Gothic"/>
-                <a:ea typeface="Yu Gothic"/>
-                <a:cs typeface="Yu Gothic"/>
-              </a:rPr>
-              <a:t>変えないのは仕事、直すのは家事です。</a:t>
-            </a:r>
-          </a:p>
-        </p:txBody>
-      </p:sp>
-      <p:sp>
-        <p:nvSpPr>
-          <p:cNvPr id="21" name="TextBox 21"/>
           <p:cNvSpPr txBox="1"/>
           <p:nvPr/>
         </p:nvSpPr>
@@ -1886,7 +1833,7 @@
       </p:sp>
       <p:sp>
         <p:nvSpPr>
-          <p:cNvPr id="22" name="TextBox 22"/>
+          <p:cNvPr id="15" name="TextBox 15"/>
           <p:cNvSpPr txBox="1"/>
           <p:nvPr/>
         </p:nvSpPr>
@@ -1932,6 +1879,1596 @@
 </file>
 
 <file path=ppt/slides/slide11.xml><?xml version="1.0" encoding="utf-8"?>
+<p:sld xmlns:a="http://schemas.openxmlformats.org/drawingml/2006/main" xmlns:r="http://schemas.openxmlformats.org/officeDocument/2006/relationships" xmlns:p="http://schemas.openxmlformats.org/presentationml/2006/main">
+  <p:cSld>
+    <p:bg>
+      <p:bgPr>
+        <a:solidFill>
+          <a:srgbClr val="FFFFFF"/>
+        </a:solidFill>
+        <a:effectLst/>
+      </p:bgPr>
+    </p:bg>
+    <p:spTree>
+      <p:nvGrpSpPr>
+        <p:cNvPr id="1" name=""/>
+        <p:cNvGrpSpPr/>
+        <p:nvPr/>
+      </p:nvGrpSpPr>
+      <p:grpSpPr>
+        <a:xfrm>
+          <a:off x="0" y="0"/>
+          <a:ext cx="0" cy="0"/>
+          <a:chOff x="0" y="0"/>
+          <a:chExt cx="0" cy="0"/>
+        </a:xfrm>
+      </p:grpSpPr>
+      <p:sp>
+        <p:nvSpPr>
+          <p:cNvPr id="2" name="TextBox 2"/>
+          <p:cNvSpPr txBox="1"/>
+          <p:nvPr/>
+        </p:nvSpPr>
+        <p:spPr>
+          <a:xfrm>
+            <a:off x="841248" y="155448"/>
+            <a:ext cx="10515600" cy="329184"/>
+          </a:xfrm>
+          <a:prstGeom prst="rect">
+            <a:avLst/>
+          </a:prstGeom>
+          <a:noFill/>
+        </p:spPr>
+        <p:txBody>
+          <a:bodyPr wrap="square" lIns="0" tIns="0" rIns="0" bIns="0" anchor="t" rtlCol="0"/>
+          <a:lstStyle/>
+          <a:p>
+            <a:pPr algn="l">
+              <a:lnSpc>
+                <a:spcPct val="145000"/>
+              </a:lnSpc>
+            </a:pPr>
+            <a:r>
+              <a:rPr lang="ja-JP" altLang="en-US" sz="1300" b="1" spc="150">
+                <a:solidFill>
+                  <a:srgbClr val="14141A"/>
+                </a:solidFill>
+                <a:latin typeface="Yu Gothic"/>
+                <a:ea typeface="Yu Gothic"/>
+                <a:cs typeface="Yu Gothic"/>
+              </a:rPr>
+              <a:t>お互いについて</a:t>
+            </a:r>
+          </a:p>
+        </p:txBody>
+      </p:sp>
+      <p:sp>
+        <p:nvSpPr>
+          <p:cNvPr id="3" name="TextBox 3"/>
+          <p:cNvSpPr txBox="1"/>
+          <p:nvPr/>
+        </p:nvSpPr>
+        <p:spPr>
+          <a:xfrm>
+            <a:off x="841248" y="585216"/>
+            <a:ext cx="10515600" cy="1005840"/>
+          </a:xfrm>
+          <a:prstGeom prst="rect">
+            <a:avLst/>
+          </a:prstGeom>
+          <a:noFill/>
+        </p:spPr>
+        <p:txBody>
+          <a:bodyPr wrap="square" lIns="0" tIns="0" rIns="0" bIns="0" anchor="t" rtlCol="0"/>
+          <a:lstStyle/>
+          <a:p>
+            <a:pPr algn="l">
+              <a:lnSpc>
+                <a:spcPct val="140000"/>
+              </a:lnSpc>
+            </a:pPr>
+            <a:r>
+              <a:rPr lang="ja-JP" altLang="en-US" sz="2200" b="0">
+                <a:solidFill>
+                  <a:srgbClr val="14141A"/>
+                </a:solidFill>
+                <a:latin typeface="Yu Gothic Medium"/>
+                <a:ea typeface="Yu Gothic Medium"/>
+                <a:cs typeface="Yu Gothic Medium"/>
+              </a:rPr>
+              <a:t>私ひとりの話ではなく、ふたりで見たときの話も書いておきます。</a:t>
+            </a:r>
+          </a:p>
+        </p:txBody>
+      </p:sp>
+      <p:sp>
+        <p:nvSpPr>
+          <p:cNvPr id="4" name="Shape 4"/>
+          <p:cNvSpPr/>
+          <p:nvPr/>
+        </p:nvSpPr>
+        <p:spPr>
+          <a:xfrm>
+            <a:off x="841248" y="1773936"/>
+            <a:ext cx="3230880" cy="38100"/>
+          </a:xfrm>
+          <a:prstGeom prst="rect">
+            <a:avLst/>
+          </a:prstGeom>
+          <a:solidFill>
+            <a:srgbClr val="00C4B3"/>
+          </a:solidFill>
+          <a:ln>
+            <a:noFill/>
+          </a:ln>
+        </p:spPr>
+        <p:txBody>
+          <a:bodyPr wrap="square" lIns="0" tIns="0" rIns="0" bIns="0" anchor="ctr" rtlCol="0"/>
+          <a:lstStyle/>
+          <a:p/>
+        </p:txBody>
+      </p:sp>
+      <p:sp>
+        <p:nvSpPr>
+          <p:cNvPr id="5" name="TextBox 5"/>
+          <p:cNvSpPr txBox="1"/>
+          <p:nvPr/>
+        </p:nvSpPr>
+        <p:spPr>
+          <a:xfrm>
+            <a:off x="841248" y="2002536"/>
+            <a:ext cx="3230880" cy="320040"/>
+          </a:xfrm>
+          <a:prstGeom prst="rect">
+            <a:avLst/>
+          </a:prstGeom>
+          <a:noFill/>
+        </p:spPr>
+        <p:txBody>
+          <a:bodyPr wrap="square" lIns="0" tIns="0" rIns="0" bIns="0" anchor="t" rtlCol="0"/>
+          <a:lstStyle/>
+          <a:p>
+            <a:pPr algn="l">
+              <a:lnSpc>
+                <a:spcPct val="145000"/>
+              </a:lnSpc>
+            </a:pPr>
+            <a:r>
+              <a:rPr lang="ja-JP" altLang="en-US" sz="1200" b="1" spc="120">
+                <a:solidFill>
+                  <a:srgbClr val="00C4B3"/>
+                </a:solidFill>
+                <a:latin typeface="Yu Gothic"/>
+                <a:ea typeface="Yu Gothic"/>
+                <a:cs typeface="Yu Gothic"/>
+              </a:rPr>
+              <a:t>相性</a:t>
+            </a:r>
+          </a:p>
+        </p:txBody>
+      </p:sp>
+      <p:sp>
+        <p:nvSpPr>
+          <p:cNvPr id="6" name="TextBox 6"/>
+          <p:cNvSpPr txBox="1"/>
+          <p:nvPr/>
+        </p:nvSpPr>
+        <p:spPr>
+          <a:xfrm>
+            <a:off x="841248" y="2414016"/>
+            <a:ext cx="3230880" cy="1005840"/>
+          </a:xfrm>
+          <a:prstGeom prst="rect">
+            <a:avLst/>
+          </a:prstGeom>
+          <a:noFill/>
+        </p:spPr>
+        <p:txBody>
+          <a:bodyPr wrap="square" lIns="0" tIns="0" rIns="0" bIns="0" anchor="t" rtlCol="0"/>
+          <a:lstStyle/>
+          <a:p>
+            <a:pPr algn="l">
+              <a:lnSpc>
+                <a:spcPct val="125000"/>
+              </a:lnSpc>
+            </a:pPr>
+            <a:r>
+              <a:rPr lang="ja-JP" altLang="en-US" sz="2200" b="1">
+                <a:solidFill>
+                  <a:srgbClr val="14141A"/>
+                </a:solidFill>
+                <a:latin typeface="Yu Gothic"/>
+                <a:ea typeface="Yu Gothic"/>
+                <a:cs typeface="Yu Gothic"/>
+              </a:rPr>
+              <a:t>昼も夜も、</a:t>
+            </a:r>
+          </a:p>
+          <a:p>
+            <a:pPr algn="l">
+              <a:lnSpc>
+                <a:spcPct val="125000"/>
+              </a:lnSpc>
+            </a:pPr>
+            <a:r>
+              <a:rPr lang="ja-JP" altLang="en-US" sz="2200" b="1">
+                <a:solidFill>
+                  <a:srgbClr val="14141A"/>
+                </a:solidFill>
+                <a:latin typeface="Yu Gothic"/>
+                <a:ea typeface="Yu Gothic"/>
+                <a:cs typeface="Yu Gothic"/>
+              </a:rPr>
+              <a:t>悪くないです</a:t>
+            </a:r>
+          </a:p>
+        </p:txBody>
+      </p:sp>
+      <p:sp>
+        <p:nvSpPr>
+          <p:cNvPr id="7" name="TextBox 7"/>
+          <p:cNvSpPr txBox="1"/>
+          <p:nvPr/>
+        </p:nvSpPr>
+        <p:spPr>
+          <a:xfrm>
+            <a:off x="841248" y="3511296"/>
+            <a:ext cx="3230880" cy="1444752"/>
+          </a:xfrm>
+          <a:prstGeom prst="rect">
+            <a:avLst/>
+          </a:prstGeom>
+          <a:noFill/>
+        </p:spPr>
+        <p:txBody>
+          <a:bodyPr wrap="square" lIns="0" tIns="0" rIns="0" bIns="0" anchor="t" rtlCol="0"/>
+          <a:lstStyle/>
+          <a:p>
+            <a:pPr algn="l">
+              <a:lnSpc>
+                <a:spcPct val="155000"/>
+              </a:lnSpc>
+            </a:pPr>
+            <a:r>
+              <a:rPr lang="ja-JP" altLang="en-US" sz="1500" b="0">
+                <a:solidFill>
+                  <a:srgbClr val="14141A"/>
+                </a:solidFill>
+                <a:latin typeface="Yu Gothic"/>
+                <a:ea typeface="Yu Gothic"/>
+                <a:cs typeface="Yu Gothic"/>
+              </a:rPr>
+              <a:t>たぶん、きっと、という但し書きはつきます。ここだけは主観です。</a:t>
+            </a:r>
+          </a:p>
+        </p:txBody>
+      </p:sp>
+      <p:sp>
+        <p:nvSpPr>
+          <p:cNvPr id="8" name="Shape 8"/>
+          <p:cNvSpPr/>
+          <p:nvPr/>
+        </p:nvSpPr>
+        <p:spPr>
+          <a:xfrm>
+            <a:off x="4483608" y="1773936"/>
+            <a:ext cx="3230880" cy="38100"/>
+          </a:xfrm>
+          <a:prstGeom prst="rect">
+            <a:avLst/>
+          </a:prstGeom>
+          <a:solidFill>
+            <a:srgbClr val="FFD93D"/>
+          </a:solidFill>
+          <a:ln>
+            <a:noFill/>
+          </a:ln>
+        </p:spPr>
+        <p:txBody>
+          <a:bodyPr wrap="square" lIns="0" tIns="0" rIns="0" bIns="0" anchor="ctr" rtlCol="0"/>
+          <a:lstStyle/>
+          <a:p/>
+        </p:txBody>
+      </p:sp>
+      <p:sp>
+        <p:nvSpPr>
+          <p:cNvPr id="9" name="TextBox 9"/>
+          <p:cNvSpPr txBox="1"/>
+          <p:nvPr/>
+        </p:nvSpPr>
+        <p:spPr>
+          <a:xfrm>
+            <a:off x="4483608" y="2002536"/>
+            <a:ext cx="3230880" cy="320040"/>
+          </a:xfrm>
+          <a:prstGeom prst="rect">
+            <a:avLst/>
+          </a:prstGeom>
+          <a:noFill/>
+        </p:spPr>
+        <p:txBody>
+          <a:bodyPr wrap="square" lIns="0" tIns="0" rIns="0" bIns="0" anchor="t" rtlCol="0"/>
+          <a:lstStyle/>
+          <a:p>
+            <a:pPr algn="l">
+              <a:lnSpc>
+                <a:spcPct val="145000"/>
+              </a:lnSpc>
+            </a:pPr>
+            <a:r>
+              <a:rPr lang="ja-JP" altLang="en-US" sz="1200" b="1" spc="120">
+                <a:solidFill>
+                  <a:srgbClr val="14141A"/>
+                </a:solidFill>
+                <a:latin typeface="Yu Gothic"/>
+                <a:ea typeface="Yu Gothic"/>
+                <a:cs typeface="Yu Gothic"/>
+              </a:rPr>
+              <a:t>姿勢</a:t>
+            </a:r>
+          </a:p>
+        </p:txBody>
+      </p:sp>
+      <p:sp>
+        <p:nvSpPr>
+          <p:cNvPr id="10" name="TextBox 10"/>
+          <p:cNvSpPr txBox="1"/>
+          <p:nvPr/>
+        </p:nvSpPr>
+        <p:spPr>
+          <a:xfrm>
+            <a:off x="4483608" y="2414016"/>
+            <a:ext cx="3230880" cy="1005840"/>
+          </a:xfrm>
+          <a:prstGeom prst="rect">
+            <a:avLst/>
+          </a:prstGeom>
+          <a:noFill/>
+        </p:spPr>
+        <p:txBody>
+          <a:bodyPr wrap="square" lIns="0" tIns="0" rIns="0" bIns="0" anchor="t" rtlCol="0"/>
+          <a:lstStyle/>
+          <a:p>
+            <a:pPr algn="l">
+              <a:lnSpc>
+                <a:spcPct val="125000"/>
+              </a:lnSpc>
+            </a:pPr>
+            <a:r>
+              <a:rPr lang="ja-JP" altLang="en-US" sz="2200" b="1">
+                <a:solidFill>
+                  <a:srgbClr val="14141A"/>
+                </a:solidFill>
+                <a:latin typeface="Yu Gothic"/>
+                <a:ea typeface="Yu Gothic"/>
+                <a:cs typeface="Yu Gothic"/>
+              </a:rPr>
+              <a:t>お互い、</a:t>
+            </a:r>
+          </a:p>
+          <a:p>
+            <a:pPr algn="l">
+              <a:lnSpc>
+                <a:spcPct val="125000"/>
+              </a:lnSpc>
+            </a:pPr>
+            <a:r>
+              <a:rPr lang="ja-JP" altLang="en-US" sz="2200" b="1">
+                <a:solidFill>
+                  <a:srgbClr val="14141A"/>
+                </a:solidFill>
+                <a:latin typeface="Yu Gothic"/>
+                <a:ea typeface="Yu Gothic"/>
+                <a:cs typeface="Yu Gothic"/>
+              </a:rPr>
+              <a:t>直そうとします</a:t>
+            </a:r>
+          </a:p>
+        </p:txBody>
+      </p:sp>
+      <p:sp>
+        <p:nvSpPr>
+          <p:cNvPr id="11" name="TextBox 11"/>
+          <p:cNvSpPr txBox="1"/>
+          <p:nvPr/>
+        </p:nvSpPr>
+        <p:spPr>
+          <a:xfrm>
+            <a:off x="4483608" y="3511296"/>
+            <a:ext cx="3230880" cy="1444752"/>
+          </a:xfrm>
+          <a:prstGeom prst="rect">
+            <a:avLst/>
+          </a:prstGeom>
+          <a:noFill/>
+        </p:spPr>
+        <p:txBody>
+          <a:bodyPr wrap="square" lIns="0" tIns="0" rIns="0" bIns="0" anchor="t" rtlCol="0"/>
+          <a:lstStyle/>
+          <a:p>
+            <a:pPr algn="l">
+              <a:lnSpc>
+                <a:spcPct val="155000"/>
+              </a:lnSpc>
+            </a:pPr>
+            <a:r>
+              <a:rPr lang="ja-JP" altLang="en-US" sz="1500" b="0">
+                <a:solidFill>
+                  <a:srgbClr val="14141A"/>
+                </a:solidFill>
+                <a:latin typeface="Yu Gothic"/>
+                <a:ea typeface="Yu Gothic"/>
+                <a:cs typeface="Yu Gothic"/>
+              </a:rPr>
+              <a:t>自分のよくないところを、言われる前に直そうとする人同士だと思っています。</a:t>
+            </a:r>
+          </a:p>
+        </p:txBody>
+      </p:sp>
+      <p:sp>
+        <p:nvSpPr>
+          <p:cNvPr id="12" name="Shape 12"/>
+          <p:cNvSpPr/>
+          <p:nvPr/>
+        </p:nvSpPr>
+        <p:spPr>
+          <a:xfrm>
+            <a:off x="8125968" y="1773936"/>
+            <a:ext cx="3230880" cy="38100"/>
+          </a:xfrm>
+          <a:prstGeom prst="rect">
+            <a:avLst/>
+          </a:prstGeom>
+          <a:solidFill>
+            <a:srgbClr val="FF5C77"/>
+          </a:solidFill>
+          <a:ln>
+            <a:noFill/>
+          </a:ln>
+        </p:spPr>
+        <p:txBody>
+          <a:bodyPr wrap="square" lIns="0" tIns="0" rIns="0" bIns="0" anchor="ctr" rtlCol="0"/>
+          <a:lstStyle/>
+          <a:p/>
+        </p:txBody>
+      </p:sp>
+      <p:sp>
+        <p:nvSpPr>
+          <p:cNvPr id="13" name="TextBox 13"/>
+          <p:cNvSpPr txBox="1"/>
+          <p:nvPr/>
+        </p:nvSpPr>
+        <p:spPr>
+          <a:xfrm>
+            <a:off x="8125968" y="2002536"/>
+            <a:ext cx="3230880" cy="320040"/>
+          </a:xfrm>
+          <a:prstGeom prst="rect">
+            <a:avLst/>
+          </a:prstGeom>
+          <a:noFill/>
+        </p:spPr>
+        <p:txBody>
+          <a:bodyPr wrap="square" lIns="0" tIns="0" rIns="0" bIns="0" anchor="t" rtlCol="0"/>
+          <a:lstStyle/>
+          <a:p>
+            <a:pPr algn="l">
+              <a:lnSpc>
+                <a:spcPct val="145000"/>
+              </a:lnSpc>
+            </a:pPr>
+            <a:r>
+              <a:rPr lang="ja-JP" altLang="en-US" sz="1200" b="1" spc="120">
+                <a:solidFill>
+                  <a:srgbClr val="FF5C77"/>
+                </a:solidFill>
+                <a:latin typeface="Yu Gothic"/>
+                <a:ea typeface="Yu Gothic"/>
+                <a:cs typeface="Yu Gothic"/>
+              </a:rPr>
+              <a:t>周囲</a:t>
+            </a:r>
+          </a:p>
+        </p:txBody>
+      </p:sp>
+      <p:sp>
+        <p:nvSpPr>
+          <p:cNvPr id="14" name="TextBox 14"/>
+          <p:cNvSpPr txBox="1"/>
+          <p:nvPr/>
+        </p:nvSpPr>
+        <p:spPr>
+          <a:xfrm>
+            <a:off x="8125968" y="2414016"/>
+            <a:ext cx="3230880" cy="1005840"/>
+          </a:xfrm>
+          <a:prstGeom prst="rect">
+            <a:avLst/>
+          </a:prstGeom>
+          <a:noFill/>
+        </p:spPr>
+        <p:txBody>
+          <a:bodyPr wrap="square" lIns="0" tIns="0" rIns="0" bIns="0" anchor="t" rtlCol="0"/>
+          <a:lstStyle/>
+          <a:p>
+            <a:pPr algn="l">
+              <a:lnSpc>
+                <a:spcPct val="125000"/>
+              </a:lnSpc>
+            </a:pPr>
+            <a:r>
+              <a:rPr lang="ja-JP" altLang="en-US" sz="2200" b="1">
+                <a:solidFill>
+                  <a:srgbClr val="14141A"/>
+                </a:solidFill>
+                <a:latin typeface="Yu Gothic"/>
+                <a:ea typeface="Yu Gothic"/>
+                <a:cs typeface="Yu Gothic"/>
+              </a:rPr>
+              <a:t>共通の知り合いも、</a:t>
+            </a:r>
+          </a:p>
+          <a:p>
+            <a:pPr algn="l">
+              <a:lnSpc>
+                <a:spcPct val="125000"/>
+              </a:lnSpc>
+            </a:pPr>
+            <a:r>
+              <a:rPr lang="ja-JP" altLang="en-US" sz="2200" b="1">
+                <a:solidFill>
+                  <a:srgbClr val="14141A"/>
+                </a:solidFill>
+                <a:latin typeface="Yu Gothic"/>
+                <a:ea typeface="Yu Gothic"/>
+                <a:cs typeface="Yu Gothic"/>
+              </a:rPr>
+              <a:t>できています</a:t>
+            </a:r>
+          </a:p>
+        </p:txBody>
+      </p:sp>
+      <p:sp>
+        <p:nvSpPr>
+          <p:cNvPr id="15" name="TextBox 15"/>
+          <p:cNvSpPr txBox="1"/>
+          <p:nvPr/>
+        </p:nvSpPr>
+        <p:spPr>
+          <a:xfrm>
+            <a:off x="8125968" y="3511296"/>
+            <a:ext cx="3230880" cy="1444752"/>
+          </a:xfrm>
+          <a:prstGeom prst="rect">
+            <a:avLst/>
+          </a:prstGeom>
+          <a:noFill/>
+        </p:spPr>
+        <p:txBody>
+          <a:bodyPr wrap="square" lIns="0" tIns="0" rIns="0" bIns="0" anchor="t" rtlCol="0"/>
+          <a:lstStyle/>
+          <a:p>
+            <a:pPr algn="l">
+              <a:lnSpc>
+                <a:spcPct val="155000"/>
+              </a:lnSpc>
+            </a:pPr>
+            <a:r>
+              <a:rPr lang="ja-JP" altLang="en-US" sz="1500" b="0">
+                <a:solidFill>
+                  <a:srgbClr val="14141A"/>
+                </a:solidFill>
+                <a:latin typeface="Yu Gothic"/>
+                <a:ea typeface="Yu Gothic"/>
+                <a:cs typeface="Yu Gothic"/>
+              </a:rPr>
+              <a:t>お互いの友人にも会っていて、印象も悪くないはずです。たぶん。</a:t>
+            </a:r>
+          </a:p>
+        </p:txBody>
+      </p:sp>
+      <p:sp>
+        <p:nvSpPr>
+          <p:cNvPr id="16" name="TextBox 16"/>
+          <p:cNvSpPr txBox="1"/>
+          <p:nvPr/>
+        </p:nvSpPr>
+        <p:spPr>
+          <a:xfrm>
+            <a:off x="841248" y="5138928"/>
+            <a:ext cx="10515600" cy="914400"/>
+          </a:xfrm>
+          <a:prstGeom prst="rect">
+            <a:avLst/>
+          </a:prstGeom>
+          <a:noFill/>
+        </p:spPr>
+        <p:txBody>
+          <a:bodyPr wrap="square" lIns="0" tIns="0" rIns="0" bIns="0" anchor="b" rtlCol="0"/>
+          <a:lstStyle/>
+          <a:p>
+            <a:pPr algn="l">
+              <a:lnSpc>
+                <a:spcPct val="125000"/>
+              </a:lnSpc>
+            </a:pPr>
+            <a:r>
+              <a:rPr lang="ja-JP" altLang="en-US" sz="2800" b="1">
+                <a:solidFill>
+                  <a:srgbClr val="14141A"/>
+                </a:solidFill>
+                <a:latin typeface="Yu Gothic"/>
+                <a:ea typeface="Yu Gothic"/>
+                <a:cs typeface="Yu Gothic"/>
+              </a:rPr>
+              <a:t>だから、一緒に暮らしても大丈夫だと思っています。</a:t>
+            </a:r>
+          </a:p>
+        </p:txBody>
+      </p:sp>
+      <p:sp>
+        <p:nvSpPr>
+          <p:cNvPr id="17" name="TextBox 17"/>
+          <p:cNvSpPr txBox="1"/>
+          <p:nvPr/>
+        </p:nvSpPr>
+        <p:spPr>
+          <a:xfrm>
+            <a:off x="841248" y="6391656"/>
+            <a:ext cx="5486400" cy="274320"/>
+          </a:xfrm>
+          <a:prstGeom prst="rect">
+            <a:avLst/>
+          </a:prstGeom>
+          <a:noFill/>
+        </p:spPr>
+        <p:txBody>
+          <a:bodyPr wrap="square" lIns="0" tIns="0" rIns="0" bIns="0" anchor="t" rtlCol="0"/>
+          <a:lstStyle/>
+          <a:p>
+            <a:pPr algn="l">
+              <a:lnSpc>
+                <a:spcPct val="145000"/>
+              </a:lnSpc>
+            </a:pPr>
+            <a:r>
+              <a:rPr lang="ja-JP" altLang="en-US" sz="1000" b="0" spc="50">
+                <a:solidFill>
+                  <a:srgbClr val="A3A3AE"/>
+                </a:solidFill>
+                <a:latin typeface="Yu Gothic"/>
+                <a:ea typeface="Yu Gothic"/>
+                <a:cs typeface="Yu Gothic"/>
+              </a:rPr>
+              <a:t>ふたりの計画のご提案</a:t>
+            </a:r>
+          </a:p>
+        </p:txBody>
+      </p:sp>
+      <p:sp>
+        <p:nvSpPr>
+          <p:cNvPr id="18" name="TextBox 18"/>
+          <p:cNvSpPr txBox="1"/>
+          <p:nvPr/>
+        </p:nvSpPr>
+        <p:spPr>
+          <a:xfrm>
+            <a:off x="10436047" y="6373368"/>
+            <a:ext cx="914400" cy="274320"/>
+          </a:xfrm>
+          <a:prstGeom prst="rect">
+            <a:avLst/>
+          </a:prstGeom>
+          <a:noFill/>
+        </p:spPr>
+        <p:txBody>
+          <a:bodyPr wrap="square" lIns="0" tIns="0" rIns="0" bIns="0" anchor="t" rtlCol="0"/>
+          <a:lstStyle/>
+          <a:p>
+            <a:pPr algn="r">
+              <a:lnSpc>
+                <a:spcPct val="145000"/>
+              </a:lnSpc>
+            </a:pPr>
+            <a:r>
+              <a:rPr lang="ja-JP" altLang="en-US" sz="1200" b="1" spc="50">
+                <a:solidFill>
+                  <a:srgbClr val="A3A3AE"/>
+                </a:solidFill>
+                <a:latin typeface="Yu Gothic"/>
+                <a:ea typeface="Yu Gothic"/>
+                <a:cs typeface="Yu Gothic"/>
+              </a:rPr>
+              <a:t>11</a:t>
+            </a:r>
+          </a:p>
+        </p:txBody>
+      </p:sp>
+    </p:spTree>
+  </p:cSld>
+  <p:clrMapOvr>
+    <a:masterClrMapping/>
+  </p:clrMapOvr>
+</p:sld>
+</file>
+
+<file path=ppt/slides/slide12.xml><?xml version="1.0" encoding="utf-8"?>
+<p:sld xmlns:a="http://schemas.openxmlformats.org/drawingml/2006/main" xmlns:r="http://schemas.openxmlformats.org/officeDocument/2006/relationships" xmlns:p="http://schemas.openxmlformats.org/presentationml/2006/main">
+  <p:cSld>
+    <p:bg>
+      <p:bgPr>
+        <a:solidFill>
+          <a:srgbClr val="FFFFFF"/>
+        </a:solidFill>
+        <a:effectLst/>
+      </p:bgPr>
+    </p:bg>
+    <p:spTree>
+      <p:nvGrpSpPr>
+        <p:cNvPr id="1" name=""/>
+        <p:cNvGrpSpPr/>
+        <p:nvPr/>
+      </p:nvGrpSpPr>
+      <p:grpSpPr>
+        <a:xfrm>
+          <a:off x="0" y="0"/>
+          <a:ext cx="0" cy="0"/>
+          <a:chOff x="0" y="0"/>
+          <a:chExt cx="0" cy="0"/>
+        </a:xfrm>
+      </p:grpSpPr>
+      <p:sp>
+        <p:nvSpPr>
+          <p:cNvPr id="2" name="TextBox 2"/>
+          <p:cNvSpPr txBox="1"/>
+          <p:nvPr/>
+        </p:nvSpPr>
+        <p:spPr>
+          <a:xfrm>
+            <a:off x="841248" y="155448"/>
+            <a:ext cx="10515600" cy="329184"/>
+          </a:xfrm>
+          <a:prstGeom prst="rect">
+            <a:avLst/>
+          </a:prstGeom>
+          <a:noFill/>
+        </p:spPr>
+        <p:txBody>
+          <a:bodyPr wrap="square" lIns="0" tIns="0" rIns="0" bIns="0" anchor="t" rtlCol="0"/>
+          <a:lstStyle/>
+          <a:p>
+            <a:pPr algn="l">
+              <a:lnSpc>
+                <a:spcPct val="145000"/>
+              </a:lnSpc>
+            </a:pPr>
+            <a:r>
+              <a:rPr lang="ja-JP" altLang="en-US" sz="1300" b="1" spc="150">
+                <a:solidFill>
+                  <a:srgbClr val="14141A"/>
+                </a:solidFill>
+                <a:latin typeface="Yu Gothic"/>
+                <a:ea typeface="Yu Gothic"/>
+                <a:cs typeface="Yu Gothic"/>
+              </a:rPr>
+              <a:t>約束</a:t>
+            </a:r>
+          </a:p>
+        </p:txBody>
+      </p:sp>
+      <p:sp>
+        <p:nvSpPr>
+          <p:cNvPr id="3" name="TextBox 3"/>
+          <p:cNvSpPr txBox="1"/>
+          <p:nvPr/>
+        </p:nvSpPr>
+        <p:spPr>
+          <a:xfrm>
+            <a:off x="841248" y="585216"/>
+            <a:ext cx="10515600" cy="1005840"/>
+          </a:xfrm>
+          <a:prstGeom prst="rect">
+            <a:avLst/>
+          </a:prstGeom>
+          <a:noFill/>
+        </p:spPr>
+        <p:txBody>
+          <a:bodyPr wrap="square" lIns="0" tIns="0" rIns="0" bIns="0" anchor="t" rtlCol="0"/>
+          <a:lstStyle/>
+          <a:p>
+            <a:pPr algn="l">
+              <a:lnSpc>
+                <a:spcPct val="140000"/>
+              </a:lnSpc>
+            </a:pPr>
+            <a:r>
+              <a:rPr lang="ja-JP" altLang="en-US" sz="2200" b="0">
+                <a:solidFill>
+                  <a:srgbClr val="14141A"/>
+                </a:solidFill>
+                <a:latin typeface="Yu Gothic Medium"/>
+                <a:ea typeface="Yu Gothic Medium"/>
+                <a:cs typeface="Yu Gothic Medium"/>
+              </a:rPr>
+              <a:t>私の側から先に書きます。変えないことと、直すことに分けました。</a:t>
+            </a:r>
+          </a:p>
+        </p:txBody>
+      </p:sp>
+      <p:sp>
+        <p:nvSpPr>
+          <p:cNvPr id="4" name="Shape 4"/>
+          <p:cNvSpPr/>
+          <p:nvPr/>
+        </p:nvSpPr>
+        <p:spPr>
+          <a:xfrm>
+            <a:off x="841248" y="1773936"/>
+            <a:ext cx="2320290" cy="38100"/>
+          </a:xfrm>
+          <a:prstGeom prst="rect">
+            <a:avLst/>
+          </a:prstGeom>
+          <a:solidFill>
+            <a:srgbClr val="00C4B3"/>
+          </a:solidFill>
+          <a:ln>
+            <a:noFill/>
+          </a:ln>
+        </p:spPr>
+        <p:txBody>
+          <a:bodyPr wrap="square" lIns="0" tIns="0" rIns="0" bIns="0" anchor="ctr" rtlCol="0"/>
+          <a:lstStyle/>
+          <a:p/>
+        </p:txBody>
+      </p:sp>
+      <p:sp>
+        <p:nvSpPr>
+          <p:cNvPr id="5" name="TextBox 5"/>
+          <p:cNvSpPr txBox="1"/>
+          <p:nvPr/>
+        </p:nvSpPr>
+        <p:spPr>
+          <a:xfrm>
+            <a:off x="841248" y="2002536"/>
+            <a:ext cx="2320290" cy="320040"/>
+          </a:xfrm>
+          <a:prstGeom prst="rect">
+            <a:avLst/>
+          </a:prstGeom>
+          <a:noFill/>
+        </p:spPr>
+        <p:txBody>
+          <a:bodyPr wrap="square" lIns="0" tIns="0" rIns="0" bIns="0" anchor="t" rtlCol="0"/>
+          <a:lstStyle/>
+          <a:p>
+            <a:pPr algn="l">
+              <a:lnSpc>
+                <a:spcPct val="145000"/>
+              </a:lnSpc>
+            </a:pPr>
+            <a:r>
+              <a:rPr lang="ja-JP" altLang="en-US" sz="1200" b="1" spc="120">
+                <a:solidFill>
+                  <a:srgbClr val="00C4B3"/>
+                </a:solidFill>
+                <a:latin typeface="Yu Gothic"/>
+                <a:ea typeface="Yu Gothic"/>
+                <a:cs typeface="Yu Gothic"/>
+              </a:rPr>
+              <a:t>仕事</a:t>
+            </a:r>
+          </a:p>
+        </p:txBody>
+      </p:sp>
+      <p:sp>
+        <p:nvSpPr>
+          <p:cNvPr id="6" name="TextBox 6"/>
+          <p:cNvSpPr txBox="1"/>
+          <p:nvPr/>
+        </p:nvSpPr>
+        <p:spPr>
+          <a:xfrm>
+            <a:off x="841248" y="2414016"/>
+            <a:ext cx="2320290" cy="1005840"/>
+          </a:xfrm>
+          <a:prstGeom prst="rect">
+            <a:avLst/>
+          </a:prstGeom>
+          <a:noFill/>
+        </p:spPr>
+        <p:txBody>
+          <a:bodyPr wrap="square" lIns="0" tIns="0" rIns="0" bIns="0" anchor="t" rtlCol="0"/>
+          <a:lstStyle/>
+          <a:p>
+            <a:pPr algn="l">
+              <a:lnSpc>
+                <a:spcPct val="125000"/>
+              </a:lnSpc>
+            </a:pPr>
+            <a:r>
+              <a:rPr lang="ja-JP" altLang="en-US" sz="2200" b="1">
+                <a:solidFill>
+                  <a:srgbClr val="14141A"/>
+                </a:solidFill>
+                <a:latin typeface="Yu Gothic"/>
+                <a:ea typeface="Yu Gothic"/>
+                <a:cs typeface="Yu Gothic"/>
+              </a:rPr>
+              <a:t>熱量は</a:t>
+            </a:r>
+          </a:p>
+          <a:p>
+            <a:pPr algn="l">
+              <a:lnSpc>
+                <a:spcPct val="125000"/>
+              </a:lnSpc>
+            </a:pPr>
+            <a:r>
+              <a:rPr lang="ja-JP" altLang="en-US" sz="2200" b="1">
+                <a:solidFill>
+                  <a:srgbClr val="14141A"/>
+                </a:solidFill>
+                <a:latin typeface="Yu Gothic"/>
+                <a:ea typeface="Yu Gothic"/>
+                <a:cs typeface="Yu Gothic"/>
+              </a:rPr>
+              <a:t>落としません</a:t>
+            </a:r>
+          </a:p>
+        </p:txBody>
+      </p:sp>
+      <p:sp>
+        <p:nvSpPr>
+          <p:cNvPr id="7" name="TextBox 7"/>
+          <p:cNvSpPr txBox="1"/>
+          <p:nvPr/>
+        </p:nvSpPr>
+        <p:spPr>
+          <a:xfrm>
+            <a:off x="841248" y="3511296"/>
+            <a:ext cx="2320290" cy="1444752"/>
+          </a:xfrm>
+          <a:prstGeom prst="rect">
+            <a:avLst/>
+          </a:prstGeom>
+          <a:noFill/>
+        </p:spPr>
+        <p:txBody>
+          <a:bodyPr wrap="square" lIns="0" tIns="0" rIns="0" bIns="0" anchor="t" rtlCol="0"/>
+          <a:lstStyle/>
+          <a:p>
+            <a:pPr algn="l">
+              <a:lnSpc>
+                <a:spcPct val="155000"/>
+              </a:lnSpc>
+            </a:pPr>
+            <a:r>
+              <a:rPr lang="ja-JP" altLang="en-US" sz="1400" b="0">
+                <a:solidFill>
+                  <a:srgbClr val="14141A"/>
+                </a:solidFill>
+                <a:latin typeface="Yu Gothic"/>
+                <a:ea typeface="Yu Gothic"/>
+                <a:cs typeface="Yu Gothic"/>
+              </a:rPr>
+              <a:t>30歳まではお互い仕事優先です。結婚が仕事の邪魔をしない形にします。</a:t>
+            </a:r>
+          </a:p>
+        </p:txBody>
+      </p:sp>
+      <p:sp>
+        <p:nvSpPr>
+          <p:cNvPr id="8" name="Shape 8"/>
+          <p:cNvSpPr/>
+          <p:nvPr/>
+        </p:nvSpPr>
+        <p:spPr>
+          <a:xfrm>
+            <a:off x="3573018" y="1773936"/>
+            <a:ext cx="2320290" cy="38100"/>
+          </a:xfrm>
+          <a:prstGeom prst="rect">
+            <a:avLst/>
+          </a:prstGeom>
+          <a:solidFill>
+            <a:srgbClr val="FFD93D"/>
+          </a:solidFill>
+          <a:ln>
+            <a:noFill/>
+          </a:ln>
+        </p:spPr>
+        <p:txBody>
+          <a:bodyPr wrap="square" lIns="0" tIns="0" rIns="0" bIns="0" anchor="ctr" rtlCol="0"/>
+          <a:lstStyle/>
+          <a:p/>
+        </p:txBody>
+      </p:sp>
+      <p:sp>
+        <p:nvSpPr>
+          <p:cNvPr id="9" name="TextBox 9"/>
+          <p:cNvSpPr txBox="1"/>
+          <p:nvPr/>
+        </p:nvSpPr>
+        <p:spPr>
+          <a:xfrm>
+            <a:off x="3573018" y="2002536"/>
+            <a:ext cx="2320290" cy="320040"/>
+          </a:xfrm>
+          <a:prstGeom prst="rect">
+            <a:avLst/>
+          </a:prstGeom>
+          <a:noFill/>
+        </p:spPr>
+        <p:txBody>
+          <a:bodyPr wrap="square" lIns="0" tIns="0" rIns="0" bIns="0" anchor="t" rtlCol="0"/>
+          <a:lstStyle/>
+          <a:p>
+            <a:pPr algn="l">
+              <a:lnSpc>
+                <a:spcPct val="145000"/>
+              </a:lnSpc>
+            </a:pPr>
+            <a:r>
+              <a:rPr lang="ja-JP" altLang="en-US" sz="1200" b="1" spc="120">
+                <a:solidFill>
+                  <a:srgbClr val="14141A"/>
+                </a:solidFill>
+                <a:latin typeface="Yu Gothic"/>
+                <a:ea typeface="Yu Gothic"/>
+                <a:cs typeface="Yu Gothic"/>
+              </a:rPr>
+              <a:t>自由</a:t>
+            </a:r>
+          </a:p>
+        </p:txBody>
+      </p:sp>
+      <p:sp>
+        <p:nvSpPr>
+          <p:cNvPr id="10" name="TextBox 10"/>
+          <p:cNvSpPr txBox="1"/>
+          <p:nvPr/>
+        </p:nvSpPr>
+        <p:spPr>
+          <a:xfrm>
+            <a:off x="3573018" y="2414016"/>
+            <a:ext cx="2320290" cy="1005840"/>
+          </a:xfrm>
+          <a:prstGeom prst="rect">
+            <a:avLst/>
+          </a:prstGeom>
+          <a:noFill/>
+        </p:spPr>
+        <p:txBody>
+          <a:bodyPr wrap="square" lIns="0" tIns="0" rIns="0" bIns="0" anchor="t" rtlCol="0"/>
+          <a:lstStyle/>
+          <a:p>
+            <a:pPr algn="l">
+              <a:lnSpc>
+                <a:spcPct val="125000"/>
+              </a:lnSpc>
+            </a:pPr>
+            <a:r>
+              <a:rPr lang="ja-JP" altLang="en-US" sz="2200" b="1">
+                <a:solidFill>
+                  <a:srgbClr val="14141A"/>
+                </a:solidFill>
+                <a:latin typeface="Yu Gothic"/>
+                <a:ea typeface="Yu Gothic"/>
+                <a:cs typeface="Yu Gothic"/>
+              </a:rPr>
+              <a:t>ひとりの時間は</a:t>
+            </a:r>
+          </a:p>
+          <a:p>
+            <a:pPr algn="l">
+              <a:lnSpc>
+                <a:spcPct val="125000"/>
+              </a:lnSpc>
+            </a:pPr>
+            <a:r>
+              <a:rPr lang="ja-JP" altLang="en-US" sz="2200" b="1">
+                <a:solidFill>
+                  <a:srgbClr val="14141A"/>
+                </a:solidFill>
+                <a:latin typeface="Yu Gothic"/>
+                <a:ea typeface="Yu Gothic"/>
+                <a:cs typeface="Yu Gothic"/>
+              </a:rPr>
+              <a:t>制度で守ります</a:t>
+            </a:r>
+          </a:p>
+        </p:txBody>
+      </p:sp>
+      <p:sp>
+        <p:nvSpPr>
+          <p:cNvPr id="11" name="TextBox 11"/>
+          <p:cNvSpPr txBox="1"/>
+          <p:nvPr/>
+        </p:nvSpPr>
+        <p:spPr>
+          <a:xfrm>
+            <a:off x="3573018" y="3511296"/>
+            <a:ext cx="2320290" cy="1444752"/>
+          </a:xfrm>
+          <a:prstGeom prst="rect">
+            <a:avLst/>
+          </a:prstGeom>
+          <a:noFill/>
+        </p:spPr>
+        <p:txBody>
+          <a:bodyPr wrap="square" lIns="0" tIns="0" rIns="0" bIns="0" anchor="t" rtlCol="0"/>
+          <a:lstStyle/>
+          <a:p>
+            <a:pPr algn="l">
+              <a:lnSpc>
+                <a:spcPct val="155000"/>
+              </a:lnSpc>
+            </a:pPr>
+            <a:r>
+              <a:rPr lang="ja-JP" altLang="en-US" sz="1400" b="0">
+                <a:solidFill>
+                  <a:srgbClr val="14141A"/>
+                </a:solidFill>
+                <a:latin typeface="Yu Gothic"/>
+                <a:ea typeface="Yu Gothic"/>
+                <a:cs typeface="Yu Gothic"/>
+              </a:rPr>
+              <a:t>二人の家に自室を持ちます。週に一度は別行動でかまいません。</a:t>
+            </a:r>
+          </a:p>
+        </p:txBody>
+      </p:sp>
+      <p:sp>
+        <p:nvSpPr>
+          <p:cNvPr id="12" name="Shape 12"/>
+          <p:cNvSpPr/>
+          <p:nvPr/>
+        </p:nvSpPr>
+        <p:spPr>
+          <a:xfrm>
+            <a:off x="6304788" y="1773936"/>
+            <a:ext cx="2320290" cy="38100"/>
+          </a:xfrm>
+          <a:prstGeom prst="rect">
+            <a:avLst/>
+          </a:prstGeom>
+          <a:solidFill>
+            <a:srgbClr val="FF5C77"/>
+          </a:solidFill>
+          <a:ln>
+            <a:noFill/>
+          </a:ln>
+        </p:spPr>
+        <p:txBody>
+          <a:bodyPr wrap="square" lIns="0" tIns="0" rIns="0" bIns="0" anchor="ctr" rtlCol="0"/>
+          <a:lstStyle/>
+          <a:p/>
+        </p:txBody>
+      </p:sp>
+      <p:sp>
+        <p:nvSpPr>
+          <p:cNvPr id="13" name="TextBox 13"/>
+          <p:cNvSpPr txBox="1"/>
+          <p:nvPr/>
+        </p:nvSpPr>
+        <p:spPr>
+          <a:xfrm>
+            <a:off x="6304788" y="2002536"/>
+            <a:ext cx="2320290" cy="320040"/>
+          </a:xfrm>
+          <a:prstGeom prst="rect">
+            <a:avLst/>
+          </a:prstGeom>
+          <a:noFill/>
+        </p:spPr>
+        <p:txBody>
+          <a:bodyPr wrap="square" lIns="0" tIns="0" rIns="0" bIns="0" anchor="t" rtlCol="0"/>
+          <a:lstStyle/>
+          <a:p>
+            <a:pPr algn="l">
+              <a:lnSpc>
+                <a:spcPct val="145000"/>
+              </a:lnSpc>
+            </a:pPr>
+            <a:r>
+              <a:rPr lang="ja-JP" altLang="en-US" sz="1200" b="1" spc="120">
+                <a:solidFill>
+                  <a:srgbClr val="FF5C77"/>
+                </a:solidFill>
+                <a:latin typeface="Yu Gothic"/>
+                <a:ea typeface="Yu Gothic"/>
+                <a:cs typeface="Yu Gothic"/>
+              </a:rPr>
+              <a:t>家事</a:t>
+            </a:r>
+          </a:p>
+        </p:txBody>
+      </p:sp>
+      <p:sp>
+        <p:nvSpPr>
+          <p:cNvPr id="14" name="TextBox 14"/>
+          <p:cNvSpPr txBox="1"/>
+          <p:nvPr/>
+        </p:nvSpPr>
+        <p:spPr>
+          <a:xfrm>
+            <a:off x="6304788" y="2414016"/>
+            <a:ext cx="2320290" cy="1005840"/>
+          </a:xfrm>
+          <a:prstGeom prst="rect">
+            <a:avLst/>
+          </a:prstGeom>
+          <a:noFill/>
+        </p:spPr>
+        <p:txBody>
+          <a:bodyPr wrap="square" lIns="0" tIns="0" rIns="0" bIns="0" anchor="t" rtlCol="0"/>
+          <a:lstStyle/>
+          <a:p>
+            <a:pPr algn="l">
+              <a:lnSpc>
+                <a:spcPct val="125000"/>
+              </a:lnSpc>
+            </a:pPr>
+            <a:r>
+              <a:rPr lang="ja-JP" altLang="en-US" sz="2200" b="1">
+                <a:solidFill>
+                  <a:srgbClr val="14141A"/>
+                </a:solidFill>
+                <a:latin typeface="Yu Gothic"/>
+                <a:ea typeface="Yu Gothic"/>
+                <a:cs typeface="Yu Gothic"/>
+              </a:rPr>
+              <a:t>掃除は</a:t>
+            </a:r>
+          </a:p>
+          <a:p>
+            <a:pPr algn="l">
+              <a:lnSpc>
+                <a:spcPct val="125000"/>
+              </a:lnSpc>
+            </a:pPr>
+            <a:r>
+              <a:rPr lang="ja-JP" altLang="en-US" sz="2200" b="1">
+                <a:solidFill>
+                  <a:srgbClr val="14141A"/>
+                </a:solidFill>
+                <a:latin typeface="Yu Gothic"/>
+                <a:ea typeface="Yu Gothic"/>
+                <a:cs typeface="Yu Gothic"/>
+              </a:rPr>
+              <a:t>改善中です</a:t>
+            </a:r>
+          </a:p>
+        </p:txBody>
+      </p:sp>
+      <p:sp>
+        <p:nvSpPr>
+          <p:cNvPr id="15" name="TextBox 15"/>
+          <p:cNvSpPr txBox="1"/>
+          <p:nvPr/>
+        </p:nvSpPr>
+        <p:spPr>
+          <a:xfrm>
+            <a:off x="6304788" y="3511296"/>
+            <a:ext cx="2320290" cy="1444752"/>
+          </a:xfrm>
+          <a:prstGeom prst="rect">
+            <a:avLst/>
+          </a:prstGeom>
+          <a:noFill/>
+        </p:spPr>
+        <p:txBody>
+          <a:bodyPr wrap="square" lIns="0" tIns="0" rIns="0" bIns="0" anchor="t" rtlCol="0"/>
+          <a:lstStyle/>
+          <a:p>
+            <a:pPr algn="l">
+              <a:lnSpc>
+                <a:spcPct val="155000"/>
+              </a:lnSpc>
+            </a:pPr>
+            <a:r>
+              <a:rPr lang="ja-JP" altLang="en-US" sz="1400" b="0">
+                <a:solidFill>
+                  <a:srgbClr val="14141A"/>
+                </a:solidFill>
+                <a:latin typeface="Yu Gothic"/>
+                <a:ea typeface="Yu Gothic"/>
+                <a:cs typeface="Yu Gothic"/>
+              </a:rPr>
+              <a:t>得意なほうがやります。決まらないものは、外注も選択肢に入れます。</a:t>
+            </a:r>
+          </a:p>
+        </p:txBody>
+      </p:sp>
+      <p:sp>
+        <p:nvSpPr>
+          <p:cNvPr id="16" name="Shape 16"/>
+          <p:cNvSpPr/>
+          <p:nvPr/>
+        </p:nvSpPr>
+        <p:spPr>
+          <a:xfrm>
+            <a:off x="9036558" y="1773936"/>
+            <a:ext cx="2320290" cy="38100"/>
+          </a:xfrm>
+          <a:prstGeom prst="rect">
+            <a:avLst/>
+          </a:prstGeom>
+          <a:solidFill>
+            <a:srgbClr val="6C5CE7"/>
+          </a:solidFill>
+          <a:ln>
+            <a:noFill/>
+          </a:ln>
+        </p:spPr>
+        <p:txBody>
+          <a:bodyPr wrap="square" lIns="0" tIns="0" rIns="0" bIns="0" anchor="ctr" rtlCol="0"/>
+          <a:lstStyle/>
+          <a:p/>
+        </p:txBody>
+      </p:sp>
+      <p:sp>
+        <p:nvSpPr>
+          <p:cNvPr id="17" name="TextBox 17"/>
+          <p:cNvSpPr txBox="1"/>
+          <p:nvPr/>
+        </p:nvSpPr>
+        <p:spPr>
+          <a:xfrm>
+            <a:off x="9036558" y="2002536"/>
+            <a:ext cx="2320290" cy="320040"/>
+          </a:xfrm>
+          <a:prstGeom prst="rect">
+            <a:avLst/>
+          </a:prstGeom>
+          <a:noFill/>
+        </p:spPr>
+        <p:txBody>
+          <a:bodyPr wrap="square" lIns="0" tIns="0" rIns="0" bIns="0" anchor="t" rtlCol="0"/>
+          <a:lstStyle/>
+          <a:p>
+            <a:pPr algn="l">
+              <a:lnSpc>
+                <a:spcPct val="145000"/>
+              </a:lnSpc>
+            </a:pPr>
+            <a:r>
+              <a:rPr lang="ja-JP" altLang="en-US" sz="1200" b="1" spc="120">
+                <a:solidFill>
+                  <a:srgbClr val="6C5CE7"/>
+                </a:solidFill>
+                <a:latin typeface="Yu Gothic"/>
+                <a:ea typeface="Yu Gothic"/>
+                <a:cs typeface="Yu Gothic"/>
+              </a:rPr>
+              <a:t>ケンカ</a:t>
+            </a:r>
+          </a:p>
+        </p:txBody>
+      </p:sp>
+      <p:sp>
+        <p:nvSpPr>
+          <p:cNvPr id="18" name="TextBox 18"/>
+          <p:cNvSpPr txBox="1"/>
+          <p:nvPr/>
+        </p:nvSpPr>
+        <p:spPr>
+          <a:xfrm>
+            <a:off x="9036558" y="2414016"/>
+            <a:ext cx="2320290" cy="1005840"/>
+          </a:xfrm>
+          <a:prstGeom prst="rect">
+            <a:avLst/>
+          </a:prstGeom>
+          <a:noFill/>
+        </p:spPr>
+        <p:txBody>
+          <a:bodyPr wrap="square" lIns="0" tIns="0" rIns="0" bIns="0" anchor="t" rtlCol="0"/>
+          <a:lstStyle/>
+          <a:p>
+            <a:pPr algn="l">
+              <a:lnSpc>
+                <a:spcPct val="125000"/>
+              </a:lnSpc>
+            </a:pPr>
+            <a:r>
+              <a:rPr lang="ja-JP" altLang="en-US" sz="2200" b="1">
+                <a:solidFill>
+                  <a:srgbClr val="14141A"/>
+                </a:solidFill>
+                <a:latin typeface="Yu Gothic"/>
+                <a:ea typeface="Yu Gothic"/>
+                <a:cs typeface="Yu Gothic"/>
+              </a:rPr>
+              <a:t>片方が謝って</a:t>
+            </a:r>
+          </a:p>
+          <a:p>
+            <a:pPr algn="l">
+              <a:lnSpc>
+                <a:spcPct val="125000"/>
+              </a:lnSpc>
+            </a:pPr>
+            <a:r>
+              <a:rPr lang="ja-JP" altLang="en-US" sz="2200" b="1">
+                <a:solidFill>
+                  <a:srgbClr val="14141A"/>
+                </a:solidFill>
+                <a:latin typeface="Yu Gothic"/>
+                <a:ea typeface="Yu Gothic"/>
+                <a:cs typeface="Yu Gothic"/>
+              </a:rPr>
+              <a:t>終わります</a:t>
+            </a:r>
+          </a:p>
+        </p:txBody>
+      </p:sp>
+      <p:sp>
+        <p:nvSpPr>
+          <p:cNvPr id="19" name="TextBox 19"/>
+          <p:cNvSpPr txBox="1"/>
+          <p:nvPr/>
+        </p:nvSpPr>
+        <p:spPr>
+          <a:xfrm>
+            <a:off x="9036558" y="3511296"/>
+            <a:ext cx="2320290" cy="1444752"/>
+          </a:xfrm>
+          <a:prstGeom prst="rect">
+            <a:avLst/>
+          </a:prstGeom>
+          <a:noFill/>
+        </p:spPr>
+        <p:txBody>
+          <a:bodyPr wrap="square" lIns="0" tIns="0" rIns="0" bIns="0" anchor="t" rtlCol="0"/>
+          <a:lstStyle/>
+          <a:p>
+            <a:pPr algn="l">
+              <a:lnSpc>
+                <a:spcPct val="155000"/>
+              </a:lnSpc>
+            </a:pPr>
+            <a:r>
+              <a:rPr lang="ja-JP" altLang="en-US" sz="1400" b="0">
+                <a:solidFill>
+                  <a:srgbClr val="14141A"/>
+                </a:solidFill>
+                <a:latin typeface="Yu Gothic"/>
+                <a:ea typeface="Yu Gothic"/>
+                <a:cs typeface="Yu Gothic"/>
+              </a:rPr>
+              <a:t>今のやり方を変えません。翌日には持ち越しません。</a:t>
+            </a:r>
+          </a:p>
+        </p:txBody>
+      </p:sp>
+      <p:sp>
+        <p:nvSpPr>
+          <p:cNvPr id="20" name="TextBox 20"/>
+          <p:cNvSpPr txBox="1"/>
+          <p:nvPr/>
+        </p:nvSpPr>
+        <p:spPr>
+          <a:xfrm>
+            <a:off x="841248" y="5138928"/>
+            <a:ext cx="10515600" cy="914400"/>
+          </a:xfrm>
+          <a:prstGeom prst="rect">
+            <a:avLst/>
+          </a:prstGeom>
+          <a:noFill/>
+        </p:spPr>
+        <p:txBody>
+          <a:bodyPr wrap="square" lIns="0" tIns="0" rIns="0" bIns="0" anchor="b" rtlCol="0"/>
+          <a:lstStyle/>
+          <a:p>
+            <a:pPr algn="l">
+              <a:lnSpc>
+                <a:spcPct val="125000"/>
+              </a:lnSpc>
+            </a:pPr>
+            <a:r>
+              <a:rPr lang="ja-JP" altLang="en-US" sz="2800" b="1">
+                <a:solidFill>
+                  <a:srgbClr val="14141A"/>
+                </a:solidFill>
+                <a:latin typeface="Yu Gothic"/>
+                <a:ea typeface="Yu Gothic"/>
+                <a:cs typeface="Yu Gothic"/>
+              </a:rPr>
+              <a:t>変えないのは仕事、直すのは家事です。</a:t>
+            </a:r>
+          </a:p>
+        </p:txBody>
+      </p:sp>
+      <p:sp>
+        <p:nvSpPr>
+          <p:cNvPr id="21" name="TextBox 21"/>
+          <p:cNvSpPr txBox="1"/>
+          <p:nvPr/>
+        </p:nvSpPr>
+        <p:spPr>
+          <a:xfrm>
+            <a:off x="841248" y="6391656"/>
+            <a:ext cx="5486400" cy="274320"/>
+          </a:xfrm>
+          <a:prstGeom prst="rect">
+            <a:avLst/>
+          </a:prstGeom>
+          <a:noFill/>
+        </p:spPr>
+        <p:txBody>
+          <a:bodyPr wrap="square" lIns="0" tIns="0" rIns="0" bIns="0" anchor="t" rtlCol="0"/>
+          <a:lstStyle/>
+          <a:p>
+            <a:pPr algn="l">
+              <a:lnSpc>
+                <a:spcPct val="145000"/>
+              </a:lnSpc>
+            </a:pPr>
+            <a:r>
+              <a:rPr lang="ja-JP" altLang="en-US" sz="1000" b="0" spc="50">
+                <a:solidFill>
+                  <a:srgbClr val="A3A3AE"/>
+                </a:solidFill>
+                <a:latin typeface="Yu Gothic"/>
+                <a:ea typeface="Yu Gothic"/>
+                <a:cs typeface="Yu Gothic"/>
+              </a:rPr>
+              <a:t>ふたりの計画のご提案</a:t>
+            </a:r>
+          </a:p>
+        </p:txBody>
+      </p:sp>
+      <p:sp>
+        <p:nvSpPr>
+          <p:cNvPr id="22" name="TextBox 22"/>
+          <p:cNvSpPr txBox="1"/>
+          <p:nvPr/>
+        </p:nvSpPr>
+        <p:spPr>
+          <a:xfrm>
+            <a:off x="10436047" y="6373368"/>
+            <a:ext cx="914400" cy="274320"/>
+          </a:xfrm>
+          <a:prstGeom prst="rect">
+            <a:avLst/>
+          </a:prstGeom>
+          <a:noFill/>
+        </p:spPr>
+        <p:txBody>
+          <a:bodyPr wrap="square" lIns="0" tIns="0" rIns="0" bIns="0" anchor="t" rtlCol="0"/>
+          <a:lstStyle/>
+          <a:p>
+            <a:pPr algn="r">
+              <a:lnSpc>
+                <a:spcPct val="145000"/>
+              </a:lnSpc>
+            </a:pPr>
+            <a:r>
+              <a:rPr lang="ja-JP" altLang="en-US" sz="1200" b="1" spc="50">
+                <a:solidFill>
+                  <a:srgbClr val="A3A3AE"/>
+                </a:solidFill>
+                <a:latin typeface="Yu Gothic"/>
+                <a:ea typeface="Yu Gothic"/>
+                <a:cs typeface="Yu Gothic"/>
+              </a:rPr>
+              <a:t>12</a:t>
+            </a:r>
+          </a:p>
+        </p:txBody>
+      </p:sp>
+    </p:spTree>
+  </p:cSld>
+  <p:clrMapOvr>
+    <a:masterClrMapping/>
+  </p:clrMapOvr>
+</p:sld>
+</file>
+
+<file path=ppt/slides/slide13.xml><?xml version="1.0" encoding="utf-8"?>
 <p:sld xmlns:a="http://schemas.openxmlformats.org/drawingml/2006/main" xmlns:r="http://schemas.openxmlformats.org/officeDocument/2006/relationships" xmlns:p="http://schemas.openxmlformats.org/presentationml/2006/main">
   <p:cSld>
     <p:bg>

</xml_diff>

<commit_message>
Give the cover, dividers and closing a soft pink, hearts treatment
- new lighten() helper and a fixed scatter of heart shapes placed clear of
  the text column
- cover and closing move to a blush ground with deep-rose headings; the
  full-bleed dividers keep their colour and gain lighter hearts
- headings can take a separate display face via meta.font_display
- HTML preview draws the same hearts from an inline SVG data URI

Co-Authored-By: Claude Opus 5 <noreply@anthropic.com>
Claude-Session: https://claude.ai/code/session_017z6FTKMRuHAVL86624AoYU
</commit_message>
<xml_diff>
--- a/proposal/ふたりの計画のご提案.pptx
+++ b/proposal/ふたりの計画のご提案.pptx
@@ -1694,7 +1694,7 @@
     <p:bg>
       <p:bgPr>
         <a:solidFill>
-          <a:srgbClr val="FFD93D"/>
+          <a:srgbClr val="FFF1F4"/>
         </a:solidFill>
         <a:effectLst/>
       </p:bgPr>
@@ -1715,7 +1715,250 @@
       </p:grpSpPr>
       <p:sp>
         <p:nvSpPr>
-          <p:cNvPr id="2" name="TextBox 2"/>
+          <p:cNvPr id="2" name="Shape 2"/>
+          <p:cNvSpPr/>
+          <p:nvPr/>
+        </p:nvSpPr>
+        <p:spPr>
+          <a:xfrm>
+            <a:off x="8130323" y="160020"/>
+            <a:ext cx="1051560" cy="1051560"/>
+          </a:xfrm>
+          <a:prstGeom prst="heart">
+            <a:avLst/>
+          </a:prstGeom>
+          <a:solidFill>
+            <a:srgbClr val="FFC1CB"/>
+          </a:solidFill>
+          <a:ln>
+            <a:noFill/>
+          </a:ln>
+        </p:spPr>
+        <p:txBody>
+          <a:bodyPr wrap="square" lIns="0" tIns="0" rIns="0" bIns="0" anchor="ctr" rtlCol="0"/>
+          <a:lstStyle/>
+          <a:p/>
+        </p:txBody>
+      </p:sp>
+      <p:sp>
+        <p:nvSpPr>
+          <p:cNvPr id="3" name="Shape 3"/>
+          <p:cNvSpPr/>
+          <p:nvPr/>
+        </p:nvSpPr>
+        <p:spPr>
+          <a:xfrm>
+            <a:off x="10445227" y="1773936"/>
+            <a:ext cx="566928" cy="566928"/>
+          </a:xfrm>
+          <a:prstGeom prst="heart">
+            <a:avLst/>
+          </a:prstGeom>
+          <a:solidFill>
+            <a:srgbClr val="FF99AA"/>
+          </a:solidFill>
+          <a:ln>
+            <a:noFill/>
+          </a:ln>
+        </p:spPr>
+        <p:txBody>
+          <a:bodyPr wrap="square" lIns="0" tIns="0" rIns="0" bIns="0" anchor="ctr" rtlCol="0"/>
+          <a:lstStyle/>
+          <a:p/>
+        </p:txBody>
+      </p:sp>
+      <p:sp>
+        <p:nvSpPr>
+          <p:cNvPr id="4" name="Shape 4"/>
+          <p:cNvSpPr/>
+          <p:nvPr/>
+        </p:nvSpPr>
+        <p:spPr>
+          <a:xfrm>
+            <a:off x="9210815" y="3214116"/>
+            <a:ext cx="841248" cy="841248"/>
+          </a:xfrm>
+          <a:prstGeom prst="heart">
+            <a:avLst/>
+          </a:prstGeom>
+          <a:solidFill>
+            <a:srgbClr val="FF99AA"/>
+          </a:solidFill>
+          <a:ln>
+            <a:noFill/>
+          </a:ln>
+        </p:spPr>
+        <p:txBody>
+          <a:bodyPr wrap="square" lIns="0" tIns="0" rIns="0" bIns="0" anchor="ctr" rtlCol="0"/>
+          <a:lstStyle/>
+          <a:p/>
+        </p:txBody>
+      </p:sp>
+      <p:sp>
+        <p:nvSpPr>
+          <p:cNvPr id="5" name="Shape 5"/>
+          <p:cNvSpPr/>
+          <p:nvPr/>
+        </p:nvSpPr>
+        <p:spPr>
+          <a:xfrm>
+            <a:off x="11240737" y="4649724"/>
+            <a:ext cx="438912" cy="438912"/>
+          </a:xfrm>
+          <a:prstGeom prst="heart">
+            <a:avLst/>
+          </a:prstGeom>
+          <a:solidFill>
+            <a:srgbClr val="FFC1CB"/>
+          </a:solidFill>
+          <a:ln>
+            <a:noFill/>
+          </a:ln>
+        </p:spPr>
+        <p:txBody>
+          <a:bodyPr wrap="square" lIns="0" tIns="0" rIns="0" bIns="0" anchor="ctr" rtlCol="0"/>
+          <a:lstStyle/>
+          <a:p/>
+        </p:txBody>
+      </p:sp>
+      <p:sp>
+        <p:nvSpPr>
+          <p:cNvPr id="6" name="Shape 6"/>
+          <p:cNvSpPr/>
+          <p:nvPr/>
+        </p:nvSpPr>
+        <p:spPr>
+          <a:xfrm>
+            <a:off x="7622849" y="5116068"/>
+            <a:ext cx="603504" cy="603504"/>
+          </a:xfrm>
+          <a:prstGeom prst="heart">
+            <a:avLst/>
+          </a:prstGeom>
+          <a:solidFill>
+            <a:srgbClr val="FFC1CB"/>
+          </a:solidFill>
+          <a:ln>
+            <a:noFill/>
+          </a:ln>
+        </p:spPr>
+        <p:txBody>
+          <a:bodyPr wrap="square" lIns="0" tIns="0" rIns="0" bIns="0" anchor="ctr" rtlCol="0"/>
+          <a:lstStyle/>
+          <a:p/>
+        </p:txBody>
+      </p:sp>
+      <p:sp>
+        <p:nvSpPr>
+          <p:cNvPr id="7" name="Shape 7"/>
+          <p:cNvSpPr/>
+          <p:nvPr/>
+        </p:nvSpPr>
+        <p:spPr>
+          <a:xfrm>
+            <a:off x="281927" y="205740"/>
+            <a:ext cx="411480" cy="411480"/>
+          </a:xfrm>
+          <a:prstGeom prst="heart">
+            <a:avLst/>
+          </a:prstGeom>
+          <a:solidFill>
+            <a:srgbClr val="FF99AA"/>
+          </a:solidFill>
+          <a:ln>
+            <a:noFill/>
+          </a:ln>
+        </p:spPr>
+        <p:txBody>
+          <a:bodyPr wrap="square" lIns="0" tIns="0" rIns="0" bIns="0" anchor="ctr" rtlCol="0"/>
+          <a:lstStyle/>
+          <a:p/>
+        </p:txBody>
+      </p:sp>
+      <p:sp>
+        <p:nvSpPr>
+          <p:cNvPr id="8" name="Shape 8"/>
+          <p:cNvSpPr/>
+          <p:nvPr/>
+        </p:nvSpPr>
+        <p:spPr>
+          <a:xfrm>
+            <a:off x="1700738" y="77724"/>
+            <a:ext cx="256032" cy="256032"/>
+          </a:xfrm>
+          <a:prstGeom prst="heart">
+            <a:avLst/>
+          </a:prstGeom>
+          <a:solidFill>
+            <a:srgbClr val="FFC1CB"/>
+          </a:solidFill>
+          <a:ln>
+            <a:noFill/>
+          </a:ln>
+        </p:spPr>
+        <p:txBody>
+          <a:bodyPr wrap="square" lIns="0" tIns="0" rIns="0" bIns="0" anchor="ctr" rtlCol="0"/>
+          <a:lstStyle/>
+          <a:p/>
+        </p:txBody>
+      </p:sp>
+      <p:sp>
+        <p:nvSpPr>
+          <p:cNvPr id="9" name="Shape 9"/>
+          <p:cNvSpPr/>
+          <p:nvPr/>
+        </p:nvSpPr>
+        <p:spPr>
+          <a:xfrm>
+            <a:off x="36566" y="3922776"/>
+            <a:ext cx="658368" cy="658368"/>
+          </a:xfrm>
+          <a:prstGeom prst="heart">
+            <a:avLst/>
+          </a:prstGeom>
+          <a:solidFill>
+            <a:srgbClr val="FFC1CB"/>
+          </a:solidFill>
+          <a:ln>
+            <a:noFill/>
+          </a:ln>
+        </p:spPr>
+        <p:txBody>
+          <a:bodyPr wrap="square" lIns="0" tIns="0" rIns="0" bIns="0" anchor="ctr" rtlCol="0"/>
+          <a:lstStyle/>
+          <a:p/>
+        </p:txBody>
+      </p:sp>
+      <p:sp>
+        <p:nvSpPr>
+          <p:cNvPr id="10" name="Shape 10"/>
+          <p:cNvSpPr/>
+          <p:nvPr/>
+        </p:nvSpPr>
+        <p:spPr>
+          <a:xfrm>
+            <a:off x="5199753" y="6281928"/>
+            <a:ext cx="329184" cy="329184"/>
+          </a:xfrm>
+          <a:prstGeom prst="heart">
+            <a:avLst/>
+          </a:prstGeom>
+          <a:solidFill>
+            <a:srgbClr val="FF99AA"/>
+          </a:solidFill>
+          <a:ln>
+            <a:noFill/>
+          </a:ln>
+        </p:spPr>
+        <p:txBody>
+          <a:bodyPr wrap="square" lIns="0" tIns="0" rIns="0" bIns="0" anchor="ctr" rtlCol="0"/>
+          <a:lstStyle/>
+          <a:p/>
+        </p:txBody>
+      </p:sp>
+      <p:sp>
+        <p:nvSpPr>
+          <p:cNvPr id="11" name="TextBox 11"/>
           <p:cNvSpPr txBox="1"/>
           <p:nvPr/>
         </p:nvSpPr>
@@ -1741,7 +1984,7 @@
             <a:r>
               <a:rPr lang="ja-JP" altLang="en-US" sz="1400" b="1" spc="150">
                 <a:solidFill>
-                  <a:srgbClr val="14141A"/>
+                  <a:srgbClr val="C9184A"/>
                 </a:solidFill>
                 <a:latin typeface="Yu Gothic"/>
                 <a:ea typeface="Yu Gothic"/>
@@ -1754,37 +1997,37 @@
       </p:sp>
       <p:sp>
         <p:nvSpPr>
-          <p:cNvPr id="3" name="TextBox 3"/>
+          <p:cNvPr id="12" name="TextBox 12"/>
           <p:cNvSpPr txBox="1"/>
           <p:nvPr/>
         </p:nvSpPr>
         <p:spPr>
           <a:xfrm>
             <a:off x="841248" y="1371600"/>
-            <a:ext cx="10515600" cy="3931920"/>
-          </a:xfrm>
-          <a:prstGeom prst="rect">
-            <a:avLst/>
-          </a:prstGeom>
-          <a:noFill/>
-        </p:spPr>
-        <p:txBody>
-          <a:bodyPr wrap="square" lIns="0" tIns="0" rIns="0" bIns="0" anchor="ctr" rtlCol="0"/>
-          <a:lstStyle/>
-          <a:p>
-            <a:pPr algn="l">
-              <a:lnSpc>
-                <a:spcPct val="105000"/>
+            <a:ext cx="7863840" cy="3931920"/>
+          </a:xfrm>
+          <a:prstGeom prst="rect">
+            <a:avLst/>
+          </a:prstGeom>
+          <a:noFill/>
+        </p:spPr>
+        <p:txBody>
+          <a:bodyPr wrap="square" lIns="0" tIns="0" rIns="0" bIns="0" anchor="ctr" rtlCol="0"/>
+          <a:lstStyle/>
+          <a:p>
+            <a:pPr algn="l">
+              <a:lnSpc>
+                <a:spcPct val="108000"/>
               </a:lnSpc>
             </a:pPr>
             <a:r>
               <a:rPr lang="ja-JP" altLang="en-US" sz="8000" b="1">
                 <a:solidFill>
-                  <a:srgbClr val="14141A"/>
-                </a:solidFill>
-                <a:latin typeface="Yu Gothic"/>
-                <a:ea typeface="Yu Gothic"/>
-                <a:cs typeface="Yu Gothic"/>
+                  <a:srgbClr val="C9184A"/>
+                </a:solidFill>
+                <a:latin typeface="Hiragino Maru Gothic ProN"/>
+                <a:ea typeface="Hiragino Maru Gothic ProN"/>
+                <a:cs typeface="Hiragino Maru Gothic ProN"/>
               </a:rPr>
               <a:t>ふたりの計画の</a:t>
             </a:r>
@@ -1792,17 +2035,17 @@
           <a:p>
             <a:pPr algn="l">
               <a:lnSpc>
-                <a:spcPct val="105000"/>
+                <a:spcPct val="108000"/>
               </a:lnSpc>
             </a:pPr>
             <a:r>
               <a:rPr lang="ja-JP" altLang="en-US" sz="8000" b="1">
                 <a:solidFill>
-                  <a:srgbClr val="14141A"/>
-                </a:solidFill>
-                <a:latin typeface="Yu Gothic"/>
-                <a:ea typeface="Yu Gothic"/>
-                <a:cs typeface="Yu Gothic"/>
+                  <a:srgbClr val="C9184A"/>
+                </a:solidFill>
+                <a:latin typeface="Hiragino Maru Gothic ProN"/>
+                <a:ea typeface="Hiragino Maru Gothic ProN"/>
+                <a:cs typeface="Hiragino Maru Gothic ProN"/>
               </a:rPr>
               <a:t>ご提案</a:t>
             </a:r>
@@ -1811,14 +2054,14 @@
       </p:sp>
       <p:sp>
         <p:nvSpPr>
-          <p:cNvPr id="4" name="TextBox 4"/>
+          <p:cNvPr id="13" name="TextBox 13"/>
           <p:cNvSpPr txBox="1"/>
           <p:nvPr/>
         </p:nvSpPr>
         <p:spPr>
           <a:xfrm>
             <a:off x="841248" y="5212080"/>
-            <a:ext cx="10515600" cy="457200"/>
+            <a:ext cx="7863840" cy="457200"/>
           </a:xfrm>
           <a:prstGeom prst="rect">
             <a:avLst/>
@@ -1839,9 +2082,9 @@
                 <a:solidFill>
                   <a:srgbClr val="14141A"/>
                 </a:solidFill>
-                <a:latin typeface="Yu Gothic Medium"/>
-                <a:ea typeface="Yu Gothic Medium"/>
-                <a:cs typeface="Yu Gothic Medium"/>
+                <a:latin typeface="Hiragino Maru Gothic ProN"/>
+                <a:ea typeface="Hiragino Maru Gothic ProN"/>
+                <a:cs typeface="Hiragino Maru Gothic ProN"/>
               </a:rPr>
               <a:t>2026 → 2029 のたたき台です。</a:t>
             </a:r>
@@ -1850,7 +2093,7 @@
       </p:sp>
       <p:sp>
         <p:nvSpPr>
-          <p:cNvPr id="5" name="TextBox 5"/>
+          <p:cNvPr id="14" name="TextBox 14"/>
           <p:cNvSpPr txBox="1"/>
           <p:nvPr/>
         </p:nvSpPr>
@@ -1876,7 +2119,7 @@
             <a:r>
               <a:rPr lang="ja-JP" altLang="en-US" sz="1300" b="1" spc="120">
                 <a:solidFill>
-                  <a:srgbClr val="14141A"/>
+                  <a:srgbClr val="6B6B76"/>
                 </a:solidFill>
                 <a:latin typeface="Yu Gothic"/>
                 <a:ea typeface="Yu Gothic"/>
@@ -2189,7 +2432,250 @@
       </p:grpSpPr>
       <p:sp>
         <p:nvSpPr>
-          <p:cNvPr id="2" name="TextBox 2"/>
+          <p:cNvPr id="2" name="Shape 2"/>
+          <p:cNvSpPr/>
+          <p:nvPr/>
+        </p:nvSpPr>
+        <p:spPr>
+          <a:xfrm>
+            <a:off x="8130323" y="160020"/>
+            <a:ext cx="1051560" cy="1051560"/>
+          </a:xfrm>
+          <a:prstGeom prst="heart">
+            <a:avLst/>
+          </a:prstGeom>
+          <a:solidFill>
+            <a:srgbClr val="FFBAC5"/>
+          </a:solidFill>
+          <a:ln>
+            <a:noFill/>
+          </a:ln>
+        </p:spPr>
+        <p:txBody>
+          <a:bodyPr wrap="square" lIns="0" tIns="0" rIns="0" bIns="0" anchor="ctr" rtlCol="0"/>
+          <a:lstStyle/>
+          <a:p/>
+        </p:txBody>
+      </p:sp>
+      <p:sp>
+        <p:nvSpPr>
+          <p:cNvPr id="3" name="Shape 3"/>
+          <p:cNvSpPr/>
+          <p:nvPr/>
+        </p:nvSpPr>
+        <p:spPr>
+          <a:xfrm>
+            <a:off x="10445227" y="1773936"/>
+            <a:ext cx="566928" cy="566928"/>
+          </a:xfrm>
+          <a:prstGeom prst="heart">
+            <a:avLst/>
+          </a:prstGeom>
+          <a:solidFill>
+            <a:srgbClr val="FF93A5"/>
+          </a:solidFill>
+          <a:ln>
+            <a:noFill/>
+          </a:ln>
+        </p:spPr>
+        <p:txBody>
+          <a:bodyPr wrap="square" lIns="0" tIns="0" rIns="0" bIns="0" anchor="ctr" rtlCol="0"/>
+          <a:lstStyle/>
+          <a:p/>
+        </p:txBody>
+      </p:sp>
+      <p:sp>
+        <p:nvSpPr>
+          <p:cNvPr id="4" name="Shape 4"/>
+          <p:cNvSpPr/>
+          <p:nvPr/>
+        </p:nvSpPr>
+        <p:spPr>
+          <a:xfrm>
+            <a:off x="9210815" y="3214116"/>
+            <a:ext cx="841248" cy="841248"/>
+          </a:xfrm>
+          <a:prstGeom prst="heart">
+            <a:avLst/>
+          </a:prstGeom>
+          <a:solidFill>
+            <a:srgbClr val="FF93A5"/>
+          </a:solidFill>
+          <a:ln>
+            <a:noFill/>
+          </a:ln>
+        </p:spPr>
+        <p:txBody>
+          <a:bodyPr wrap="square" lIns="0" tIns="0" rIns="0" bIns="0" anchor="ctr" rtlCol="0"/>
+          <a:lstStyle/>
+          <a:p/>
+        </p:txBody>
+      </p:sp>
+      <p:sp>
+        <p:nvSpPr>
+          <p:cNvPr id="5" name="Shape 5"/>
+          <p:cNvSpPr/>
+          <p:nvPr/>
+        </p:nvSpPr>
+        <p:spPr>
+          <a:xfrm>
+            <a:off x="11240737" y="4649724"/>
+            <a:ext cx="438912" cy="438912"/>
+          </a:xfrm>
+          <a:prstGeom prst="heart">
+            <a:avLst/>
+          </a:prstGeom>
+          <a:solidFill>
+            <a:srgbClr val="FFBAC5"/>
+          </a:solidFill>
+          <a:ln>
+            <a:noFill/>
+          </a:ln>
+        </p:spPr>
+        <p:txBody>
+          <a:bodyPr wrap="square" lIns="0" tIns="0" rIns="0" bIns="0" anchor="ctr" rtlCol="0"/>
+          <a:lstStyle/>
+          <a:p/>
+        </p:txBody>
+      </p:sp>
+      <p:sp>
+        <p:nvSpPr>
+          <p:cNvPr id="6" name="Shape 6"/>
+          <p:cNvSpPr/>
+          <p:nvPr/>
+        </p:nvSpPr>
+        <p:spPr>
+          <a:xfrm>
+            <a:off x="7622849" y="5116068"/>
+            <a:ext cx="603504" cy="603504"/>
+          </a:xfrm>
+          <a:prstGeom prst="heart">
+            <a:avLst/>
+          </a:prstGeom>
+          <a:solidFill>
+            <a:srgbClr val="FFBAC5"/>
+          </a:solidFill>
+          <a:ln>
+            <a:noFill/>
+          </a:ln>
+        </p:spPr>
+        <p:txBody>
+          <a:bodyPr wrap="square" lIns="0" tIns="0" rIns="0" bIns="0" anchor="ctr" rtlCol="0"/>
+          <a:lstStyle/>
+          <a:p/>
+        </p:txBody>
+      </p:sp>
+      <p:sp>
+        <p:nvSpPr>
+          <p:cNvPr id="7" name="Shape 7"/>
+          <p:cNvSpPr/>
+          <p:nvPr/>
+        </p:nvSpPr>
+        <p:spPr>
+          <a:xfrm>
+            <a:off x="281927" y="205740"/>
+            <a:ext cx="411480" cy="411480"/>
+          </a:xfrm>
+          <a:prstGeom prst="heart">
+            <a:avLst/>
+          </a:prstGeom>
+          <a:solidFill>
+            <a:srgbClr val="FF93A5"/>
+          </a:solidFill>
+          <a:ln>
+            <a:noFill/>
+          </a:ln>
+        </p:spPr>
+        <p:txBody>
+          <a:bodyPr wrap="square" lIns="0" tIns="0" rIns="0" bIns="0" anchor="ctr" rtlCol="0"/>
+          <a:lstStyle/>
+          <a:p/>
+        </p:txBody>
+      </p:sp>
+      <p:sp>
+        <p:nvSpPr>
+          <p:cNvPr id="8" name="Shape 8"/>
+          <p:cNvSpPr/>
+          <p:nvPr/>
+        </p:nvSpPr>
+        <p:spPr>
+          <a:xfrm>
+            <a:off x="1700738" y="77724"/>
+            <a:ext cx="256032" cy="256032"/>
+          </a:xfrm>
+          <a:prstGeom prst="heart">
+            <a:avLst/>
+          </a:prstGeom>
+          <a:solidFill>
+            <a:srgbClr val="FFBAC5"/>
+          </a:solidFill>
+          <a:ln>
+            <a:noFill/>
+          </a:ln>
+        </p:spPr>
+        <p:txBody>
+          <a:bodyPr wrap="square" lIns="0" tIns="0" rIns="0" bIns="0" anchor="ctr" rtlCol="0"/>
+          <a:lstStyle/>
+          <a:p/>
+        </p:txBody>
+      </p:sp>
+      <p:sp>
+        <p:nvSpPr>
+          <p:cNvPr id="9" name="Shape 9"/>
+          <p:cNvSpPr/>
+          <p:nvPr/>
+        </p:nvSpPr>
+        <p:spPr>
+          <a:xfrm>
+            <a:off x="36566" y="3922776"/>
+            <a:ext cx="658368" cy="658368"/>
+          </a:xfrm>
+          <a:prstGeom prst="heart">
+            <a:avLst/>
+          </a:prstGeom>
+          <a:solidFill>
+            <a:srgbClr val="FFBAC5"/>
+          </a:solidFill>
+          <a:ln>
+            <a:noFill/>
+          </a:ln>
+        </p:spPr>
+        <p:txBody>
+          <a:bodyPr wrap="square" lIns="0" tIns="0" rIns="0" bIns="0" anchor="ctr" rtlCol="0"/>
+          <a:lstStyle/>
+          <a:p/>
+        </p:txBody>
+      </p:sp>
+      <p:sp>
+        <p:nvSpPr>
+          <p:cNvPr id="10" name="Shape 10"/>
+          <p:cNvSpPr/>
+          <p:nvPr/>
+        </p:nvSpPr>
+        <p:spPr>
+          <a:xfrm>
+            <a:off x="5199753" y="6281928"/>
+            <a:ext cx="329184" cy="329184"/>
+          </a:xfrm>
+          <a:prstGeom prst="heart">
+            <a:avLst/>
+          </a:prstGeom>
+          <a:solidFill>
+            <a:srgbClr val="FF93A5"/>
+          </a:solidFill>
+          <a:ln>
+            <a:noFill/>
+          </a:ln>
+        </p:spPr>
+        <p:txBody>
+          <a:bodyPr wrap="square" lIns="0" tIns="0" rIns="0" bIns="0" anchor="ctr" rtlCol="0"/>
+          <a:lstStyle/>
+          <a:p/>
+        </p:txBody>
+      </p:sp>
+      <p:sp>
+        <p:nvSpPr>
+          <p:cNvPr id="11" name="TextBox 11"/>
           <p:cNvSpPr txBox="1"/>
           <p:nvPr/>
         </p:nvSpPr>
@@ -2228,7 +2714,7 @@
       </p:sp>
       <p:sp>
         <p:nvSpPr>
-          <p:cNvPr id="3" name="TextBox 3"/>
+          <p:cNvPr id="12" name="TextBox 12"/>
           <p:cNvSpPr txBox="1"/>
           <p:nvPr/>
         </p:nvSpPr>
@@ -2256,9 +2742,9 @@
                 <a:solidFill>
                   <a:srgbClr val="FFFFFF"/>
                 </a:solidFill>
-                <a:latin typeface="Yu Gothic"/>
-                <a:ea typeface="Yu Gothic"/>
-                <a:cs typeface="Yu Gothic"/>
+                <a:latin typeface="Hiragino Maru Gothic ProN"/>
+                <a:ea typeface="Hiragino Maru Gothic ProN"/>
+                <a:cs typeface="Hiragino Maru Gothic ProN"/>
               </a:rPr>
               <a:t>お互いについて</a:t>
             </a:r>
@@ -2267,7 +2753,7 @@
       </p:sp>
       <p:sp>
         <p:nvSpPr>
-          <p:cNvPr id="4" name="TextBox 4"/>
+          <p:cNvPr id="13" name="TextBox 13"/>
           <p:cNvSpPr txBox="1"/>
           <p:nvPr/>
         </p:nvSpPr>
@@ -3140,7 +3626,250 @@
       </p:grpSpPr>
       <p:sp>
         <p:nvSpPr>
-          <p:cNvPr id="2" name="TextBox 2"/>
+          <p:cNvPr id="2" name="Shape 2"/>
+          <p:cNvSpPr/>
+          <p:nvPr/>
+        </p:nvSpPr>
+        <p:spPr>
+          <a:xfrm>
+            <a:off x="8130323" y="160020"/>
+            <a:ext cx="1051560" cy="1051560"/>
+          </a:xfrm>
+          <a:prstGeom prst="heart">
+            <a:avLst/>
+          </a:prstGeom>
+          <a:solidFill>
+            <a:srgbClr val="93E6DF"/>
+          </a:solidFill>
+          <a:ln>
+            <a:noFill/>
+          </a:ln>
+        </p:spPr>
+        <p:txBody>
+          <a:bodyPr wrap="square" lIns="0" tIns="0" rIns="0" bIns="0" anchor="ctr" rtlCol="0"/>
+          <a:lstStyle/>
+          <a:p/>
+        </p:txBody>
+      </p:sp>
+      <p:sp>
+        <p:nvSpPr>
+          <p:cNvPr id="3" name="Shape 3"/>
+          <p:cNvSpPr/>
+          <p:nvPr/>
+        </p:nvSpPr>
+        <p:spPr>
+          <a:xfrm>
+            <a:off x="10445227" y="1773936"/>
+            <a:ext cx="566928" cy="566928"/>
+          </a:xfrm>
+          <a:prstGeom prst="heart">
+            <a:avLst/>
+          </a:prstGeom>
+          <a:solidFill>
+            <a:srgbClr val="56D8CC"/>
+          </a:solidFill>
+          <a:ln>
+            <a:noFill/>
+          </a:ln>
+        </p:spPr>
+        <p:txBody>
+          <a:bodyPr wrap="square" lIns="0" tIns="0" rIns="0" bIns="0" anchor="ctr" rtlCol="0"/>
+          <a:lstStyle/>
+          <a:p/>
+        </p:txBody>
+      </p:sp>
+      <p:sp>
+        <p:nvSpPr>
+          <p:cNvPr id="4" name="Shape 4"/>
+          <p:cNvSpPr/>
+          <p:nvPr/>
+        </p:nvSpPr>
+        <p:spPr>
+          <a:xfrm>
+            <a:off x="9210815" y="3214116"/>
+            <a:ext cx="841248" cy="841248"/>
+          </a:xfrm>
+          <a:prstGeom prst="heart">
+            <a:avLst/>
+          </a:prstGeom>
+          <a:solidFill>
+            <a:srgbClr val="56D8CC"/>
+          </a:solidFill>
+          <a:ln>
+            <a:noFill/>
+          </a:ln>
+        </p:spPr>
+        <p:txBody>
+          <a:bodyPr wrap="square" lIns="0" tIns="0" rIns="0" bIns="0" anchor="ctr" rtlCol="0"/>
+          <a:lstStyle/>
+          <a:p/>
+        </p:txBody>
+      </p:sp>
+      <p:sp>
+        <p:nvSpPr>
+          <p:cNvPr id="5" name="Shape 5"/>
+          <p:cNvSpPr/>
+          <p:nvPr/>
+        </p:nvSpPr>
+        <p:spPr>
+          <a:xfrm>
+            <a:off x="11240737" y="4649724"/>
+            <a:ext cx="438912" cy="438912"/>
+          </a:xfrm>
+          <a:prstGeom prst="heart">
+            <a:avLst/>
+          </a:prstGeom>
+          <a:solidFill>
+            <a:srgbClr val="93E6DF"/>
+          </a:solidFill>
+          <a:ln>
+            <a:noFill/>
+          </a:ln>
+        </p:spPr>
+        <p:txBody>
+          <a:bodyPr wrap="square" lIns="0" tIns="0" rIns="0" bIns="0" anchor="ctr" rtlCol="0"/>
+          <a:lstStyle/>
+          <a:p/>
+        </p:txBody>
+      </p:sp>
+      <p:sp>
+        <p:nvSpPr>
+          <p:cNvPr id="6" name="Shape 6"/>
+          <p:cNvSpPr/>
+          <p:nvPr/>
+        </p:nvSpPr>
+        <p:spPr>
+          <a:xfrm>
+            <a:off x="7622849" y="5116068"/>
+            <a:ext cx="603504" cy="603504"/>
+          </a:xfrm>
+          <a:prstGeom prst="heart">
+            <a:avLst/>
+          </a:prstGeom>
+          <a:solidFill>
+            <a:srgbClr val="93E6DF"/>
+          </a:solidFill>
+          <a:ln>
+            <a:noFill/>
+          </a:ln>
+        </p:spPr>
+        <p:txBody>
+          <a:bodyPr wrap="square" lIns="0" tIns="0" rIns="0" bIns="0" anchor="ctr" rtlCol="0"/>
+          <a:lstStyle/>
+          <a:p/>
+        </p:txBody>
+      </p:sp>
+      <p:sp>
+        <p:nvSpPr>
+          <p:cNvPr id="7" name="Shape 7"/>
+          <p:cNvSpPr/>
+          <p:nvPr/>
+        </p:nvSpPr>
+        <p:spPr>
+          <a:xfrm>
+            <a:off x="281927" y="205740"/>
+            <a:ext cx="411480" cy="411480"/>
+          </a:xfrm>
+          <a:prstGeom prst="heart">
+            <a:avLst/>
+          </a:prstGeom>
+          <a:solidFill>
+            <a:srgbClr val="56D8CC"/>
+          </a:solidFill>
+          <a:ln>
+            <a:noFill/>
+          </a:ln>
+        </p:spPr>
+        <p:txBody>
+          <a:bodyPr wrap="square" lIns="0" tIns="0" rIns="0" bIns="0" anchor="ctr" rtlCol="0"/>
+          <a:lstStyle/>
+          <a:p/>
+        </p:txBody>
+      </p:sp>
+      <p:sp>
+        <p:nvSpPr>
+          <p:cNvPr id="8" name="Shape 8"/>
+          <p:cNvSpPr/>
+          <p:nvPr/>
+        </p:nvSpPr>
+        <p:spPr>
+          <a:xfrm>
+            <a:off x="1700738" y="77724"/>
+            <a:ext cx="256032" cy="256032"/>
+          </a:xfrm>
+          <a:prstGeom prst="heart">
+            <a:avLst/>
+          </a:prstGeom>
+          <a:solidFill>
+            <a:srgbClr val="93E6DF"/>
+          </a:solidFill>
+          <a:ln>
+            <a:noFill/>
+          </a:ln>
+        </p:spPr>
+        <p:txBody>
+          <a:bodyPr wrap="square" lIns="0" tIns="0" rIns="0" bIns="0" anchor="ctr" rtlCol="0"/>
+          <a:lstStyle/>
+          <a:p/>
+        </p:txBody>
+      </p:sp>
+      <p:sp>
+        <p:nvSpPr>
+          <p:cNvPr id="9" name="Shape 9"/>
+          <p:cNvSpPr/>
+          <p:nvPr/>
+        </p:nvSpPr>
+        <p:spPr>
+          <a:xfrm>
+            <a:off x="36566" y="3922776"/>
+            <a:ext cx="658368" cy="658368"/>
+          </a:xfrm>
+          <a:prstGeom prst="heart">
+            <a:avLst/>
+          </a:prstGeom>
+          <a:solidFill>
+            <a:srgbClr val="93E6DF"/>
+          </a:solidFill>
+          <a:ln>
+            <a:noFill/>
+          </a:ln>
+        </p:spPr>
+        <p:txBody>
+          <a:bodyPr wrap="square" lIns="0" tIns="0" rIns="0" bIns="0" anchor="ctr" rtlCol="0"/>
+          <a:lstStyle/>
+          <a:p/>
+        </p:txBody>
+      </p:sp>
+      <p:sp>
+        <p:nvSpPr>
+          <p:cNvPr id="10" name="Shape 10"/>
+          <p:cNvSpPr/>
+          <p:nvPr/>
+        </p:nvSpPr>
+        <p:spPr>
+          <a:xfrm>
+            <a:off x="5199753" y="6281928"/>
+            <a:ext cx="329184" cy="329184"/>
+          </a:xfrm>
+          <a:prstGeom prst="heart">
+            <a:avLst/>
+          </a:prstGeom>
+          <a:solidFill>
+            <a:srgbClr val="56D8CC"/>
+          </a:solidFill>
+          <a:ln>
+            <a:noFill/>
+          </a:ln>
+        </p:spPr>
+        <p:txBody>
+          <a:bodyPr wrap="square" lIns="0" tIns="0" rIns="0" bIns="0" anchor="ctr" rtlCol="0"/>
+          <a:lstStyle/>
+          <a:p/>
+        </p:txBody>
+      </p:sp>
+      <p:sp>
+        <p:nvSpPr>
+          <p:cNvPr id="11" name="TextBox 11"/>
           <p:cNvSpPr txBox="1"/>
           <p:nvPr/>
         </p:nvSpPr>
@@ -3179,7 +3908,7 @@
       </p:sp>
       <p:sp>
         <p:nvSpPr>
-          <p:cNvPr id="3" name="TextBox 3"/>
+          <p:cNvPr id="12" name="TextBox 12"/>
           <p:cNvSpPr txBox="1"/>
           <p:nvPr/>
         </p:nvSpPr>
@@ -3207,9 +3936,9 @@
                 <a:solidFill>
                   <a:srgbClr val="FFFFFF"/>
                 </a:solidFill>
-                <a:latin typeface="Yu Gothic"/>
-                <a:ea typeface="Yu Gothic"/>
-                <a:cs typeface="Yu Gothic"/>
+                <a:latin typeface="Hiragino Maru Gothic ProN"/>
+                <a:ea typeface="Hiragino Maru Gothic ProN"/>
+                <a:cs typeface="Hiragino Maru Gothic ProN"/>
               </a:rPr>
               <a:t>だから、大丈夫です。</a:t>
             </a:r>
@@ -3218,7 +3947,7 @@
       </p:sp>
       <p:sp>
         <p:nvSpPr>
-          <p:cNvPr id="4" name="TextBox 4"/>
+          <p:cNvPr id="13" name="TextBox 13"/>
           <p:cNvSpPr txBox="1"/>
           <p:nvPr/>
         </p:nvSpPr>
@@ -12934,7 +13663,7 @@
     <p:bg>
       <p:bgPr>
         <a:solidFill>
-          <a:srgbClr val="FFD93D"/>
+          <a:srgbClr val="FFF1F4"/>
         </a:solidFill>
         <a:effectLst/>
       </p:bgPr>
@@ -12955,7 +13684,250 @@
       </p:grpSpPr>
       <p:sp>
         <p:nvSpPr>
-          <p:cNvPr id="2" name="TextBox 2"/>
+          <p:cNvPr id="2" name="Shape 2"/>
+          <p:cNvSpPr/>
+          <p:nvPr/>
+        </p:nvSpPr>
+        <p:spPr>
+          <a:xfrm>
+            <a:off x="8130323" y="160020"/>
+            <a:ext cx="1051560" cy="1051560"/>
+          </a:xfrm>
+          <a:prstGeom prst="heart">
+            <a:avLst/>
+          </a:prstGeom>
+          <a:solidFill>
+            <a:srgbClr val="FFC1CB"/>
+          </a:solidFill>
+          <a:ln>
+            <a:noFill/>
+          </a:ln>
+        </p:spPr>
+        <p:txBody>
+          <a:bodyPr wrap="square" lIns="0" tIns="0" rIns="0" bIns="0" anchor="ctr" rtlCol="0"/>
+          <a:lstStyle/>
+          <a:p/>
+        </p:txBody>
+      </p:sp>
+      <p:sp>
+        <p:nvSpPr>
+          <p:cNvPr id="3" name="Shape 3"/>
+          <p:cNvSpPr/>
+          <p:nvPr/>
+        </p:nvSpPr>
+        <p:spPr>
+          <a:xfrm>
+            <a:off x="10445227" y="1773936"/>
+            <a:ext cx="566928" cy="566928"/>
+          </a:xfrm>
+          <a:prstGeom prst="heart">
+            <a:avLst/>
+          </a:prstGeom>
+          <a:solidFill>
+            <a:srgbClr val="FF99AA"/>
+          </a:solidFill>
+          <a:ln>
+            <a:noFill/>
+          </a:ln>
+        </p:spPr>
+        <p:txBody>
+          <a:bodyPr wrap="square" lIns="0" tIns="0" rIns="0" bIns="0" anchor="ctr" rtlCol="0"/>
+          <a:lstStyle/>
+          <a:p/>
+        </p:txBody>
+      </p:sp>
+      <p:sp>
+        <p:nvSpPr>
+          <p:cNvPr id="4" name="Shape 4"/>
+          <p:cNvSpPr/>
+          <p:nvPr/>
+        </p:nvSpPr>
+        <p:spPr>
+          <a:xfrm>
+            <a:off x="9210815" y="3214116"/>
+            <a:ext cx="841248" cy="841248"/>
+          </a:xfrm>
+          <a:prstGeom prst="heart">
+            <a:avLst/>
+          </a:prstGeom>
+          <a:solidFill>
+            <a:srgbClr val="FF99AA"/>
+          </a:solidFill>
+          <a:ln>
+            <a:noFill/>
+          </a:ln>
+        </p:spPr>
+        <p:txBody>
+          <a:bodyPr wrap="square" lIns="0" tIns="0" rIns="0" bIns="0" anchor="ctr" rtlCol="0"/>
+          <a:lstStyle/>
+          <a:p/>
+        </p:txBody>
+      </p:sp>
+      <p:sp>
+        <p:nvSpPr>
+          <p:cNvPr id="5" name="Shape 5"/>
+          <p:cNvSpPr/>
+          <p:nvPr/>
+        </p:nvSpPr>
+        <p:spPr>
+          <a:xfrm>
+            <a:off x="11240737" y="4649724"/>
+            <a:ext cx="438912" cy="438912"/>
+          </a:xfrm>
+          <a:prstGeom prst="heart">
+            <a:avLst/>
+          </a:prstGeom>
+          <a:solidFill>
+            <a:srgbClr val="FFC1CB"/>
+          </a:solidFill>
+          <a:ln>
+            <a:noFill/>
+          </a:ln>
+        </p:spPr>
+        <p:txBody>
+          <a:bodyPr wrap="square" lIns="0" tIns="0" rIns="0" bIns="0" anchor="ctr" rtlCol="0"/>
+          <a:lstStyle/>
+          <a:p/>
+        </p:txBody>
+      </p:sp>
+      <p:sp>
+        <p:nvSpPr>
+          <p:cNvPr id="6" name="Shape 6"/>
+          <p:cNvSpPr/>
+          <p:nvPr/>
+        </p:nvSpPr>
+        <p:spPr>
+          <a:xfrm>
+            <a:off x="7622849" y="5116068"/>
+            <a:ext cx="603504" cy="603504"/>
+          </a:xfrm>
+          <a:prstGeom prst="heart">
+            <a:avLst/>
+          </a:prstGeom>
+          <a:solidFill>
+            <a:srgbClr val="FFC1CB"/>
+          </a:solidFill>
+          <a:ln>
+            <a:noFill/>
+          </a:ln>
+        </p:spPr>
+        <p:txBody>
+          <a:bodyPr wrap="square" lIns="0" tIns="0" rIns="0" bIns="0" anchor="ctr" rtlCol="0"/>
+          <a:lstStyle/>
+          <a:p/>
+        </p:txBody>
+      </p:sp>
+      <p:sp>
+        <p:nvSpPr>
+          <p:cNvPr id="7" name="Shape 7"/>
+          <p:cNvSpPr/>
+          <p:nvPr/>
+        </p:nvSpPr>
+        <p:spPr>
+          <a:xfrm>
+            <a:off x="281927" y="205740"/>
+            <a:ext cx="411480" cy="411480"/>
+          </a:xfrm>
+          <a:prstGeom prst="heart">
+            <a:avLst/>
+          </a:prstGeom>
+          <a:solidFill>
+            <a:srgbClr val="FF99AA"/>
+          </a:solidFill>
+          <a:ln>
+            <a:noFill/>
+          </a:ln>
+        </p:spPr>
+        <p:txBody>
+          <a:bodyPr wrap="square" lIns="0" tIns="0" rIns="0" bIns="0" anchor="ctr" rtlCol="0"/>
+          <a:lstStyle/>
+          <a:p/>
+        </p:txBody>
+      </p:sp>
+      <p:sp>
+        <p:nvSpPr>
+          <p:cNvPr id="8" name="Shape 8"/>
+          <p:cNvSpPr/>
+          <p:nvPr/>
+        </p:nvSpPr>
+        <p:spPr>
+          <a:xfrm>
+            <a:off x="1700738" y="77724"/>
+            <a:ext cx="256032" cy="256032"/>
+          </a:xfrm>
+          <a:prstGeom prst="heart">
+            <a:avLst/>
+          </a:prstGeom>
+          <a:solidFill>
+            <a:srgbClr val="FFC1CB"/>
+          </a:solidFill>
+          <a:ln>
+            <a:noFill/>
+          </a:ln>
+        </p:spPr>
+        <p:txBody>
+          <a:bodyPr wrap="square" lIns="0" tIns="0" rIns="0" bIns="0" anchor="ctr" rtlCol="0"/>
+          <a:lstStyle/>
+          <a:p/>
+        </p:txBody>
+      </p:sp>
+      <p:sp>
+        <p:nvSpPr>
+          <p:cNvPr id="9" name="Shape 9"/>
+          <p:cNvSpPr/>
+          <p:nvPr/>
+        </p:nvSpPr>
+        <p:spPr>
+          <a:xfrm>
+            <a:off x="36566" y="3922776"/>
+            <a:ext cx="658368" cy="658368"/>
+          </a:xfrm>
+          <a:prstGeom prst="heart">
+            <a:avLst/>
+          </a:prstGeom>
+          <a:solidFill>
+            <a:srgbClr val="FFC1CB"/>
+          </a:solidFill>
+          <a:ln>
+            <a:noFill/>
+          </a:ln>
+        </p:spPr>
+        <p:txBody>
+          <a:bodyPr wrap="square" lIns="0" tIns="0" rIns="0" bIns="0" anchor="ctr" rtlCol="0"/>
+          <a:lstStyle/>
+          <a:p/>
+        </p:txBody>
+      </p:sp>
+      <p:sp>
+        <p:nvSpPr>
+          <p:cNvPr id="10" name="Shape 10"/>
+          <p:cNvSpPr/>
+          <p:nvPr/>
+        </p:nvSpPr>
+        <p:spPr>
+          <a:xfrm>
+            <a:off x="5199753" y="6281928"/>
+            <a:ext cx="329184" cy="329184"/>
+          </a:xfrm>
+          <a:prstGeom prst="heart">
+            <a:avLst/>
+          </a:prstGeom>
+          <a:solidFill>
+            <a:srgbClr val="FF99AA"/>
+          </a:solidFill>
+          <a:ln>
+            <a:noFill/>
+          </a:ln>
+        </p:spPr>
+        <p:txBody>
+          <a:bodyPr wrap="square" lIns="0" tIns="0" rIns="0" bIns="0" anchor="ctr" rtlCol="0"/>
+          <a:lstStyle/>
+          <a:p/>
+        </p:txBody>
+      </p:sp>
+      <p:sp>
+        <p:nvSpPr>
+          <p:cNvPr id="11" name="TextBox 11"/>
           <p:cNvSpPr txBox="1"/>
           <p:nvPr/>
         </p:nvSpPr>
@@ -12981,7 +13953,7 @@
             <a:r>
               <a:rPr lang="ja-JP" altLang="en-US" sz="1400" b="1" spc="150">
                 <a:solidFill>
-                  <a:srgbClr val="14141A"/>
+                  <a:srgbClr val="C9184A"/>
                 </a:solidFill>
                 <a:latin typeface="Yu Gothic"/>
                 <a:ea typeface="Yu Gothic"/>
@@ -12994,37 +13966,37 @@
       </p:sp>
       <p:sp>
         <p:nvSpPr>
-          <p:cNvPr id="3" name="TextBox 3"/>
+          <p:cNvPr id="12" name="TextBox 12"/>
           <p:cNvSpPr txBox="1"/>
           <p:nvPr/>
         </p:nvSpPr>
         <p:spPr>
           <a:xfrm>
             <a:off x="841248" y="1828800"/>
-            <a:ext cx="10515600" cy="2743200"/>
-          </a:xfrm>
-          <a:prstGeom prst="rect">
-            <a:avLst/>
-          </a:prstGeom>
-          <a:noFill/>
-        </p:spPr>
-        <p:txBody>
-          <a:bodyPr wrap="square" lIns="0" tIns="0" rIns="0" bIns="0" anchor="ctr" rtlCol="0"/>
-          <a:lstStyle/>
-          <a:p>
-            <a:pPr algn="l">
-              <a:lnSpc>
-                <a:spcPct val="112000"/>
+            <a:ext cx="8595360" cy="2743200"/>
+          </a:xfrm>
+          <a:prstGeom prst="rect">
+            <a:avLst/>
+          </a:prstGeom>
+          <a:noFill/>
+        </p:spPr>
+        <p:txBody>
+          <a:bodyPr wrap="square" lIns="0" tIns="0" rIns="0" bIns="0" anchor="ctr" rtlCol="0"/>
+          <a:lstStyle/>
+          <a:p>
+            <a:pPr algn="l">
+              <a:lnSpc>
+                <a:spcPct val="114999"/>
               </a:lnSpc>
             </a:pPr>
             <a:r>
               <a:rPr lang="ja-JP" altLang="en-US" sz="5330" b="1">
                 <a:solidFill>
-                  <a:srgbClr val="14141A"/>
-                </a:solidFill>
-                <a:latin typeface="Yu Gothic"/>
-                <a:ea typeface="Yu Gothic"/>
-                <a:cs typeface="Yu Gothic"/>
+                  <a:srgbClr val="C9184A"/>
+                </a:solidFill>
+                <a:latin typeface="Hiragino Maru Gothic ProN"/>
+                <a:ea typeface="Hiragino Maru Gothic ProN"/>
+                <a:cs typeface="Hiragino Maru Gothic ProN"/>
               </a:rPr>
               <a:t>この資料を、</a:t>
             </a:r>
@@ -13032,17 +14004,17 @@
           <a:p>
             <a:pPr algn="l">
               <a:lnSpc>
-                <a:spcPct val="112000"/>
+                <a:spcPct val="114999"/>
               </a:lnSpc>
             </a:pPr>
             <a:r>
               <a:rPr lang="ja-JP" altLang="en-US" sz="5330" b="1">
                 <a:solidFill>
-                  <a:srgbClr val="14141A"/>
-                </a:solidFill>
-                <a:latin typeface="Yu Gothic"/>
-                <a:ea typeface="Yu Gothic"/>
-                <a:cs typeface="Yu Gothic"/>
+                  <a:srgbClr val="C9184A"/>
+                </a:solidFill>
+                <a:latin typeface="Hiragino Maru Gothic ProN"/>
+                <a:ea typeface="Hiragino Maru Gothic ProN"/>
+                <a:cs typeface="Hiragino Maru Gothic ProN"/>
               </a:rPr>
               <a:t>たたき台にしてください。</a:t>
             </a:r>
@@ -13051,14 +14023,14 @@
       </p:sp>
       <p:sp>
         <p:nvSpPr>
-          <p:cNvPr id="4" name="TextBox 4"/>
+          <p:cNvPr id="13" name="TextBox 13"/>
           <p:cNvSpPr txBox="1"/>
           <p:nvPr/>
         </p:nvSpPr>
         <p:spPr>
           <a:xfrm>
             <a:off x="841248" y="4754880"/>
-            <a:ext cx="10515600" cy="914400"/>
+            <a:ext cx="8595360" cy="914400"/>
           </a:xfrm>
           <a:prstGeom prst="rect">
             <a:avLst/>
@@ -13079,9 +14051,9 @@
                 <a:solidFill>
                   <a:srgbClr val="14141A"/>
                 </a:solidFill>
-                <a:latin typeface="Yu Gothic Medium"/>
-                <a:ea typeface="Yu Gothic Medium"/>
-                <a:cs typeface="Yu Gothic Medium"/>
+                <a:latin typeface="Hiragino Maru Gothic ProN"/>
+                <a:ea typeface="Hiragino Maru Gothic ProN"/>
+                <a:cs typeface="Hiragino Maru Gothic ProN"/>
               </a:rPr>
               <a:t>次に開くのは2027年3月です。それまでに、気になるところを直して返してください。</a:t>
             </a:r>
@@ -14034,7 +15006,250 @@
       </p:grpSpPr>
       <p:sp>
         <p:nvSpPr>
-          <p:cNvPr id="2" name="TextBox 2"/>
+          <p:cNvPr id="2" name="Shape 2"/>
+          <p:cNvSpPr/>
+          <p:nvPr/>
+        </p:nvSpPr>
+        <p:spPr>
+          <a:xfrm>
+            <a:off x="8130323" y="160020"/>
+            <a:ext cx="1051560" cy="1051560"/>
+          </a:xfrm>
+          <a:prstGeom prst="heart">
+            <a:avLst/>
+          </a:prstGeom>
+          <a:solidFill>
+            <a:srgbClr val="FFEFAD"/>
+          </a:solidFill>
+          <a:ln>
+            <a:noFill/>
+          </a:ln>
+        </p:spPr>
+        <p:txBody>
+          <a:bodyPr wrap="square" lIns="0" tIns="0" rIns="0" bIns="0" anchor="ctr" rtlCol="0"/>
+          <a:lstStyle/>
+          <a:p/>
+        </p:txBody>
+      </p:sp>
+      <p:sp>
+        <p:nvSpPr>
+          <p:cNvPr id="3" name="Shape 3"/>
+          <p:cNvSpPr/>
+          <p:nvPr/>
+        </p:nvSpPr>
+        <p:spPr>
+          <a:xfrm>
+            <a:off x="10445227" y="1773936"/>
+            <a:ext cx="566928" cy="566928"/>
+          </a:xfrm>
+          <a:prstGeom prst="heart">
+            <a:avLst/>
+          </a:prstGeom>
+          <a:solidFill>
+            <a:srgbClr val="FFE57E"/>
+          </a:solidFill>
+          <a:ln>
+            <a:noFill/>
+          </a:ln>
+        </p:spPr>
+        <p:txBody>
+          <a:bodyPr wrap="square" lIns="0" tIns="0" rIns="0" bIns="0" anchor="ctr" rtlCol="0"/>
+          <a:lstStyle/>
+          <a:p/>
+        </p:txBody>
+      </p:sp>
+      <p:sp>
+        <p:nvSpPr>
+          <p:cNvPr id="4" name="Shape 4"/>
+          <p:cNvSpPr/>
+          <p:nvPr/>
+        </p:nvSpPr>
+        <p:spPr>
+          <a:xfrm>
+            <a:off x="9210815" y="3214116"/>
+            <a:ext cx="841248" cy="841248"/>
+          </a:xfrm>
+          <a:prstGeom prst="heart">
+            <a:avLst/>
+          </a:prstGeom>
+          <a:solidFill>
+            <a:srgbClr val="FFE57E"/>
+          </a:solidFill>
+          <a:ln>
+            <a:noFill/>
+          </a:ln>
+        </p:spPr>
+        <p:txBody>
+          <a:bodyPr wrap="square" lIns="0" tIns="0" rIns="0" bIns="0" anchor="ctr" rtlCol="0"/>
+          <a:lstStyle/>
+          <a:p/>
+        </p:txBody>
+      </p:sp>
+      <p:sp>
+        <p:nvSpPr>
+          <p:cNvPr id="5" name="Shape 5"/>
+          <p:cNvSpPr/>
+          <p:nvPr/>
+        </p:nvSpPr>
+        <p:spPr>
+          <a:xfrm>
+            <a:off x="11240737" y="4649724"/>
+            <a:ext cx="438912" cy="438912"/>
+          </a:xfrm>
+          <a:prstGeom prst="heart">
+            <a:avLst/>
+          </a:prstGeom>
+          <a:solidFill>
+            <a:srgbClr val="FFEFAD"/>
+          </a:solidFill>
+          <a:ln>
+            <a:noFill/>
+          </a:ln>
+        </p:spPr>
+        <p:txBody>
+          <a:bodyPr wrap="square" lIns="0" tIns="0" rIns="0" bIns="0" anchor="ctr" rtlCol="0"/>
+          <a:lstStyle/>
+          <a:p/>
+        </p:txBody>
+      </p:sp>
+      <p:sp>
+        <p:nvSpPr>
+          <p:cNvPr id="6" name="Shape 6"/>
+          <p:cNvSpPr/>
+          <p:nvPr/>
+        </p:nvSpPr>
+        <p:spPr>
+          <a:xfrm>
+            <a:off x="7622849" y="5116068"/>
+            <a:ext cx="603504" cy="603504"/>
+          </a:xfrm>
+          <a:prstGeom prst="heart">
+            <a:avLst/>
+          </a:prstGeom>
+          <a:solidFill>
+            <a:srgbClr val="FFEFAD"/>
+          </a:solidFill>
+          <a:ln>
+            <a:noFill/>
+          </a:ln>
+        </p:spPr>
+        <p:txBody>
+          <a:bodyPr wrap="square" lIns="0" tIns="0" rIns="0" bIns="0" anchor="ctr" rtlCol="0"/>
+          <a:lstStyle/>
+          <a:p/>
+        </p:txBody>
+      </p:sp>
+      <p:sp>
+        <p:nvSpPr>
+          <p:cNvPr id="7" name="Shape 7"/>
+          <p:cNvSpPr/>
+          <p:nvPr/>
+        </p:nvSpPr>
+        <p:spPr>
+          <a:xfrm>
+            <a:off x="281927" y="205740"/>
+            <a:ext cx="411480" cy="411480"/>
+          </a:xfrm>
+          <a:prstGeom prst="heart">
+            <a:avLst/>
+          </a:prstGeom>
+          <a:solidFill>
+            <a:srgbClr val="FFE57E"/>
+          </a:solidFill>
+          <a:ln>
+            <a:noFill/>
+          </a:ln>
+        </p:spPr>
+        <p:txBody>
+          <a:bodyPr wrap="square" lIns="0" tIns="0" rIns="0" bIns="0" anchor="ctr" rtlCol="0"/>
+          <a:lstStyle/>
+          <a:p/>
+        </p:txBody>
+      </p:sp>
+      <p:sp>
+        <p:nvSpPr>
+          <p:cNvPr id="8" name="Shape 8"/>
+          <p:cNvSpPr/>
+          <p:nvPr/>
+        </p:nvSpPr>
+        <p:spPr>
+          <a:xfrm>
+            <a:off x="1700738" y="77724"/>
+            <a:ext cx="256032" cy="256032"/>
+          </a:xfrm>
+          <a:prstGeom prst="heart">
+            <a:avLst/>
+          </a:prstGeom>
+          <a:solidFill>
+            <a:srgbClr val="FFEFAD"/>
+          </a:solidFill>
+          <a:ln>
+            <a:noFill/>
+          </a:ln>
+        </p:spPr>
+        <p:txBody>
+          <a:bodyPr wrap="square" lIns="0" tIns="0" rIns="0" bIns="0" anchor="ctr" rtlCol="0"/>
+          <a:lstStyle/>
+          <a:p/>
+        </p:txBody>
+      </p:sp>
+      <p:sp>
+        <p:nvSpPr>
+          <p:cNvPr id="9" name="Shape 9"/>
+          <p:cNvSpPr/>
+          <p:nvPr/>
+        </p:nvSpPr>
+        <p:spPr>
+          <a:xfrm>
+            <a:off x="36566" y="3922776"/>
+            <a:ext cx="658368" cy="658368"/>
+          </a:xfrm>
+          <a:prstGeom prst="heart">
+            <a:avLst/>
+          </a:prstGeom>
+          <a:solidFill>
+            <a:srgbClr val="FFEFAD"/>
+          </a:solidFill>
+          <a:ln>
+            <a:noFill/>
+          </a:ln>
+        </p:spPr>
+        <p:txBody>
+          <a:bodyPr wrap="square" lIns="0" tIns="0" rIns="0" bIns="0" anchor="ctr" rtlCol="0"/>
+          <a:lstStyle/>
+          <a:p/>
+        </p:txBody>
+      </p:sp>
+      <p:sp>
+        <p:nvSpPr>
+          <p:cNvPr id="10" name="Shape 10"/>
+          <p:cNvSpPr/>
+          <p:nvPr/>
+        </p:nvSpPr>
+        <p:spPr>
+          <a:xfrm>
+            <a:off x="5199753" y="6281928"/>
+            <a:ext cx="329184" cy="329184"/>
+          </a:xfrm>
+          <a:prstGeom prst="heart">
+            <a:avLst/>
+          </a:prstGeom>
+          <a:solidFill>
+            <a:srgbClr val="FFE57E"/>
+          </a:solidFill>
+          <a:ln>
+            <a:noFill/>
+          </a:ln>
+        </p:spPr>
+        <p:txBody>
+          <a:bodyPr wrap="square" lIns="0" tIns="0" rIns="0" bIns="0" anchor="ctr" rtlCol="0"/>
+          <a:lstStyle/>
+          <a:p/>
+        </p:txBody>
+      </p:sp>
+      <p:sp>
+        <p:nvSpPr>
+          <p:cNvPr id="11" name="TextBox 11"/>
           <p:cNvSpPr txBox="1"/>
           <p:nvPr/>
         </p:nvSpPr>
@@ -14073,7 +15288,7 @@
       </p:sp>
       <p:sp>
         <p:nvSpPr>
-          <p:cNvPr id="3" name="TextBox 3"/>
+          <p:cNvPr id="12" name="TextBox 12"/>
           <p:cNvSpPr txBox="1"/>
           <p:nvPr/>
         </p:nvSpPr>
@@ -14101,9 +15316,9 @@
                 <a:solidFill>
                   <a:srgbClr val="14141A"/>
                 </a:solidFill>
-                <a:latin typeface="Yu Gothic"/>
-                <a:ea typeface="Yu Gothic"/>
-                <a:cs typeface="Yu Gothic"/>
+                <a:latin typeface="Hiragino Maru Gothic ProN"/>
+                <a:ea typeface="Hiragino Maru Gothic ProN"/>
+                <a:cs typeface="Hiragino Maru Gothic ProN"/>
               </a:rPr>
               <a:t>私の魅力</a:t>
             </a:r>
@@ -14112,7 +15327,7 @@
       </p:sp>
       <p:sp>
         <p:nvSpPr>
-          <p:cNvPr id="4" name="TextBox 4"/>
+          <p:cNvPr id="13" name="TextBox 13"/>
           <p:cNvSpPr txBox="1"/>
           <p:nvPr/>
         </p:nvSpPr>

</xml_diff>